<commit_message>
Añadir el ejemplo de Unreal Engine a la regla «primero las personas»
- bloque1.pptx: nueva diapositiva «Misma herramienta, mismo resultado»
  tras «La regla de todo el curso», con la historia en las notas.
  Insertada sin modificar ninguna de las diapositivas existentes.
- Guion: la historia en los minutos 15–20.

Co-Authored-By: Claude Opus 5.5 <noreply@anthropic.com>
</commit_message>
<xml_diff>
--- a/diapositivas/bloque1.pptx
+++ b/diapositivas/bloque1.pptx
@@ -27,6 +27,7 @@
     <p:sldId id="272" r:id="rId18"/>
     <p:sldId id="273" r:id="rId19"/>
     <p:sldId id="274" r:id="rId20"/>
+    <p:sldId id="284" r:id="rId35"/>
     <p:sldId id="275" r:id="rId21"/>
     <p:sldId id="276" r:id="rId22"/>
     <p:sldId id="277" r:id="rId23"/>
@@ -171,6 +172,7 @@
         <p14:section name="Brainstorming" id="{B1D90EA5-E9A1-1FA3-6157-4003D122319B}">
           <p14:sldIdLst>
             <p14:sldId id="274"/>
+            <p14:sldId id="284"/>
             <p14:sldId id="275"/>
             <p14:sldId id="276"/>
             <p14:sldId id="277"/>
@@ -2150,6 +2152,88 @@
         <p14:creationId xmlns:p14="http://schemas.microsoft.com/office/powerpoint/2010/main" val="1024086991"/>
       </p:ext>
     </p:extLst>
+  </p:cSld>
+  <p:clrMapOvr>
+    <a:masterClrMapping/>
+  </p:clrMapOvr>
+</p:notes>
+</file>
+
+<file path=ppt/notesSlides/notesSlide29.xml><?xml version="1.0" encoding="utf-8"?>
+<p:notes xmlns:a="http://schemas.openxmlformats.org/drawingml/2006/main" xmlns:p="http://schemas.openxmlformats.org/presentationml/2006/main" xmlns:r="http://schemas.openxmlformats.org/officeDocument/2006/relationships">
+  <p:cSld>
+    <p:spTree>
+      <p:nvGrpSpPr>
+        <p:cNvPr id="1" name=""/>
+        <p:cNvGrpSpPr/>
+        <p:nvPr/>
+      </p:nvGrpSpPr>
+      <p:grpSpPr>
+        <a:xfrm>
+          <a:off x="0" y="0"/>
+          <a:ext cx="0" cy="0"/>
+          <a:chOff x="0" y="0"/>
+          <a:chExt cx="0" cy="0"/>
+        </a:xfrm>
+      </p:grpSpPr>
+      <p:sp>
+        <p:nvSpPr>
+          <p:cNvPr id="3" name="Notes Placeholder 2"/>
+          <p:cNvSpPr>
+            <a:spLocks noGrp="1"/>
+          </p:cNvSpPr>
+          <p:nvPr>
+            <p:ph type="body" idx="1"/>
+          </p:nvPr>
+        </p:nvSpPr>
+        <p:spPr/>
+        <p:txBody>
+          <a:bodyPr/>
+          <a:lstStyle/>
+          <a:p>
+            <a:r>
+              <a:t>Minutos 15–20, justo después de la regla «primero las personas, después la IA». Contarlo como historia, en un minuto:</a:t>
+            </a:r>
+          </a:p>
+          <a:p/>
+          <a:p>
+            <a:r>
+              <a:t>Hay un programa para crear videojuegos, Unreal Engine 5, que lo hace casi todo solo: la luz, las sombras, los reflejos, el detalle de cada objeto. Con él, una persona desde su casa puede hacer un juego que parece de un gran estudio.</a:t>
+            </a:r>
+          </a:p>
+          <a:p/>
+          <a:p>
+            <a:r>
+              <a:t>Muchísima gente lo usó y dejó que el programa decidiera la luz y el aspecto del juego. Y pasó algo curioso: muchos juegos empezaron a parecerse entre sí. Técnicamente eran impecables, pero tenían todos el mismo aire. Los que llamaban la atención eran los que tenían un estilo propio, y ese estilo no lo pone la herramienta: lo pone la persona.</a:t>
+            </a:r>
+          </a:p>
+          <a:p/>
+          <a:p>
+            <a:r>
+              <a:t>Con la IA pasa lo mismo. Da ideas, resume y redacta muy bien. Pero si todos le preguntamos lo mismo, todos recibimos respuestas parecidas. Ya pasa con las cartas de presentación: las empresas reciben cientos que suenan iguales porque las ha escrito la misma IA.</a:t>
+            </a:r>
+          </a:p>
+          <a:p/>
+          <a:p>
+            <a:r>
+              <a:t>Las personas fallamos más y tenemos días malos. Pero la idea rara, la que nadie más tendría, es la que marca la diferencia, y esa suele salir de nosotros. Por eso: primero pensamos las personas y después usamos la IA para ampliar lo nuestro, no para sustituirlo.</a:t>
+            </a:r>
+          </a:p>
+          <a:p/>
+          <a:p>
+            <a:r>
+              <a:t>Cuidado: no afirmar que la IA es peor que las personas. El argumento es que, si todos usamos la misma herramienta, todos acabamos haciendo lo mismo. Así no se adelanta la conclusión de la comparación del Ejercicio 1.</a:t>
+            </a:r>
+          </a:p>
+          <a:p/>
+          <a:p>
+            <a:r>
+              <a:t>Respaldo (comprobar la referencia antes de citarla): un estudio publicado en 2024 en Science Advances encontró que la IA hacía algo más creativos los textos de cada persona, pero que los textos se parecían mucho más entre sí.</a:t>
+            </a:r>
+          </a:p>
+        </p:txBody>
+      </p:sp>
+    </p:spTree>
   </p:cSld>
   <p:clrMapOvr>
     <a:masterClrMapping/>
@@ -16719,6 +16803,847 @@
               <a:t>28</a:t>
             </a:fld>
             <a:endParaRPr lang="en-US"/>
+          </a:p>
+        </p:txBody>
+      </p:sp>
+    </p:spTree>
+  </p:cSld>
+  <p:clrMapOvr>
+    <a:masterClrMapping/>
+  </p:clrMapOvr>
+</p:sld>
+</file>
+
+<file path=ppt/slides/slide29.xml><?xml version="1.0" encoding="utf-8"?>
+<p:sld xmlns:a="http://schemas.openxmlformats.org/drawingml/2006/main" xmlns:p="http://schemas.openxmlformats.org/presentationml/2006/main" xmlns:r="http://schemas.openxmlformats.org/officeDocument/2006/relationships">
+  <p:cSld>
+    <p:spTree>
+      <p:nvGrpSpPr>
+        <p:cNvPr id="1" name=""/>
+        <p:cNvGrpSpPr/>
+        <p:nvPr/>
+      </p:nvGrpSpPr>
+      <p:grpSpPr/>
+      <p:sp>
+        <p:nvSpPr>
+          <p:cNvPr id="2" name="Text 0"/>
+          <p:cNvSpPr>
+            <a:spLocks noGrp="1"/>
+          </p:cNvSpPr>
+          <p:nvPr>
+            <p:ph type="title" idx="100" hasCustomPrompt="1"/>
+          </p:nvPr>
+        </p:nvSpPr>
+        <p:spPr>
+          <a:xfrm>
+            <a:off x="548640" y="411480"/>
+            <a:ext cx="11094415" cy="777240"/>
+          </a:xfrm>
+          <a:prstGeom prst="rect">
+            <a:avLst/>
+          </a:prstGeom>
+          <a:noFill/>
+          <a:ln/>
+        </p:spPr>
+        <p:txBody>
+          <a:bodyPr wrap="square" lIns="0" tIns="0" rIns="0" bIns="0" rtlCol="0" anchor="ctr"/>
+          <a:lstStyle/>
+          <a:p>
+            <a:pPr marL="0" indent="0" algn="l">
+              <a:buNone/>
+            </a:pPr>
+            <a:r>
+              <a:rPr lang="en-US" sz="3200" b="1" dirty="0">
+                <a:solidFill>
+                  <a:schemeClr val="tx1"/>
+                </a:solidFill>
+              </a:rPr>
+              <a:t>Misma herramienta, mismo resultado</a:t>
+            </a:r>
+            <a:endParaRPr lang="en-US" sz="3200" dirty="0"/>
+          </a:p>
+        </p:txBody>
+      </p:sp>
+      <p:sp>
+        <p:nvSpPr>
+          <p:cNvPr id="3" name="Etiqueta de tiempo"/>
+          <p:cNvSpPr/>
+          <p:nvPr/>
+        </p:nvSpPr>
+        <p:spPr>
+          <a:xfrm>
+            <a:off x="10134295" y="548640"/>
+            <a:ext cx="1508760" cy="457200"/>
+          </a:xfrm>
+          <a:prstGeom prst="roundRect">
+            <a:avLst>
+              <a:gd name="adj" fmla="val 50000"/>
+            </a:avLst>
+          </a:prstGeom>
+          <a:solidFill>
+            <a:schemeClr val="bg2"/>
+          </a:solidFill>
+          <a:ln/>
+        </p:spPr>
+      </p:sp>
+      <p:sp>
+        <p:nvSpPr>
+          <p:cNvPr id="4" name="Text 2"/>
+          <p:cNvSpPr txBox="1"/>
+          <p:nvPr/>
+        </p:nvSpPr>
+        <p:spPr>
+          <a:xfrm>
+            <a:off x="10134295" y="548640"/>
+            <a:ext cx="1508760" cy="457200"/>
+          </a:xfrm>
+          <a:prstGeom prst="rect">
+            <a:avLst/>
+          </a:prstGeom>
+          <a:noFill/>
+          <a:ln/>
+        </p:spPr>
+        <p:txBody>
+          <a:bodyPr wrap="square" lIns="0" tIns="0" rIns="0" bIns="0" rtlCol="0" anchor="ctr"/>
+          <a:lstStyle/>
+          <a:p>
+            <a:pPr marL="0" indent="0" algn="ctr">
+              <a:buNone/>
+            </a:pPr>
+            <a:r>
+              <a:rPr lang="en-US" sz="1400" b="1" dirty="0">
+                <a:solidFill>
+                  <a:schemeClr val="tx1"/>
+                </a:solidFill>
+              </a:rPr>
+              <a:t>Min. 15–20</a:t>
+            </a:r>
+            <a:endParaRPr lang="en-US" sz="1400" dirty="0"/>
+          </a:p>
+        </p:txBody>
+      </p:sp>
+      <p:sp>
+        <p:nvSpPr>
+          <p:cNvPr id="25" name="Slide Number Placeholder 0"/>
+          <p:cNvSpPr>
+            <a:spLocks noGrp="1"/>
+          </p:cNvSpPr>
+          <p:nvPr>
+            <p:ph type="sldNum" sz="quarter" idx="4294967295"/>
+          </p:nvPr>
+        </p:nvSpPr>
+        <p:spPr>
+          <a:xfrm>
+            <a:off x="11091672" y="6355080"/>
+            <a:ext cx="548640" cy="320040"/>
+          </a:xfrm>
+          <a:prstGeom prst="rect">
+            <a:avLst/>
+          </a:prstGeom>
+          <a:extLst>
+            <a:ext uri="{C572A759-6A51-4108-AA02-DFA0A04FC94B}">
+              <ma14:wrappingTextBoxFlag xmlns:ma14="http://schemas.microsoft.com/office/mac/drawingml/2011/main" xmlns="" val="0"/>
+            </a:ext>
+          </a:extLst>
+        </p:spPr>
+        <p:txBody>
+          <a:bodyPr/>
+          <a:lstStyle>
+            <a:lvl1pPr>
+              <a:defRPr sz="1100">
+                <a:solidFill>
+                  <a:srgbClr val="8A94A6"/>
+                </a:solidFill>
+              </a:defRPr>
+            </a:lvl1pPr>
+          </a:lstStyle>
+          <a:p>
+            <a:pPr algn="r"/>
+            <a:fld id="{F7021451-1387-4CA6-816F-3879F97B5CBC}" type="slidenum">
+              <a:rPr lang="en-US" b="0"/>
+              <a:t>19</a:t>
+            </a:fld>
+            <a:endParaRPr lang="en-US"/>
+          </a:p>
+        </p:txBody>
+      </p:sp>
+      <p:sp>
+        <p:nvSpPr>
+          <p:cNvPr id="26" name="Tarjeta Unreal Engine 5"/>
+          <p:cNvSpPr/>
+          <p:nvPr/>
+        </p:nvSpPr>
+        <p:spPr>
+          <a:xfrm>
+            <a:off x="548640" y="1463040"/>
+            <a:ext cx="11094415" cy="1463040"/>
+          </a:xfrm>
+          <a:prstGeom prst="roundRect">
+            <a:avLst>
+              <a:gd name="adj" fmla="val 9374"/>
+            </a:avLst>
+          </a:prstGeom>
+          <a:solidFill>
+            <a:schemeClr val="bg2"/>
+          </a:solidFill>
+          <a:ln>
+            <a:noFill/>
+          </a:ln>
+          <a:effectLst/>
+        </p:spPr>
+        <p:style>
+          <a:lnRef idx="1">
+            <a:schemeClr val="accent1"/>
+          </a:lnRef>
+          <a:fillRef idx="3">
+            <a:schemeClr val="accent1"/>
+          </a:fillRef>
+          <a:effectRef idx="2">
+            <a:schemeClr val="accent1"/>
+          </a:effectRef>
+          <a:fontRef idx="minor">
+            <a:schemeClr val="lt1"/>
+          </a:fontRef>
+        </p:style>
+        <p:txBody>
+          <a:bodyPr rtlCol="0" anchor="ctr"/>
+          <a:lstStyle/>
+          <a:p>
+            <a:pPr algn="ctr"/>
+          </a:p>
+        </p:txBody>
+      </p:sp>
+      <p:sp>
+        <p:nvSpPr>
+          <p:cNvPr id="27" name="Unreal Engine 5"/>
+          <p:cNvSpPr/>
+          <p:nvPr/>
+        </p:nvSpPr>
+        <p:spPr>
+          <a:xfrm>
+            <a:off x="822959" y="1737360"/>
+            <a:ext cx="914400" cy="914400"/>
+          </a:xfrm>
+          <a:prstGeom prst="ellipse">
+            <a:avLst/>
+          </a:prstGeom>
+          <a:solidFill>
+            <a:schemeClr val="tx1"/>
+          </a:solidFill>
+          <a:ln>
+            <a:noFill/>
+          </a:ln>
+          <a:effectLst/>
+        </p:spPr>
+        <p:style>
+          <a:lnRef idx="1">
+            <a:schemeClr val="accent1"/>
+          </a:lnRef>
+          <a:fillRef idx="3">
+            <a:schemeClr val="accent1"/>
+          </a:fillRef>
+          <a:effectRef idx="2">
+            <a:schemeClr val="accent1"/>
+          </a:effectRef>
+          <a:fontRef idx="minor">
+            <a:schemeClr val="lt1"/>
+          </a:fontRef>
+        </p:style>
+        <p:txBody>
+          <a:bodyPr rtlCol="0" anchor="ctr"/>
+          <a:lstStyle/>
+          <a:p>
+            <a:pPr algn="ctr"/>
+          </a:p>
+        </p:txBody>
+      </p:sp>
+      <p:pic>
+        <p:nvPicPr>
+          <p:cNvPr id="28" name="Unreal Engine 5" descr="FaGamepad-FFFFFF.png"/>
+          <p:cNvPicPr>
+            <a:picLocks noChangeAspect="1"/>
+          </p:cNvPicPr>
+          <p:nvPr/>
+        </p:nvPicPr>
+        <p:blipFill>
+          <a:blip r:embed="rId2"/>
+          <a:stretch>
+            <a:fillRect/>
+          </a:stretch>
+        </p:blipFill>
+        <p:spPr>
+          <a:xfrm>
+            <a:off x="1042415" y="1956816"/>
+            <a:ext cx="475488" cy="475488"/>
+          </a:xfrm>
+          <a:prstGeom prst="rect">
+            <a:avLst/>
+          </a:prstGeom>
+        </p:spPr>
+      </p:pic>
+      <p:sp>
+        <p:nvSpPr>
+          <p:cNvPr id="29" name="Texto Unreal Engine 5"/>
+          <p:cNvSpPr txBox="1"/>
+          <p:nvPr/>
+        </p:nvSpPr>
+        <p:spPr>
+          <a:xfrm>
+            <a:off x="2011680" y="1463040"/>
+            <a:ext cx="5760720" cy="1463040"/>
+          </a:xfrm>
+          <a:prstGeom prst="rect">
+            <a:avLst/>
+          </a:prstGeom>
+          <a:noFill/>
+        </p:spPr>
+        <p:txBody>
+          <a:bodyPr wrap="square" anchor="ctr" lIns="0" rIns="0" tIns="0" bIns="0">
+            <a:spAutoFit/>
+          </a:bodyPr>
+          <a:lstStyle/>
+          <a:p>
+            <a:r>
+              <a:rPr sz="2000" b="1">
+                <a:solidFill>
+                  <a:schemeClr val="tx1"/>
+                </a:solidFill>
+              </a:rPr>
+              <a:t>Unreal Engine 5</a:t>
+            </a:r>
+          </a:p>
+          <a:p>
+            <a:pPr>
+              <a:spcBef>
+                <a:spcPts val="400"/>
+              </a:spcBef>
+            </a:pPr>
+            <a:r>
+              <a:rPr sz="1700" b="0">
+                <a:solidFill>
+                  <a:schemeClr val="tx1"/>
+                </a:solidFill>
+              </a:rPr>
+              <a:t>Cualquiera podía hacer un juego de aspecto profesional… y muchos juegos acabaron pareciéndose.</a:t>
+            </a:r>
+          </a:p>
+        </p:txBody>
+      </p:sp>
+      <p:pic>
+        <p:nvPicPr>
+          <p:cNvPr id="30" name="Resultado igual" descr="FaGamepad-8A94A6.png"/>
+          <p:cNvPicPr>
+            <a:picLocks noChangeAspect="1"/>
+          </p:cNvPicPr>
+          <p:nvPr/>
+        </p:nvPicPr>
+        <p:blipFill>
+          <a:blip r:embed="rId3"/>
+          <a:stretch>
+            <a:fillRect/>
+          </a:stretch>
+        </p:blipFill>
+        <p:spPr>
+          <a:xfrm>
+            <a:off x="8001000" y="1947672"/>
+            <a:ext cx="502920" cy="502920"/>
+          </a:xfrm>
+          <a:prstGeom prst="rect">
+            <a:avLst/>
+          </a:prstGeom>
+        </p:spPr>
+      </p:pic>
+      <p:pic>
+        <p:nvPicPr>
+          <p:cNvPr id="31" name="Resultado igual" descr="FaGamepad-8A94A6.png"/>
+          <p:cNvPicPr>
+            <a:picLocks noChangeAspect="1"/>
+          </p:cNvPicPr>
+          <p:nvPr/>
+        </p:nvPicPr>
+        <p:blipFill>
+          <a:blip r:embed="rId3"/>
+          <a:stretch>
+            <a:fillRect/>
+          </a:stretch>
+        </p:blipFill>
+        <p:spPr>
+          <a:xfrm>
+            <a:off x="8714232" y="1947672"/>
+            <a:ext cx="502920" cy="502920"/>
+          </a:xfrm>
+          <a:prstGeom prst="rect">
+            <a:avLst/>
+          </a:prstGeom>
+        </p:spPr>
+      </p:pic>
+      <p:pic>
+        <p:nvPicPr>
+          <p:cNvPr id="32" name="Resultado igual" descr="FaGamepad-8A94A6.png"/>
+          <p:cNvPicPr>
+            <a:picLocks noChangeAspect="1"/>
+          </p:cNvPicPr>
+          <p:nvPr/>
+        </p:nvPicPr>
+        <p:blipFill>
+          <a:blip r:embed="rId3"/>
+          <a:stretch>
+            <a:fillRect/>
+          </a:stretch>
+        </p:blipFill>
+        <p:spPr>
+          <a:xfrm>
+            <a:off x="9427464" y="1947672"/>
+            <a:ext cx="502920" cy="502920"/>
+          </a:xfrm>
+          <a:prstGeom prst="rect">
+            <a:avLst/>
+          </a:prstGeom>
+        </p:spPr>
+      </p:pic>
+      <p:pic>
+        <p:nvPicPr>
+          <p:cNvPr id="33" name="Resultado igual" descr="FaGamepad-8A94A6.png"/>
+          <p:cNvPicPr>
+            <a:picLocks noChangeAspect="1"/>
+          </p:cNvPicPr>
+          <p:nvPr/>
+        </p:nvPicPr>
+        <p:blipFill>
+          <a:blip r:embed="rId3"/>
+          <a:stretch>
+            <a:fillRect/>
+          </a:stretch>
+        </p:blipFill>
+        <p:spPr>
+          <a:xfrm>
+            <a:off x="10140696" y="1947672"/>
+            <a:ext cx="502920" cy="502920"/>
+          </a:xfrm>
+          <a:prstGeom prst="rect">
+            <a:avLst/>
+          </a:prstGeom>
+        </p:spPr>
+      </p:pic>
+      <p:pic>
+        <p:nvPicPr>
+          <p:cNvPr id="34" name="Resultado igual" descr="FaGamepad-8A94A6.png"/>
+          <p:cNvPicPr>
+            <a:picLocks noChangeAspect="1"/>
+          </p:cNvPicPr>
+          <p:nvPr/>
+        </p:nvPicPr>
+        <p:blipFill>
+          <a:blip r:embed="rId3"/>
+          <a:stretch>
+            <a:fillRect/>
+          </a:stretch>
+        </p:blipFill>
+        <p:spPr>
+          <a:xfrm>
+            <a:off x="10853928" y="1947672"/>
+            <a:ext cx="502920" cy="502920"/>
+          </a:xfrm>
+          <a:prstGeom prst="rect">
+            <a:avLst/>
+          </a:prstGeom>
+        </p:spPr>
+      </p:pic>
+      <p:sp>
+        <p:nvSpPr>
+          <p:cNvPr id="35" name="Tarjeta La IA"/>
+          <p:cNvSpPr/>
+          <p:nvPr/>
+        </p:nvSpPr>
+        <p:spPr>
+          <a:xfrm>
+            <a:off x="548640" y="3108960"/>
+            <a:ext cx="11094415" cy="1463040"/>
+          </a:xfrm>
+          <a:prstGeom prst="roundRect">
+            <a:avLst>
+              <a:gd name="adj" fmla="val 9374"/>
+            </a:avLst>
+          </a:prstGeom>
+          <a:solidFill>
+            <a:schemeClr val="bg2"/>
+          </a:solidFill>
+          <a:ln>
+            <a:noFill/>
+          </a:ln>
+          <a:effectLst/>
+        </p:spPr>
+        <p:style>
+          <a:lnRef idx="1">
+            <a:schemeClr val="accent1"/>
+          </a:lnRef>
+          <a:fillRef idx="3">
+            <a:schemeClr val="accent1"/>
+          </a:fillRef>
+          <a:effectRef idx="2">
+            <a:schemeClr val="accent1"/>
+          </a:effectRef>
+          <a:fontRef idx="minor">
+            <a:schemeClr val="lt1"/>
+          </a:fontRef>
+        </p:style>
+        <p:txBody>
+          <a:bodyPr rtlCol="0" anchor="ctr"/>
+          <a:lstStyle/>
+          <a:p>
+            <a:pPr algn="ctr"/>
+          </a:p>
+        </p:txBody>
+      </p:sp>
+      <p:sp>
+        <p:nvSpPr>
+          <p:cNvPr id="36" name="La IA"/>
+          <p:cNvSpPr/>
+          <p:nvPr/>
+        </p:nvSpPr>
+        <p:spPr>
+          <a:xfrm>
+            <a:off x="822959" y="3383279"/>
+            <a:ext cx="914400" cy="914400"/>
+          </a:xfrm>
+          <a:prstGeom prst="ellipse">
+            <a:avLst/>
+          </a:prstGeom>
+          <a:solidFill>
+            <a:schemeClr val="accent2"/>
+          </a:solidFill>
+          <a:ln>
+            <a:noFill/>
+          </a:ln>
+          <a:effectLst/>
+        </p:spPr>
+        <p:style>
+          <a:lnRef idx="1">
+            <a:schemeClr val="accent1"/>
+          </a:lnRef>
+          <a:fillRef idx="3">
+            <a:schemeClr val="accent1"/>
+          </a:fillRef>
+          <a:effectRef idx="2">
+            <a:schemeClr val="accent1"/>
+          </a:effectRef>
+          <a:fontRef idx="minor">
+            <a:schemeClr val="lt1"/>
+          </a:fontRef>
+        </p:style>
+        <p:txBody>
+          <a:bodyPr rtlCol="0" anchor="ctr"/>
+          <a:lstStyle/>
+          <a:p>
+            <a:pPr algn="ctr"/>
+          </a:p>
+        </p:txBody>
+      </p:sp>
+      <p:pic>
+        <p:nvPicPr>
+          <p:cNvPr id="37" name="La IA" descr="image.png"/>
+          <p:cNvPicPr>
+            <a:picLocks noChangeAspect="1"/>
+          </p:cNvPicPr>
+          <p:nvPr/>
+        </p:nvPicPr>
+        <p:blipFill>
+          <a:blip r:embed="rId4"/>
+          <a:stretch>
+            <a:fillRect/>
+          </a:stretch>
+        </p:blipFill>
+        <p:spPr>
+          <a:xfrm>
+            <a:off x="1042415" y="3602735"/>
+            <a:ext cx="475488" cy="475488"/>
+          </a:xfrm>
+          <a:prstGeom prst="rect">
+            <a:avLst/>
+          </a:prstGeom>
+        </p:spPr>
+      </p:pic>
+      <p:sp>
+        <p:nvSpPr>
+          <p:cNvPr id="38" name="Texto La IA"/>
+          <p:cNvSpPr txBox="1"/>
+          <p:nvPr/>
+        </p:nvSpPr>
+        <p:spPr>
+          <a:xfrm>
+            <a:off x="2011680" y="3108960"/>
+            <a:ext cx="5760720" cy="1463040"/>
+          </a:xfrm>
+          <a:prstGeom prst="rect">
+            <a:avLst/>
+          </a:prstGeom>
+          <a:noFill/>
+        </p:spPr>
+        <p:txBody>
+          <a:bodyPr wrap="square" anchor="ctr" lIns="0" rIns="0" tIns="0" bIns="0">
+            <a:spAutoFit/>
+          </a:bodyPr>
+          <a:lstStyle/>
+          <a:p>
+            <a:r>
+              <a:rPr sz="2000" b="1">
+                <a:solidFill>
+                  <a:schemeClr val="tx1"/>
+                </a:solidFill>
+              </a:rPr>
+              <a:t>La IA</a:t>
+            </a:r>
+          </a:p>
+          <a:p>
+            <a:pPr>
+              <a:spcBef>
+                <a:spcPts val="400"/>
+              </a:spcBef>
+            </a:pPr>
+            <a:r>
+              <a:rPr sz="1700" b="0">
+                <a:solidFill>
+                  <a:schemeClr val="tx1"/>
+                </a:solidFill>
+              </a:rPr>
+              <a:t>Si todos le pedimos lo mismo, todos recibimos lo mismo: cientos de cartas de presentación que suenan iguales.</a:t>
+            </a:r>
+          </a:p>
+        </p:txBody>
+      </p:sp>
+      <p:pic>
+        <p:nvPicPr>
+          <p:cNvPr id="39" name="Resultado igual" descr="FaFileAlt-8A94A6.png"/>
+          <p:cNvPicPr>
+            <a:picLocks noChangeAspect="1"/>
+          </p:cNvPicPr>
+          <p:nvPr/>
+        </p:nvPicPr>
+        <p:blipFill>
+          <a:blip r:embed="rId5"/>
+          <a:stretch>
+            <a:fillRect/>
+          </a:stretch>
+        </p:blipFill>
+        <p:spPr>
+          <a:xfrm>
+            <a:off x="8001000" y="3593591"/>
+            <a:ext cx="502920" cy="502920"/>
+          </a:xfrm>
+          <a:prstGeom prst="rect">
+            <a:avLst/>
+          </a:prstGeom>
+        </p:spPr>
+      </p:pic>
+      <p:pic>
+        <p:nvPicPr>
+          <p:cNvPr id="40" name="Resultado igual" descr="FaFileAlt-8A94A6.png"/>
+          <p:cNvPicPr>
+            <a:picLocks noChangeAspect="1"/>
+          </p:cNvPicPr>
+          <p:nvPr/>
+        </p:nvPicPr>
+        <p:blipFill>
+          <a:blip r:embed="rId5"/>
+          <a:stretch>
+            <a:fillRect/>
+          </a:stretch>
+        </p:blipFill>
+        <p:spPr>
+          <a:xfrm>
+            <a:off x="8714232" y="3593591"/>
+            <a:ext cx="502920" cy="502920"/>
+          </a:xfrm>
+          <a:prstGeom prst="rect">
+            <a:avLst/>
+          </a:prstGeom>
+        </p:spPr>
+      </p:pic>
+      <p:pic>
+        <p:nvPicPr>
+          <p:cNvPr id="41" name="Resultado igual" descr="FaFileAlt-8A94A6.png"/>
+          <p:cNvPicPr>
+            <a:picLocks noChangeAspect="1"/>
+          </p:cNvPicPr>
+          <p:nvPr/>
+        </p:nvPicPr>
+        <p:blipFill>
+          <a:blip r:embed="rId5"/>
+          <a:stretch>
+            <a:fillRect/>
+          </a:stretch>
+        </p:blipFill>
+        <p:spPr>
+          <a:xfrm>
+            <a:off x="9427464" y="3593591"/>
+            <a:ext cx="502920" cy="502920"/>
+          </a:xfrm>
+          <a:prstGeom prst="rect">
+            <a:avLst/>
+          </a:prstGeom>
+        </p:spPr>
+      </p:pic>
+      <p:pic>
+        <p:nvPicPr>
+          <p:cNvPr id="42" name="Resultado igual" descr="FaFileAlt-8A94A6.png"/>
+          <p:cNvPicPr>
+            <a:picLocks noChangeAspect="1"/>
+          </p:cNvPicPr>
+          <p:nvPr/>
+        </p:nvPicPr>
+        <p:blipFill>
+          <a:blip r:embed="rId5"/>
+          <a:stretch>
+            <a:fillRect/>
+          </a:stretch>
+        </p:blipFill>
+        <p:spPr>
+          <a:xfrm>
+            <a:off x="10140696" y="3593591"/>
+            <a:ext cx="502920" cy="502920"/>
+          </a:xfrm>
+          <a:prstGeom prst="rect">
+            <a:avLst/>
+          </a:prstGeom>
+        </p:spPr>
+      </p:pic>
+      <p:pic>
+        <p:nvPicPr>
+          <p:cNvPr id="43" name="Resultado igual" descr="FaFileAlt-8A94A6.png"/>
+          <p:cNvPicPr>
+            <a:picLocks noChangeAspect="1"/>
+          </p:cNvPicPr>
+          <p:nvPr/>
+        </p:nvPicPr>
+        <p:blipFill>
+          <a:blip r:embed="rId5"/>
+          <a:stretch>
+            <a:fillRect/>
+          </a:stretch>
+        </p:blipFill>
+        <p:spPr>
+          <a:xfrm>
+            <a:off x="10853928" y="3593591"/>
+            <a:ext cx="502920" cy="502920"/>
+          </a:xfrm>
+          <a:prstGeom prst="rect">
+            <a:avLst/>
+          </a:prstGeom>
+        </p:spPr>
+      </p:pic>
+      <p:sp>
+        <p:nvSpPr>
+          <p:cNvPr id="44" name="Personas"/>
+          <p:cNvSpPr/>
+          <p:nvPr/>
+        </p:nvSpPr>
+        <p:spPr>
+          <a:xfrm>
+            <a:off x="548640" y="4983480"/>
+            <a:ext cx="822960" cy="822960"/>
+          </a:xfrm>
+          <a:prstGeom prst="ellipse">
+            <a:avLst/>
+          </a:prstGeom>
+          <a:solidFill>
+            <a:schemeClr val="accent1"/>
+          </a:solidFill>
+          <a:ln>
+            <a:noFill/>
+          </a:ln>
+          <a:effectLst/>
+        </p:spPr>
+        <p:style>
+          <a:lnRef idx="1">
+            <a:schemeClr val="accent1"/>
+          </a:lnRef>
+          <a:fillRef idx="3">
+            <a:schemeClr val="accent1"/>
+          </a:fillRef>
+          <a:effectRef idx="2">
+            <a:schemeClr val="accent1"/>
+          </a:effectRef>
+          <a:fontRef idx="minor">
+            <a:schemeClr val="lt1"/>
+          </a:fontRef>
+        </p:style>
+        <p:txBody>
+          <a:bodyPr rtlCol="0" anchor="ctr"/>
+          <a:lstStyle/>
+          <a:p>
+            <a:pPr algn="ctr"/>
+          </a:p>
+        </p:txBody>
+      </p:sp>
+      <p:pic>
+        <p:nvPicPr>
+          <p:cNvPr id="45" name="Personas" descr="image.png"/>
+          <p:cNvPicPr>
+            <a:picLocks noChangeAspect="1"/>
+          </p:cNvPicPr>
+          <p:nvPr/>
+        </p:nvPicPr>
+        <p:blipFill>
+          <a:blip r:embed="rId6"/>
+          <a:stretch>
+            <a:fillRect/>
+          </a:stretch>
+        </p:blipFill>
+        <p:spPr>
+          <a:xfrm>
+            <a:off x="746150" y="5180990"/>
+            <a:ext cx="427939" cy="427939"/>
+          </a:xfrm>
+          <a:prstGeom prst="rect">
+            <a:avLst/>
+          </a:prstGeom>
+        </p:spPr>
+      </p:pic>
+      <p:sp>
+        <p:nvSpPr>
+          <p:cNvPr id="46" name="Conclusión"/>
+          <p:cNvSpPr txBox="1"/>
+          <p:nvPr/>
+        </p:nvSpPr>
+        <p:spPr>
+          <a:xfrm>
+            <a:off x="1600200" y="4846320"/>
+            <a:ext cx="10042855" cy="1097280"/>
+          </a:xfrm>
+          <a:prstGeom prst="rect">
+            <a:avLst/>
+          </a:prstGeom>
+          <a:noFill/>
+        </p:spPr>
+        <p:txBody>
+          <a:bodyPr wrap="square" anchor="ctr" lIns="0" rIns="0" tIns="0" bIns="0">
+            <a:spAutoFit/>
+          </a:bodyPr>
+          <a:lstStyle/>
+          <a:p>
+            <a:r>
+              <a:rPr sz="2000" b="1">
+                <a:solidFill>
+                  <a:schemeClr val="tx1"/>
+                </a:solidFill>
+              </a:rPr>
+              <a:t>La idea que nadie más tendría suele salir de las personas.</a:t>
+            </a:r>
+          </a:p>
+          <a:p>
+            <a:pPr>
+              <a:spcBef>
+                <a:spcPts val="400"/>
+              </a:spcBef>
+            </a:pPr>
+            <a:r>
+              <a:rPr sz="1800" b="0">
+                <a:solidFill>
+                  <a:schemeClr val="tx1"/>
+                </a:solidFill>
+              </a:rPr>
+              <a:t>Primero pensamos nosotros; después, la IA amplía lo nuestro.</a:t>
+            </a:r>
           </a:p>
         </p:txBody>
       </p:sp>

</xml_diff>

<commit_message>
Guardar las ediciones manuales de bloque1.pptx e historia_unreal.pptx
Co-Authored-By: Claude Opus 5.5 <noreply@anthropic.com>
</commit_message>
<xml_diff>
--- a/diapositivas/bloque1.pptx
+++ b/diapositivas/bloque1.pptx
@@ -5,7 +5,7 @@
     <p:sldMasterId id="2147483648" r:id="rId1"/>
   </p:sldMasterIdLst>
   <p:notesMasterIdLst>
-    <p:notesMasterId r:id="rId30"/>
+    <p:notesMasterId r:id="rId31"/>
   </p:notesMasterIdLst>
   <p:sldIdLst>
     <p:sldId id="256" r:id="rId2"/>
@@ -27,16 +27,16 @@
     <p:sldId id="272" r:id="rId18"/>
     <p:sldId id="273" r:id="rId19"/>
     <p:sldId id="274" r:id="rId20"/>
-    <p:sldId id="284" r:id="rId35"/>
-    <p:sldId id="275" r:id="rId21"/>
-    <p:sldId id="276" r:id="rId22"/>
-    <p:sldId id="277" r:id="rId23"/>
-    <p:sldId id="278" r:id="rId24"/>
-    <p:sldId id="279" r:id="rId25"/>
-    <p:sldId id="280" r:id="rId26"/>
-    <p:sldId id="281" r:id="rId27"/>
-    <p:sldId id="282" r:id="rId28"/>
-    <p:sldId id="283" r:id="rId29"/>
+    <p:sldId id="284" r:id="rId21"/>
+    <p:sldId id="275" r:id="rId22"/>
+    <p:sldId id="276" r:id="rId23"/>
+    <p:sldId id="277" r:id="rId24"/>
+    <p:sldId id="278" r:id="rId25"/>
+    <p:sldId id="279" r:id="rId26"/>
+    <p:sldId id="280" r:id="rId27"/>
+    <p:sldId id="281" r:id="rId28"/>
+    <p:sldId id="282" r:id="rId29"/>
+    <p:sldId id="283" r:id="rId30"/>
   </p:sldIdLst>
   <p:sldSz cx="12192000" cy="6858000"/>
   <p:notesSz cx="6858000" cy="12192000"/>
@@ -1395,18 +1395,6 @@
       </p:grpSpPr>
       <p:sp>
         <p:nvSpPr>
-          <p:cNvPr id="2" name="Slide Image Placeholder 1"/>
-          <p:cNvSpPr>
-            <a:spLocks noGrp="1" noRot="1" noChangeAspect="1"/>
-          </p:cNvSpPr>
-          <p:nvPr>
-            <p:ph type="sldImg"/>
-          </p:nvPr>
-        </p:nvSpPr>
-        <p:spPr/>
-      </p:sp>
-      <p:sp>
-        <p:nvSpPr>
           <p:cNvPr id="3" name="Notes Placeholder 2"/>
           <p:cNvSpPr>
             <a:spLocks noGrp="1"/>
@@ -1421,41 +1409,60 @@
           <a:lstStyle/>
           <a:p>
             <a:r>
-              <a:rPr lang="en-US" dirty="0"/>
-              <a:t>Ejemplo que acompaña a las tres técnicas del curso. Es ajeno a los ejercicios: usar siempre el mismo ejemplo deja ver qué tipo de ideas produce cada técnica.</a:t>
-            </a:r>
-          </a:p>
-        </p:txBody>
-      </p:sp>
-      <p:sp>
-        <p:nvSpPr>
-          <p:cNvPr id="4" name="Slide Number Placeholder 3"/>
-          <p:cNvSpPr>
-            <a:spLocks noGrp="1"/>
-          </p:cNvSpPr>
-          <p:nvPr>
-            <p:ph type="sldNum" sz="quarter" idx="10"/>
-          </p:nvPr>
-        </p:nvSpPr>
-        <p:spPr/>
-        <p:txBody>
-          <a:bodyPr/>
-          <a:lstStyle/>
-          <a:p>
-            <a:fld id="{F7021451-1387-4CA6-816F-3879F97B5CBC}" type="slidenum">
-              <a:rPr lang="en-US"/>
-              <a:t>20</a:t>
-            </a:fld>
-            <a:endParaRPr lang="en-US"/>
+              <a:t>Minutos 15–20, justo después de la regla «primero las personas, después la IA». Contarlo como historia, en un minuto:</a:t>
+            </a:r>
+          </a:p>
+          <a:p>
+            <a:endParaRPr/>
+          </a:p>
+          <a:p>
+            <a:r>
+              <a:t>Hay un programa para crear videojuegos, Unreal Engine 5, que lo hace casi todo solo: la luz, las sombras, los reflejos, el detalle de cada objeto. Con él, una persona desde su casa puede hacer un juego que parece de un gran estudio.</a:t>
+            </a:r>
+          </a:p>
+          <a:p>
+            <a:endParaRPr/>
+          </a:p>
+          <a:p>
+            <a:r>
+              <a:t>Muchísima gente lo usó y dejó que el programa decidiera la luz y el aspecto del juego. Y pasó algo curioso: muchos juegos empezaron a parecerse entre sí. Técnicamente eran impecables, pero tenían todos el mismo aire. Los que llamaban la atención eran los que tenían un estilo propio, y ese estilo no lo pone la herramienta: lo pone la persona.</a:t>
+            </a:r>
+          </a:p>
+          <a:p>
+            <a:endParaRPr/>
+          </a:p>
+          <a:p>
+            <a:r>
+              <a:t>Con la IA pasa lo mismo. Da ideas, resume y redacta muy bien. Pero si todos le preguntamos lo mismo, todos recibimos respuestas parecidas. Ya pasa con las cartas de presentación: las empresas reciben cientos que suenan iguales porque las ha escrito la misma IA.</a:t>
+            </a:r>
+          </a:p>
+          <a:p>
+            <a:endParaRPr/>
+          </a:p>
+          <a:p>
+            <a:r>
+              <a:t>Las personas fallamos más y tenemos días malos. Pero la idea rara, la que nadie más tendría, es la que marca la diferencia, y esa suele salir de nosotros. Por eso: primero pensamos las personas y después usamos la IA para ampliar lo nuestro, no para sustituirlo.</a:t>
+            </a:r>
+          </a:p>
+          <a:p>
+            <a:endParaRPr/>
+          </a:p>
+          <a:p>
+            <a:r>
+              <a:t>Cuidado: no afirmar que la IA es peor que las personas. El argumento es que, si todos usamos la misma herramienta, todos acabamos haciendo lo mismo. Así no se adelanta la conclusión de la comparación del Ejercicio 1.</a:t>
+            </a:r>
+          </a:p>
+          <a:p>
+            <a:endParaRPr/>
+          </a:p>
+          <a:p>
+            <a:r>
+              <a:t>Respaldo (comprobar la referencia antes de citarla): un estudio publicado en 2024 en Science Advances encontró que la IA hacía algo más creativos los textos de cada persona, pero que los textos se parecían mucho más entre sí.</a:t>
+            </a:r>
           </a:p>
         </p:txBody>
       </p:sp>
     </p:spTree>
-    <p:extLst>
-      <p:ext uri="{BB962C8B-B14F-4D97-AF65-F5344CB8AC3E}">
-        <p14:creationId xmlns:p14="http://schemas.microsoft.com/office/powerpoint/2010/main" val="1024086991"/>
-      </p:ext>
-    </p:extLst>
   </p:cSld>
   <p:clrMapOvr>
     <a:masterClrMapping/>
@@ -1509,7 +1516,7 @@
           <a:p>
             <a:r>
               <a:rPr lang="en-US" dirty="0"/>
-              <a:t>Minutos 15–20. Qué es el brainstorming y sus cuatro reglas. La regla 3 (construir sobre la idea de otra persona) se aplicará después también a la combinación de ideas del grupo y de la IA.</a:t>
+              <a:t>Ejemplo que acompaña a las tres técnicas del curso. Es ajeno a los ejercicios: usar siempre el mismo ejemplo deja ver qué tipo de ideas produce cada técnica.</a:t>
             </a:r>
           </a:p>
         </p:txBody>
@@ -1596,7 +1603,7 @@
           <a:p>
             <a:r>
               <a:rPr lang="en-US" dirty="0"/>
-              <a:t>Lanzar las ideas a buen ritmo para mostrar cómo funciona. Terminar con la idea disparatada y mostrar que, construyendo sobre ella, se llega a una idea sensata: por eso las ideas disparatadas son bienvenidas.</a:t>
+              <a:t>Minutos 15–20. Qué es el brainstorming y sus cuatro reglas. La regla 3 (construir sobre la idea de otra persona) se aplicará después también a la combinación de ideas del grupo y de la IA.</a:t>
             </a:r>
           </a:p>
         </p:txBody>
@@ -1683,7 +1690,7 @@
           <a:p>
             <a:r>
               <a:rPr lang="en-US" dirty="0"/>
-              <a:t>Minutos 20–30. Entre todo el grupo, sin IA. Dar el turno en rueda para que participen todas las personas y no solo las más extrovertidas; quien no tenga idea dice «paso» y se continúa. Apuntar todas las ideas numeradas en la pizarra o en un documento compartido, sin comentarlas. Al final, contar el total: se usará en la comparación.</a:t>
+              <a:t>Lanzar las ideas a buen ritmo para mostrar cómo funciona. Terminar con la idea disparatada y mostrar que, construyendo sobre ella, se llega a una idea sensata: por eso las ideas disparatadas son bienvenidas.</a:t>
             </a:r>
           </a:p>
         </p:txBody>
@@ -1770,7 +1777,7 @@
           <a:p>
             <a:r>
               <a:rPr lang="en-US" dirty="0"/>
-              <a:t>Minutos 30–38. Proyectar la IA y pegar la lista de ideas del grupo en el lugar indicado. Leer en voz alta las propuestas de la IA y comentar cuáles sorprenden y cuáles son genéricas o repiten lo ya dicho con otras palabras. El texto del prompt para copiar está en el guion docente.</a:t>
+              <a:t>Minutos 20–30. Entre todo el grupo, sin IA. Dar el turno en rueda para que participen todas las personas y no solo las más extrovertidas; quien no tenga idea dice «paso» y se continúa. Apuntar todas las ideas numeradas en la pizarra o en un documento compartido, sin comentarlas. Al final, contar el total: se usará en la comparación.</a:t>
             </a:r>
           </a:p>
         </p:txBody>
@@ -1857,7 +1864,7 @@
           <a:p>
             <a:r>
               <a:rPr lang="en-US" dirty="0"/>
-              <a:t>Minutos 30–38. Lanzar este segundo prompt en la misma conversación con la IA, a continuación del primero.</a:t>
+              <a:t>Minutos 30–38. Proyectar la IA y pegar la lista de ideas del grupo en el lugar indicado. Leer en voz alta las propuestas de la IA y comentar cuáles sorprenden y cuáles son genéricas o repiten lo ya dicho con otras palabras. El texto del prompt para copiar está en el guion docente.</a:t>
             </a:r>
           </a:p>
         </p:txBody>
@@ -1944,7 +1951,7 @@
           <a:p>
             <a:r>
               <a:rPr lang="en-US" dirty="0"/>
-              <a:t>Minutos 38–45. Cada persona marca las tres ideas que le parecen más originales, sin fijarse en si vienen del grupo o de la IA. Después, contar y rellenar la tabla: cuántas ideas salieron sin IA y con IA, y cuántas de las más votadas son de cada origen.</a:t>
+              <a:t>Minutos 30–38. Lanzar este segundo prompt en la misma conversación con la IA, a continuación del primero.</a:t>
             </a:r>
           </a:p>
         </p:txBody>
@@ -2031,7 +2038,7 @@
           <a:p>
             <a:r>
               <a:rPr lang="en-US" dirty="0"/>
-              <a:t>No adelantar la conclusión: puede salir que la IA aporta más cantidad pero menos originalidad, o lo contrario. Lo importante es que el grupo lo compruebe con sus propios datos de la tabla.</a:t>
+              <a:t>Minutos 38–45. Cada persona marca las tres ideas que le parecen más originales, sin fijarse en si vienen del grupo o de la IA. Después, contar y rellenar la tabla: cuántas ideas salieron sin IA y con IA, y cuántas de las más votadas son de cada origen.</a:t>
             </a:r>
           </a:p>
         </p:txBody>
@@ -2118,7 +2125,7 @@
           <a:p>
             <a:r>
               <a:rPr lang="en-US" dirty="0"/>
-              <a:t>Conclusión del bloque. Enlazar con el bloque 2: ahora se aplicarán dos técnicas más estructuradas, SCAMPER y la provocación, por parejas.</a:t>
+              <a:t>No adelantar la conclusión: puede salir que la IA aporta más cantidad pero menos originalidad, o lo contrario. Lo importante es que el grupo lo compruebe con sus propios datos de la tabla.</a:t>
             </a:r>
           </a:p>
         </p:txBody>
@@ -2160,7 +2167,7 @@
 </file>
 
 <file path=ppt/notesSlides/notesSlide29.xml><?xml version="1.0" encoding="utf-8"?>
-<p:notes xmlns:a="http://schemas.openxmlformats.org/drawingml/2006/main" xmlns:p="http://schemas.openxmlformats.org/presentationml/2006/main" xmlns:r="http://schemas.openxmlformats.org/officeDocument/2006/relationships">
+<p:notes xmlns:a="http://schemas.openxmlformats.org/drawingml/2006/main" xmlns:r="http://schemas.openxmlformats.org/officeDocument/2006/relationships" xmlns:p="http://schemas.openxmlformats.org/presentationml/2006/main">
   <p:cSld>
     <p:spTree>
       <p:nvGrpSpPr>
@@ -2178,6 +2185,18 @@
       </p:grpSpPr>
       <p:sp>
         <p:nvSpPr>
+          <p:cNvPr id="2" name="Slide Image Placeholder 1"/>
+          <p:cNvSpPr>
+            <a:spLocks noGrp="1" noRot="1" noChangeAspect="1"/>
+          </p:cNvSpPr>
+          <p:nvPr>
+            <p:ph type="sldImg"/>
+          </p:nvPr>
+        </p:nvSpPr>
+        <p:spPr/>
+      </p:sp>
+      <p:sp>
+        <p:nvSpPr>
           <p:cNvPr id="3" name="Notes Placeholder 2"/>
           <p:cNvSpPr>
             <a:spLocks noGrp="1"/>
@@ -2192,48 +2211,41 @@
           <a:lstStyle/>
           <a:p>
             <a:r>
-              <a:t>Minutos 15–20, justo después de la regla «primero las personas, después la IA». Contarlo como historia, en un minuto:</a:t>
-            </a:r>
-          </a:p>
-          <a:p/>
-          <a:p>
-            <a:r>
-              <a:t>Hay un programa para crear videojuegos, Unreal Engine 5, que lo hace casi todo solo: la luz, las sombras, los reflejos, el detalle de cada objeto. Con él, una persona desde su casa puede hacer un juego que parece de un gran estudio.</a:t>
-            </a:r>
-          </a:p>
-          <a:p/>
-          <a:p>
-            <a:r>
-              <a:t>Muchísima gente lo usó y dejó que el programa decidiera la luz y el aspecto del juego. Y pasó algo curioso: muchos juegos empezaron a parecerse entre sí. Técnicamente eran impecables, pero tenían todos el mismo aire. Los que llamaban la atención eran los que tenían un estilo propio, y ese estilo no lo pone la herramienta: lo pone la persona.</a:t>
-            </a:r>
-          </a:p>
-          <a:p/>
-          <a:p>
-            <a:r>
-              <a:t>Con la IA pasa lo mismo. Da ideas, resume y redacta muy bien. Pero si todos le preguntamos lo mismo, todos recibimos respuestas parecidas. Ya pasa con las cartas de presentación: las empresas reciben cientos que suenan iguales porque las ha escrito la misma IA.</a:t>
-            </a:r>
-          </a:p>
-          <a:p/>
-          <a:p>
-            <a:r>
-              <a:t>Las personas fallamos más y tenemos días malos. Pero la idea rara, la que nadie más tendría, es la que marca la diferencia, y esa suele salir de nosotros. Por eso: primero pensamos las personas y después usamos la IA para ampliar lo nuestro, no para sustituirlo.</a:t>
-            </a:r>
-          </a:p>
-          <a:p/>
-          <a:p>
-            <a:r>
-              <a:t>Cuidado: no afirmar que la IA es peor que las personas. El argumento es que, si todos usamos la misma herramienta, todos acabamos haciendo lo mismo. Así no se adelanta la conclusión de la comparación del Ejercicio 1.</a:t>
-            </a:r>
-          </a:p>
-          <a:p/>
-          <a:p>
-            <a:r>
-              <a:t>Respaldo (comprobar la referencia antes de citarla): un estudio publicado en 2024 en Science Advances encontró que la IA hacía algo más creativos los textos de cada persona, pero que los textos se parecían mucho más entre sí.</a:t>
-            </a:r>
+              <a:rPr lang="en-US" dirty="0"/>
+              <a:t>Conclusión del bloque. Enlazar con el bloque 2: ahora se aplicarán dos técnicas más estructuradas, SCAMPER y la provocación, por parejas.</a:t>
+            </a:r>
+          </a:p>
+        </p:txBody>
+      </p:sp>
+      <p:sp>
+        <p:nvSpPr>
+          <p:cNvPr id="4" name="Slide Number Placeholder 3"/>
+          <p:cNvSpPr>
+            <a:spLocks noGrp="1"/>
+          </p:cNvSpPr>
+          <p:nvPr>
+            <p:ph type="sldNum" sz="quarter" idx="10"/>
+          </p:nvPr>
+        </p:nvSpPr>
+        <p:spPr/>
+        <p:txBody>
+          <a:bodyPr/>
+          <a:lstStyle/>
+          <a:p>
+            <a:fld id="{F7021451-1387-4CA6-816F-3879F97B5CBC}" type="slidenum">
+              <a:rPr lang="en-US"/>
+              <a:t>29</a:t>
+            </a:fld>
+            <a:endParaRPr lang="en-US"/>
           </a:p>
         </p:txBody>
       </p:sp>
     </p:spTree>
+    <p:extLst>
+      <p:ext uri="{BB962C8B-B14F-4D97-AF65-F5344CB8AC3E}">
+        <p14:creationId xmlns:p14="http://schemas.microsoft.com/office/powerpoint/2010/main" val="1024086991"/>
+      </p:ext>
+    </p:extLst>
   </p:cSld>
   <p:clrMapOvr>
     <a:masterClrMapping/>
@@ -11209,6 +11221,244 @@
 
 <file path=ppt/slides/slide20.xml><?xml version="1.0" encoding="utf-8"?>
 <p:sld xmlns:a="http://schemas.openxmlformats.org/drawingml/2006/main" xmlns:r="http://schemas.openxmlformats.org/officeDocument/2006/relationships" xmlns:p="http://schemas.openxmlformats.org/presentationml/2006/main">
+  <p:cSld>
+    <p:spTree>
+      <p:nvGrpSpPr>
+        <p:cNvPr id="1" name=""/>
+        <p:cNvGrpSpPr/>
+        <p:nvPr/>
+      </p:nvGrpSpPr>
+      <p:grpSpPr>
+        <a:xfrm>
+          <a:off x="0" y="0"/>
+          <a:ext cx="0" cy="0"/>
+          <a:chOff x="0" y="0"/>
+          <a:chExt cx="0" cy="0"/>
+        </a:xfrm>
+      </p:grpSpPr>
+      <p:sp>
+        <p:nvSpPr>
+          <p:cNvPr id="2" name="Text 0"/>
+          <p:cNvSpPr>
+            <a:spLocks noGrp="1"/>
+          </p:cNvSpPr>
+          <p:nvPr>
+            <p:ph type="title" idx="100" hasCustomPrompt="1"/>
+          </p:nvPr>
+        </p:nvSpPr>
+        <p:spPr>
+          <a:xfrm>
+            <a:off x="548640" y="411480"/>
+            <a:ext cx="11094415" cy="777240"/>
+          </a:xfrm>
+          <a:prstGeom prst="rect">
+            <a:avLst/>
+          </a:prstGeom>
+          <a:noFill/>
+          <a:ln/>
+        </p:spPr>
+        <p:txBody>
+          <a:bodyPr wrap="square" lIns="0" tIns="0" rIns="0" bIns="0" rtlCol="0" anchor="ctr"/>
+          <a:lstStyle/>
+          <a:p>
+            <a:pPr marL="0" indent="0" algn="l">
+              <a:buNone/>
+            </a:pPr>
+            <a:r>
+              <a:rPr lang="en-US" sz="3200" b="1" dirty="0">
+                <a:solidFill>
+                  <a:schemeClr val="tx1"/>
+                </a:solidFill>
+              </a:rPr>
+              <a:t>Misma herramienta, mismo resultado</a:t>
+            </a:r>
+            <a:endParaRPr lang="en-US" sz="3200" dirty="0"/>
+          </a:p>
+        </p:txBody>
+      </p:sp>
+      <p:sp>
+        <p:nvSpPr>
+          <p:cNvPr id="3" name="Etiqueta de tiempo"/>
+          <p:cNvSpPr/>
+          <p:nvPr/>
+        </p:nvSpPr>
+        <p:spPr>
+          <a:xfrm>
+            <a:off x="10134295" y="548640"/>
+            <a:ext cx="1508760" cy="457200"/>
+          </a:xfrm>
+          <a:prstGeom prst="roundRect">
+            <a:avLst>
+              <a:gd name="adj" fmla="val 50000"/>
+            </a:avLst>
+          </a:prstGeom>
+          <a:solidFill>
+            <a:schemeClr val="bg2"/>
+          </a:solidFill>
+          <a:ln/>
+        </p:spPr>
+      </p:sp>
+      <p:sp>
+        <p:nvSpPr>
+          <p:cNvPr id="4" name="Text 2"/>
+          <p:cNvSpPr txBox="1"/>
+          <p:nvPr/>
+        </p:nvSpPr>
+        <p:spPr>
+          <a:xfrm>
+            <a:off x="10134295" y="548640"/>
+            <a:ext cx="1508760" cy="457200"/>
+          </a:xfrm>
+          <a:prstGeom prst="rect">
+            <a:avLst/>
+          </a:prstGeom>
+          <a:noFill/>
+          <a:ln/>
+        </p:spPr>
+        <p:txBody>
+          <a:bodyPr wrap="square" lIns="0" tIns="0" rIns="0" bIns="0" rtlCol="0" anchor="ctr"/>
+          <a:lstStyle/>
+          <a:p>
+            <a:pPr marL="0" indent="0" algn="ctr">
+              <a:buNone/>
+            </a:pPr>
+            <a:r>
+              <a:rPr lang="en-US" sz="1400" b="1" dirty="0">
+                <a:solidFill>
+                  <a:schemeClr val="tx1"/>
+                </a:solidFill>
+              </a:rPr>
+              <a:t>Min. 15–20</a:t>
+            </a:r>
+            <a:endParaRPr lang="en-US" sz="1400" dirty="0"/>
+          </a:p>
+        </p:txBody>
+      </p:sp>
+      <p:sp>
+        <p:nvSpPr>
+          <p:cNvPr id="25" name="Slide Number Placeholder 0"/>
+          <p:cNvSpPr>
+            <a:spLocks noGrp="1"/>
+          </p:cNvSpPr>
+          <p:nvPr>
+            <p:ph type="sldNum" sz="quarter" idx="4294967295"/>
+          </p:nvPr>
+        </p:nvSpPr>
+        <p:spPr>
+          <a:xfrm>
+            <a:off x="11091672" y="6355080"/>
+            <a:ext cx="548640" cy="320040"/>
+          </a:xfrm>
+          <a:prstGeom prst="rect">
+            <a:avLst/>
+          </a:prstGeom>
+          <a:extLst>
+            <a:ext uri="{C572A759-6A51-4108-AA02-DFA0A04FC94B}">
+              <ma14:wrappingTextBoxFlag xmlns:ma14="http://schemas.microsoft.com/office/mac/drawingml/2011/main" xmlns="" val="0"/>
+            </a:ext>
+          </a:extLst>
+        </p:spPr>
+        <p:txBody>
+          <a:bodyPr/>
+          <a:lstStyle>
+            <a:lvl1pPr>
+              <a:defRPr sz="1100">
+                <a:solidFill>
+                  <a:srgbClr val="8A94A6"/>
+                </a:solidFill>
+              </a:defRPr>
+            </a:lvl1pPr>
+          </a:lstStyle>
+          <a:p>
+            <a:pPr algn="r"/>
+            <a:fld id="{F7021451-1387-4CA6-816F-3879F97B5CBC}" type="slidenum">
+              <a:rPr lang="en-US" b="0"/>
+              <a:t>20</a:t>
+            </a:fld>
+            <a:endParaRPr lang="en-US"/>
+          </a:p>
+        </p:txBody>
+      </p:sp>
+      <p:sp>
+        <p:nvSpPr>
+          <p:cNvPr id="6" name="Text 0">
+            <a:extLst>
+              <a:ext uri="{FF2B5EF4-FFF2-40B4-BE49-F238E27FC236}">
+                <a16:creationId xmlns:a16="http://schemas.microsoft.com/office/drawing/2014/main" id="{A283B16A-A781-DFDA-EEC3-BD382FEE5646}"/>
+              </a:ext>
+            </a:extLst>
+          </p:cNvPr>
+          <p:cNvSpPr txBox="1">
+            <a:spLocks/>
+          </p:cNvSpPr>
+          <p:nvPr/>
+        </p:nvSpPr>
+        <p:spPr>
+          <a:xfrm>
+            <a:off x="868309" y="2994660"/>
+            <a:ext cx="11094415" cy="777240"/>
+          </a:xfrm>
+          <a:prstGeom prst="rect">
+            <a:avLst/>
+          </a:prstGeom>
+          <a:noFill/>
+          <a:ln/>
+        </p:spPr>
+        <p:txBody>
+          <a:bodyPr wrap="square" lIns="0" tIns="0" rIns="0" bIns="0" rtlCol="0" anchor="ctr"/>
+          <a:lstStyle>
+            <a:lvl1pPr marL="0" indent="0" algn="l" defTabSz="914400" rtl="0" eaLnBrk="1" latinLnBrk="0" hangingPunct="1">
+              <a:spcBef>
+                <a:spcPct val="0"/>
+              </a:spcBef>
+              <a:buNone/>
+              <a:defRPr lang="en-US" sz="3200" b="1" kern="1200" dirty="0">
+                <a:solidFill>
+                  <a:schemeClr val="tx1"/>
+                </a:solidFill>
+                <a:latin typeface="+mj-lt"/>
+                <a:ea typeface="+mj-ea"/>
+                <a:cs typeface="+mj-cs"/>
+              </a:defRPr>
+            </a:lvl1pPr>
+          </a:lstStyle>
+          <a:p>
+            <a:r>
+              <a:rPr lang="es-ES" dirty="0"/>
+              <a:t>Ver casos:</a:t>
+            </a:r>
+            <a:br>
+              <a:rPr lang="es-ES" dirty="0"/>
+            </a:br>
+            <a:r>
+              <a:rPr lang="es-ES" dirty="0" err="1"/>
+              <a:t>Unreal</a:t>
+            </a:r>
+            <a:r>
+              <a:rPr lang="es-ES" dirty="0"/>
+              <a:t> </a:t>
+            </a:r>
+            <a:r>
+              <a:rPr lang="es-ES" dirty="0" err="1"/>
+              <a:t>Engine</a:t>
+            </a:r>
+            <a:r>
+              <a:rPr lang="es-ES" dirty="0"/>
+              <a:t> 5 y Relatos cortos</a:t>
+            </a:r>
+          </a:p>
+        </p:txBody>
+      </p:sp>
+    </p:spTree>
+  </p:cSld>
+  <p:clrMapOvr>
+    <a:masterClrMapping/>
+  </p:clrMapOvr>
+</p:sld>
+</file>
+
+<file path=ppt/slides/slide21.xml><?xml version="1.0" encoding="utf-8"?>
+<p:sld xmlns:a="http://schemas.openxmlformats.org/drawingml/2006/main" xmlns:r="http://schemas.openxmlformats.org/officeDocument/2006/relationships" xmlns:p="http://schemas.openxmlformats.org/presentationml/2006/main">
   <p:cSld name="Slide 20">
     <p:spTree>
       <p:nvGrpSpPr>
@@ -11783,7 +12033,7 @@
             <a:pPr algn="r"/>
             <a:fld id="{F7021451-1387-4CA6-816F-3879F97B5CBC}" type="slidenum">
               <a:rPr lang="en-US" b="0"/>
-              <a:t>20</a:t>
+              <a:t>21</a:t>
             </a:fld>
             <a:endParaRPr lang="en-US"/>
           </a:p>
@@ -11797,7 +12047,7 @@
 </p:sld>
 </file>
 
-<file path=ppt/slides/slide21.xml><?xml version="1.0" encoding="utf-8"?>
+<file path=ppt/slides/slide22.xml><?xml version="1.0" encoding="utf-8"?>
 <p:sld xmlns:a="http://schemas.openxmlformats.org/drawingml/2006/main" xmlns:r="http://schemas.openxmlformats.org/officeDocument/2006/relationships" xmlns:p="http://schemas.openxmlformats.org/presentationml/2006/main">
   <p:cSld name="Slide 21">
     <p:spTree>
@@ -12443,7 +12693,7 @@
             <a:pPr algn="r"/>
             <a:fld id="{F7021451-1387-4CA6-816F-3879F97B5CBC}" type="slidenum">
               <a:rPr lang="en-US" b="0"/>
-              <a:t>21</a:t>
+              <a:t>22</a:t>
             </a:fld>
             <a:endParaRPr lang="en-US"/>
           </a:p>
@@ -12457,7 +12707,7 @@
 </p:sld>
 </file>
 
-<file path=ppt/slides/slide22.xml><?xml version="1.0" encoding="utf-8"?>
+<file path=ppt/slides/slide23.xml><?xml version="1.0" encoding="utf-8"?>
 <p:sld xmlns:a="http://schemas.openxmlformats.org/drawingml/2006/main" xmlns:r="http://schemas.openxmlformats.org/officeDocument/2006/relationships" xmlns:p="http://schemas.openxmlformats.org/presentationml/2006/main">
   <p:cSld name="Slide 22">
     <p:spTree>
@@ -12776,7 +13026,7 @@
                   <a:schemeClr val="tx1"/>
                 </a:solidFill>
               </a:rPr>
-              <a:t>Cortes gratis a estudiantes de peluquería, que practican supervisados.</a:t>
+              <a:t>Cortes gratis de estudiantes de peluquería, que practican supervisados.</a:t>
             </a:r>
             <a:endParaRPr lang="en-US" sz="1600" dirty="0"/>
           </a:p>
@@ -13105,7 +13355,7 @@
             <a:pPr algn="r"/>
             <a:fld id="{F7021451-1387-4CA6-816F-3879F97B5CBC}" type="slidenum">
               <a:rPr lang="en-US" b="0"/>
-              <a:t>22</a:t>
+              <a:t>23</a:t>
             </a:fld>
             <a:endParaRPr lang="en-US"/>
           </a:p>
@@ -13119,7 +13369,7 @@
 </p:sld>
 </file>
 
-<file path=ppt/slides/slide23.xml><?xml version="1.0" encoding="utf-8"?>
+<file path=ppt/slides/slide24.xml><?xml version="1.0" encoding="utf-8"?>
 <p:sld xmlns:a="http://schemas.openxmlformats.org/drawingml/2006/main" xmlns:r="http://schemas.openxmlformats.org/officeDocument/2006/relationships" xmlns:p="http://schemas.openxmlformats.org/presentationml/2006/main">
   <p:cSld name="Slide 23">
     <p:spTree>
@@ -13585,7 +13835,7 @@
             <a:pPr algn="r"/>
             <a:fld id="{F7021451-1387-4CA6-816F-3879F97B5CBC}" type="slidenum">
               <a:rPr lang="en-US" b="0"/>
-              <a:t>23</a:t>
+              <a:t>24</a:t>
             </a:fld>
             <a:endParaRPr lang="en-US"/>
           </a:p>
@@ -13599,7 +13849,7 @@
 </p:sld>
 </file>
 
-<file path=ppt/slides/slide24.xml><?xml version="1.0" encoding="utf-8"?>
+<file path=ppt/slides/slide25.xml><?xml version="1.0" encoding="utf-8"?>
 <p:sld xmlns:a="http://schemas.openxmlformats.org/drawingml/2006/main" xmlns:r="http://schemas.openxmlformats.org/officeDocument/2006/relationships" xmlns:p="http://schemas.openxmlformats.org/presentationml/2006/main">
   <p:cSld name="Slide 24">
     <p:spTree>
@@ -14621,7 +14871,7 @@
             <a:pPr algn="r"/>
             <a:fld id="{F7021451-1387-4CA6-816F-3879F97B5CBC}" type="slidenum">
               <a:rPr lang="en-US" b="0"/>
-              <a:t>24</a:t>
+              <a:t>25</a:t>
             </a:fld>
             <a:endParaRPr lang="en-US"/>
           </a:p>
@@ -14635,7 +14885,7 @@
 </p:sld>
 </file>
 
-<file path=ppt/slides/slide25.xml><?xml version="1.0" encoding="utf-8"?>
+<file path=ppt/slides/slide26.xml><?xml version="1.0" encoding="utf-8"?>
 <p:sld xmlns:a="http://schemas.openxmlformats.org/drawingml/2006/main" xmlns:r="http://schemas.openxmlformats.org/officeDocument/2006/relationships" xmlns:p="http://schemas.openxmlformats.org/presentationml/2006/main">
   <p:cSld name="Slide 25">
     <p:spTree>
@@ -15241,7 +15491,7 @@
             <a:pPr algn="r"/>
             <a:fld id="{F7021451-1387-4CA6-816F-3879F97B5CBC}" type="slidenum">
               <a:rPr lang="en-US" b="0"/>
-              <a:t>25</a:t>
+              <a:t>26</a:t>
             </a:fld>
             <a:endParaRPr lang="en-US"/>
           </a:p>
@@ -15255,7 +15505,7 @@
 </p:sld>
 </file>
 
-<file path=ppt/slides/slide26.xml><?xml version="1.0" encoding="utf-8"?>
+<file path=ppt/slides/slide27.xml><?xml version="1.0" encoding="utf-8"?>
 <p:sld xmlns:a="http://schemas.openxmlformats.org/drawingml/2006/main" xmlns:r="http://schemas.openxmlformats.org/officeDocument/2006/relationships" xmlns:p="http://schemas.openxmlformats.org/presentationml/2006/main">
   <p:cSld name="Slide 26">
     <p:spTree>
@@ -15546,7 +15796,7 @@
         </p:nvGraphicFramePr>
         <p:xfrm>
           <a:off x="5943600" y="1737360"/>
-          <a:ext cx="5699455" cy="914400"/>
+          <a:ext cx="5513832" cy="3108960"/>
         </p:xfrm>
         <a:graphic>
           <a:graphicData uri="http://schemas.openxmlformats.org/drawingml/2006/table">
@@ -16166,7 +16416,7 @@
             <a:pPr algn="r"/>
             <a:fld id="{F7021451-1387-4CA6-816F-3879F97B5CBC}" type="slidenum">
               <a:rPr lang="en-US" b="0"/>
-              <a:t>26</a:t>
+              <a:t>27</a:t>
             </a:fld>
             <a:endParaRPr lang="en-US"/>
           </a:p>
@@ -16180,7 +16430,7 @@
 </p:sld>
 </file>
 
-<file path=ppt/slides/slide27.xml><?xml version="1.0" encoding="utf-8"?>
+<file path=ppt/slides/slide28.xml><?xml version="1.0" encoding="utf-8"?>
 <p:sld xmlns:a="http://schemas.openxmlformats.org/drawingml/2006/main" xmlns:r="http://schemas.openxmlformats.org/officeDocument/2006/relationships" xmlns:p="http://schemas.openxmlformats.org/presentationml/2006/main">
   <p:cSld name="Slide 27">
     <p:spTree>
@@ -16640,7 +16890,7 @@
             <a:pPr algn="r"/>
             <a:fld id="{F7021451-1387-4CA6-816F-3879F97B5CBC}" type="slidenum">
               <a:rPr lang="en-US" b="0"/>
-              <a:t>27</a:t>
+              <a:t>28</a:t>
             </a:fld>
             <a:endParaRPr lang="en-US"/>
           </a:p>
@@ -16654,7 +16904,7 @@
 </p:sld>
 </file>
 
-<file path=ppt/slides/slide28.xml><?xml version="1.0" encoding="utf-8"?>
+<file path=ppt/slides/slide29.xml><?xml version="1.0" encoding="utf-8"?>
 <p:sld xmlns:a="http://schemas.openxmlformats.org/drawingml/2006/main" xmlns:r="http://schemas.openxmlformats.org/officeDocument/2006/relationships" xmlns:p="http://schemas.openxmlformats.org/presentationml/2006/main">
   <p:cSld name="Slide 28">
     <p:spTree>
@@ -16800,850 +17050,9 @@
             <a:pPr algn="r"/>
             <a:fld id="{F7021451-1387-4CA6-816F-3879F97B5CBC}" type="slidenum">
               <a:rPr lang="en-US" b="0"/>
-              <a:t>28</a:t>
+              <a:t>29</a:t>
             </a:fld>
             <a:endParaRPr lang="en-US"/>
-          </a:p>
-        </p:txBody>
-      </p:sp>
-    </p:spTree>
-  </p:cSld>
-  <p:clrMapOvr>
-    <a:masterClrMapping/>
-  </p:clrMapOvr>
-</p:sld>
-</file>
-
-<file path=ppt/slides/slide29.xml><?xml version="1.0" encoding="utf-8"?>
-<p:sld xmlns:a="http://schemas.openxmlformats.org/drawingml/2006/main" xmlns:p="http://schemas.openxmlformats.org/presentationml/2006/main" xmlns:r="http://schemas.openxmlformats.org/officeDocument/2006/relationships">
-  <p:cSld>
-    <p:spTree>
-      <p:nvGrpSpPr>
-        <p:cNvPr id="1" name=""/>
-        <p:cNvGrpSpPr/>
-        <p:nvPr/>
-      </p:nvGrpSpPr>
-      <p:grpSpPr/>
-      <p:sp>
-        <p:nvSpPr>
-          <p:cNvPr id="2" name="Text 0"/>
-          <p:cNvSpPr>
-            <a:spLocks noGrp="1"/>
-          </p:cNvSpPr>
-          <p:nvPr>
-            <p:ph type="title" idx="100" hasCustomPrompt="1"/>
-          </p:nvPr>
-        </p:nvSpPr>
-        <p:spPr>
-          <a:xfrm>
-            <a:off x="548640" y="411480"/>
-            <a:ext cx="11094415" cy="777240"/>
-          </a:xfrm>
-          <a:prstGeom prst="rect">
-            <a:avLst/>
-          </a:prstGeom>
-          <a:noFill/>
-          <a:ln/>
-        </p:spPr>
-        <p:txBody>
-          <a:bodyPr wrap="square" lIns="0" tIns="0" rIns="0" bIns="0" rtlCol="0" anchor="ctr"/>
-          <a:lstStyle/>
-          <a:p>
-            <a:pPr marL="0" indent="0" algn="l">
-              <a:buNone/>
-            </a:pPr>
-            <a:r>
-              <a:rPr lang="en-US" sz="3200" b="1" dirty="0">
-                <a:solidFill>
-                  <a:schemeClr val="tx1"/>
-                </a:solidFill>
-              </a:rPr>
-              <a:t>Misma herramienta, mismo resultado</a:t>
-            </a:r>
-            <a:endParaRPr lang="en-US" sz="3200" dirty="0"/>
-          </a:p>
-        </p:txBody>
-      </p:sp>
-      <p:sp>
-        <p:nvSpPr>
-          <p:cNvPr id="3" name="Etiqueta de tiempo"/>
-          <p:cNvSpPr/>
-          <p:nvPr/>
-        </p:nvSpPr>
-        <p:spPr>
-          <a:xfrm>
-            <a:off x="10134295" y="548640"/>
-            <a:ext cx="1508760" cy="457200"/>
-          </a:xfrm>
-          <a:prstGeom prst="roundRect">
-            <a:avLst>
-              <a:gd name="adj" fmla="val 50000"/>
-            </a:avLst>
-          </a:prstGeom>
-          <a:solidFill>
-            <a:schemeClr val="bg2"/>
-          </a:solidFill>
-          <a:ln/>
-        </p:spPr>
-      </p:sp>
-      <p:sp>
-        <p:nvSpPr>
-          <p:cNvPr id="4" name="Text 2"/>
-          <p:cNvSpPr txBox="1"/>
-          <p:nvPr/>
-        </p:nvSpPr>
-        <p:spPr>
-          <a:xfrm>
-            <a:off x="10134295" y="548640"/>
-            <a:ext cx="1508760" cy="457200"/>
-          </a:xfrm>
-          <a:prstGeom prst="rect">
-            <a:avLst/>
-          </a:prstGeom>
-          <a:noFill/>
-          <a:ln/>
-        </p:spPr>
-        <p:txBody>
-          <a:bodyPr wrap="square" lIns="0" tIns="0" rIns="0" bIns="0" rtlCol="0" anchor="ctr"/>
-          <a:lstStyle/>
-          <a:p>
-            <a:pPr marL="0" indent="0" algn="ctr">
-              <a:buNone/>
-            </a:pPr>
-            <a:r>
-              <a:rPr lang="en-US" sz="1400" b="1" dirty="0">
-                <a:solidFill>
-                  <a:schemeClr val="tx1"/>
-                </a:solidFill>
-              </a:rPr>
-              <a:t>Min. 15–20</a:t>
-            </a:r>
-            <a:endParaRPr lang="en-US" sz="1400" dirty="0"/>
-          </a:p>
-        </p:txBody>
-      </p:sp>
-      <p:sp>
-        <p:nvSpPr>
-          <p:cNvPr id="25" name="Slide Number Placeholder 0"/>
-          <p:cNvSpPr>
-            <a:spLocks noGrp="1"/>
-          </p:cNvSpPr>
-          <p:nvPr>
-            <p:ph type="sldNum" sz="quarter" idx="4294967295"/>
-          </p:nvPr>
-        </p:nvSpPr>
-        <p:spPr>
-          <a:xfrm>
-            <a:off x="11091672" y="6355080"/>
-            <a:ext cx="548640" cy="320040"/>
-          </a:xfrm>
-          <a:prstGeom prst="rect">
-            <a:avLst/>
-          </a:prstGeom>
-          <a:extLst>
-            <a:ext uri="{C572A759-6A51-4108-AA02-DFA0A04FC94B}">
-              <ma14:wrappingTextBoxFlag xmlns:ma14="http://schemas.microsoft.com/office/mac/drawingml/2011/main" xmlns="" val="0"/>
-            </a:ext>
-          </a:extLst>
-        </p:spPr>
-        <p:txBody>
-          <a:bodyPr/>
-          <a:lstStyle>
-            <a:lvl1pPr>
-              <a:defRPr sz="1100">
-                <a:solidFill>
-                  <a:srgbClr val="8A94A6"/>
-                </a:solidFill>
-              </a:defRPr>
-            </a:lvl1pPr>
-          </a:lstStyle>
-          <a:p>
-            <a:pPr algn="r"/>
-            <a:fld id="{F7021451-1387-4CA6-816F-3879F97B5CBC}" type="slidenum">
-              <a:rPr lang="en-US" b="0"/>
-              <a:t>19</a:t>
-            </a:fld>
-            <a:endParaRPr lang="en-US"/>
-          </a:p>
-        </p:txBody>
-      </p:sp>
-      <p:sp>
-        <p:nvSpPr>
-          <p:cNvPr id="26" name="Tarjeta Unreal Engine 5"/>
-          <p:cNvSpPr/>
-          <p:nvPr/>
-        </p:nvSpPr>
-        <p:spPr>
-          <a:xfrm>
-            <a:off x="548640" y="1463040"/>
-            <a:ext cx="11094415" cy="1463040"/>
-          </a:xfrm>
-          <a:prstGeom prst="roundRect">
-            <a:avLst>
-              <a:gd name="adj" fmla="val 9374"/>
-            </a:avLst>
-          </a:prstGeom>
-          <a:solidFill>
-            <a:schemeClr val="bg2"/>
-          </a:solidFill>
-          <a:ln>
-            <a:noFill/>
-          </a:ln>
-          <a:effectLst/>
-        </p:spPr>
-        <p:style>
-          <a:lnRef idx="1">
-            <a:schemeClr val="accent1"/>
-          </a:lnRef>
-          <a:fillRef idx="3">
-            <a:schemeClr val="accent1"/>
-          </a:fillRef>
-          <a:effectRef idx="2">
-            <a:schemeClr val="accent1"/>
-          </a:effectRef>
-          <a:fontRef idx="minor">
-            <a:schemeClr val="lt1"/>
-          </a:fontRef>
-        </p:style>
-        <p:txBody>
-          <a:bodyPr rtlCol="0" anchor="ctr"/>
-          <a:lstStyle/>
-          <a:p>
-            <a:pPr algn="ctr"/>
-          </a:p>
-        </p:txBody>
-      </p:sp>
-      <p:sp>
-        <p:nvSpPr>
-          <p:cNvPr id="27" name="Unreal Engine 5"/>
-          <p:cNvSpPr/>
-          <p:nvPr/>
-        </p:nvSpPr>
-        <p:spPr>
-          <a:xfrm>
-            <a:off x="822959" y="1737360"/>
-            <a:ext cx="914400" cy="914400"/>
-          </a:xfrm>
-          <a:prstGeom prst="ellipse">
-            <a:avLst/>
-          </a:prstGeom>
-          <a:solidFill>
-            <a:schemeClr val="tx1"/>
-          </a:solidFill>
-          <a:ln>
-            <a:noFill/>
-          </a:ln>
-          <a:effectLst/>
-        </p:spPr>
-        <p:style>
-          <a:lnRef idx="1">
-            <a:schemeClr val="accent1"/>
-          </a:lnRef>
-          <a:fillRef idx="3">
-            <a:schemeClr val="accent1"/>
-          </a:fillRef>
-          <a:effectRef idx="2">
-            <a:schemeClr val="accent1"/>
-          </a:effectRef>
-          <a:fontRef idx="minor">
-            <a:schemeClr val="lt1"/>
-          </a:fontRef>
-        </p:style>
-        <p:txBody>
-          <a:bodyPr rtlCol="0" anchor="ctr"/>
-          <a:lstStyle/>
-          <a:p>
-            <a:pPr algn="ctr"/>
-          </a:p>
-        </p:txBody>
-      </p:sp>
-      <p:pic>
-        <p:nvPicPr>
-          <p:cNvPr id="28" name="Unreal Engine 5" descr="FaGamepad-FFFFFF.png"/>
-          <p:cNvPicPr>
-            <a:picLocks noChangeAspect="1"/>
-          </p:cNvPicPr>
-          <p:nvPr/>
-        </p:nvPicPr>
-        <p:blipFill>
-          <a:blip r:embed="rId2"/>
-          <a:stretch>
-            <a:fillRect/>
-          </a:stretch>
-        </p:blipFill>
-        <p:spPr>
-          <a:xfrm>
-            <a:off x="1042415" y="1956816"/>
-            <a:ext cx="475488" cy="475488"/>
-          </a:xfrm>
-          <a:prstGeom prst="rect">
-            <a:avLst/>
-          </a:prstGeom>
-        </p:spPr>
-      </p:pic>
-      <p:sp>
-        <p:nvSpPr>
-          <p:cNvPr id="29" name="Texto Unreal Engine 5"/>
-          <p:cNvSpPr txBox="1"/>
-          <p:nvPr/>
-        </p:nvSpPr>
-        <p:spPr>
-          <a:xfrm>
-            <a:off x="2011680" y="1463040"/>
-            <a:ext cx="5760720" cy="1463040"/>
-          </a:xfrm>
-          <a:prstGeom prst="rect">
-            <a:avLst/>
-          </a:prstGeom>
-          <a:noFill/>
-        </p:spPr>
-        <p:txBody>
-          <a:bodyPr wrap="square" anchor="ctr" lIns="0" rIns="0" tIns="0" bIns="0">
-            <a:spAutoFit/>
-          </a:bodyPr>
-          <a:lstStyle/>
-          <a:p>
-            <a:r>
-              <a:rPr sz="2000" b="1">
-                <a:solidFill>
-                  <a:schemeClr val="tx1"/>
-                </a:solidFill>
-              </a:rPr>
-              <a:t>Unreal Engine 5</a:t>
-            </a:r>
-          </a:p>
-          <a:p>
-            <a:pPr>
-              <a:spcBef>
-                <a:spcPts val="400"/>
-              </a:spcBef>
-            </a:pPr>
-            <a:r>
-              <a:rPr sz="1700" b="0">
-                <a:solidFill>
-                  <a:schemeClr val="tx1"/>
-                </a:solidFill>
-              </a:rPr>
-              <a:t>Cualquiera podía hacer un juego de aspecto profesional… y muchos juegos acabaron pareciéndose.</a:t>
-            </a:r>
-          </a:p>
-        </p:txBody>
-      </p:sp>
-      <p:pic>
-        <p:nvPicPr>
-          <p:cNvPr id="30" name="Resultado igual" descr="FaGamepad-8A94A6.png"/>
-          <p:cNvPicPr>
-            <a:picLocks noChangeAspect="1"/>
-          </p:cNvPicPr>
-          <p:nvPr/>
-        </p:nvPicPr>
-        <p:blipFill>
-          <a:blip r:embed="rId3"/>
-          <a:stretch>
-            <a:fillRect/>
-          </a:stretch>
-        </p:blipFill>
-        <p:spPr>
-          <a:xfrm>
-            <a:off x="8001000" y="1947672"/>
-            <a:ext cx="502920" cy="502920"/>
-          </a:xfrm>
-          <a:prstGeom prst="rect">
-            <a:avLst/>
-          </a:prstGeom>
-        </p:spPr>
-      </p:pic>
-      <p:pic>
-        <p:nvPicPr>
-          <p:cNvPr id="31" name="Resultado igual" descr="FaGamepad-8A94A6.png"/>
-          <p:cNvPicPr>
-            <a:picLocks noChangeAspect="1"/>
-          </p:cNvPicPr>
-          <p:nvPr/>
-        </p:nvPicPr>
-        <p:blipFill>
-          <a:blip r:embed="rId3"/>
-          <a:stretch>
-            <a:fillRect/>
-          </a:stretch>
-        </p:blipFill>
-        <p:spPr>
-          <a:xfrm>
-            <a:off x="8714232" y="1947672"/>
-            <a:ext cx="502920" cy="502920"/>
-          </a:xfrm>
-          <a:prstGeom prst="rect">
-            <a:avLst/>
-          </a:prstGeom>
-        </p:spPr>
-      </p:pic>
-      <p:pic>
-        <p:nvPicPr>
-          <p:cNvPr id="32" name="Resultado igual" descr="FaGamepad-8A94A6.png"/>
-          <p:cNvPicPr>
-            <a:picLocks noChangeAspect="1"/>
-          </p:cNvPicPr>
-          <p:nvPr/>
-        </p:nvPicPr>
-        <p:blipFill>
-          <a:blip r:embed="rId3"/>
-          <a:stretch>
-            <a:fillRect/>
-          </a:stretch>
-        </p:blipFill>
-        <p:spPr>
-          <a:xfrm>
-            <a:off x="9427464" y="1947672"/>
-            <a:ext cx="502920" cy="502920"/>
-          </a:xfrm>
-          <a:prstGeom prst="rect">
-            <a:avLst/>
-          </a:prstGeom>
-        </p:spPr>
-      </p:pic>
-      <p:pic>
-        <p:nvPicPr>
-          <p:cNvPr id="33" name="Resultado igual" descr="FaGamepad-8A94A6.png"/>
-          <p:cNvPicPr>
-            <a:picLocks noChangeAspect="1"/>
-          </p:cNvPicPr>
-          <p:nvPr/>
-        </p:nvPicPr>
-        <p:blipFill>
-          <a:blip r:embed="rId3"/>
-          <a:stretch>
-            <a:fillRect/>
-          </a:stretch>
-        </p:blipFill>
-        <p:spPr>
-          <a:xfrm>
-            <a:off x="10140696" y="1947672"/>
-            <a:ext cx="502920" cy="502920"/>
-          </a:xfrm>
-          <a:prstGeom prst="rect">
-            <a:avLst/>
-          </a:prstGeom>
-        </p:spPr>
-      </p:pic>
-      <p:pic>
-        <p:nvPicPr>
-          <p:cNvPr id="34" name="Resultado igual" descr="FaGamepad-8A94A6.png"/>
-          <p:cNvPicPr>
-            <a:picLocks noChangeAspect="1"/>
-          </p:cNvPicPr>
-          <p:nvPr/>
-        </p:nvPicPr>
-        <p:blipFill>
-          <a:blip r:embed="rId3"/>
-          <a:stretch>
-            <a:fillRect/>
-          </a:stretch>
-        </p:blipFill>
-        <p:spPr>
-          <a:xfrm>
-            <a:off x="10853928" y="1947672"/>
-            <a:ext cx="502920" cy="502920"/>
-          </a:xfrm>
-          <a:prstGeom prst="rect">
-            <a:avLst/>
-          </a:prstGeom>
-        </p:spPr>
-      </p:pic>
-      <p:sp>
-        <p:nvSpPr>
-          <p:cNvPr id="35" name="Tarjeta La IA"/>
-          <p:cNvSpPr/>
-          <p:nvPr/>
-        </p:nvSpPr>
-        <p:spPr>
-          <a:xfrm>
-            <a:off x="548640" y="3108960"/>
-            <a:ext cx="11094415" cy="1463040"/>
-          </a:xfrm>
-          <a:prstGeom prst="roundRect">
-            <a:avLst>
-              <a:gd name="adj" fmla="val 9374"/>
-            </a:avLst>
-          </a:prstGeom>
-          <a:solidFill>
-            <a:schemeClr val="bg2"/>
-          </a:solidFill>
-          <a:ln>
-            <a:noFill/>
-          </a:ln>
-          <a:effectLst/>
-        </p:spPr>
-        <p:style>
-          <a:lnRef idx="1">
-            <a:schemeClr val="accent1"/>
-          </a:lnRef>
-          <a:fillRef idx="3">
-            <a:schemeClr val="accent1"/>
-          </a:fillRef>
-          <a:effectRef idx="2">
-            <a:schemeClr val="accent1"/>
-          </a:effectRef>
-          <a:fontRef idx="minor">
-            <a:schemeClr val="lt1"/>
-          </a:fontRef>
-        </p:style>
-        <p:txBody>
-          <a:bodyPr rtlCol="0" anchor="ctr"/>
-          <a:lstStyle/>
-          <a:p>
-            <a:pPr algn="ctr"/>
-          </a:p>
-        </p:txBody>
-      </p:sp>
-      <p:sp>
-        <p:nvSpPr>
-          <p:cNvPr id="36" name="La IA"/>
-          <p:cNvSpPr/>
-          <p:nvPr/>
-        </p:nvSpPr>
-        <p:spPr>
-          <a:xfrm>
-            <a:off x="822959" y="3383279"/>
-            <a:ext cx="914400" cy="914400"/>
-          </a:xfrm>
-          <a:prstGeom prst="ellipse">
-            <a:avLst/>
-          </a:prstGeom>
-          <a:solidFill>
-            <a:schemeClr val="accent2"/>
-          </a:solidFill>
-          <a:ln>
-            <a:noFill/>
-          </a:ln>
-          <a:effectLst/>
-        </p:spPr>
-        <p:style>
-          <a:lnRef idx="1">
-            <a:schemeClr val="accent1"/>
-          </a:lnRef>
-          <a:fillRef idx="3">
-            <a:schemeClr val="accent1"/>
-          </a:fillRef>
-          <a:effectRef idx="2">
-            <a:schemeClr val="accent1"/>
-          </a:effectRef>
-          <a:fontRef idx="minor">
-            <a:schemeClr val="lt1"/>
-          </a:fontRef>
-        </p:style>
-        <p:txBody>
-          <a:bodyPr rtlCol="0" anchor="ctr"/>
-          <a:lstStyle/>
-          <a:p>
-            <a:pPr algn="ctr"/>
-          </a:p>
-        </p:txBody>
-      </p:sp>
-      <p:pic>
-        <p:nvPicPr>
-          <p:cNvPr id="37" name="La IA" descr="image.png"/>
-          <p:cNvPicPr>
-            <a:picLocks noChangeAspect="1"/>
-          </p:cNvPicPr>
-          <p:nvPr/>
-        </p:nvPicPr>
-        <p:blipFill>
-          <a:blip r:embed="rId4"/>
-          <a:stretch>
-            <a:fillRect/>
-          </a:stretch>
-        </p:blipFill>
-        <p:spPr>
-          <a:xfrm>
-            <a:off x="1042415" y="3602735"/>
-            <a:ext cx="475488" cy="475488"/>
-          </a:xfrm>
-          <a:prstGeom prst="rect">
-            <a:avLst/>
-          </a:prstGeom>
-        </p:spPr>
-      </p:pic>
-      <p:sp>
-        <p:nvSpPr>
-          <p:cNvPr id="38" name="Texto La IA"/>
-          <p:cNvSpPr txBox="1"/>
-          <p:nvPr/>
-        </p:nvSpPr>
-        <p:spPr>
-          <a:xfrm>
-            <a:off x="2011680" y="3108960"/>
-            <a:ext cx="5760720" cy="1463040"/>
-          </a:xfrm>
-          <a:prstGeom prst="rect">
-            <a:avLst/>
-          </a:prstGeom>
-          <a:noFill/>
-        </p:spPr>
-        <p:txBody>
-          <a:bodyPr wrap="square" anchor="ctr" lIns="0" rIns="0" tIns="0" bIns="0">
-            <a:spAutoFit/>
-          </a:bodyPr>
-          <a:lstStyle/>
-          <a:p>
-            <a:r>
-              <a:rPr sz="2000" b="1">
-                <a:solidFill>
-                  <a:schemeClr val="tx1"/>
-                </a:solidFill>
-              </a:rPr>
-              <a:t>La IA</a:t>
-            </a:r>
-          </a:p>
-          <a:p>
-            <a:pPr>
-              <a:spcBef>
-                <a:spcPts val="400"/>
-              </a:spcBef>
-            </a:pPr>
-            <a:r>
-              <a:rPr sz="1700" b="0">
-                <a:solidFill>
-                  <a:schemeClr val="tx1"/>
-                </a:solidFill>
-              </a:rPr>
-              <a:t>Si todos le pedimos lo mismo, todos recibimos lo mismo: cientos de cartas de presentación que suenan iguales.</a:t>
-            </a:r>
-          </a:p>
-        </p:txBody>
-      </p:sp>
-      <p:pic>
-        <p:nvPicPr>
-          <p:cNvPr id="39" name="Resultado igual" descr="FaFileAlt-8A94A6.png"/>
-          <p:cNvPicPr>
-            <a:picLocks noChangeAspect="1"/>
-          </p:cNvPicPr>
-          <p:nvPr/>
-        </p:nvPicPr>
-        <p:blipFill>
-          <a:blip r:embed="rId5"/>
-          <a:stretch>
-            <a:fillRect/>
-          </a:stretch>
-        </p:blipFill>
-        <p:spPr>
-          <a:xfrm>
-            <a:off x="8001000" y="3593591"/>
-            <a:ext cx="502920" cy="502920"/>
-          </a:xfrm>
-          <a:prstGeom prst="rect">
-            <a:avLst/>
-          </a:prstGeom>
-        </p:spPr>
-      </p:pic>
-      <p:pic>
-        <p:nvPicPr>
-          <p:cNvPr id="40" name="Resultado igual" descr="FaFileAlt-8A94A6.png"/>
-          <p:cNvPicPr>
-            <a:picLocks noChangeAspect="1"/>
-          </p:cNvPicPr>
-          <p:nvPr/>
-        </p:nvPicPr>
-        <p:blipFill>
-          <a:blip r:embed="rId5"/>
-          <a:stretch>
-            <a:fillRect/>
-          </a:stretch>
-        </p:blipFill>
-        <p:spPr>
-          <a:xfrm>
-            <a:off x="8714232" y="3593591"/>
-            <a:ext cx="502920" cy="502920"/>
-          </a:xfrm>
-          <a:prstGeom prst="rect">
-            <a:avLst/>
-          </a:prstGeom>
-        </p:spPr>
-      </p:pic>
-      <p:pic>
-        <p:nvPicPr>
-          <p:cNvPr id="41" name="Resultado igual" descr="FaFileAlt-8A94A6.png"/>
-          <p:cNvPicPr>
-            <a:picLocks noChangeAspect="1"/>
-          </p:cNvPicPr>
-          <p:nvPr/>
-        </p:nvPicPr>
-        <p:blipFill>
-          <a:blip r:embed="rId5"/>
-          <a:stretch>
-            <a:fillRect/>
-          </a:stretch>
-        </p:blipFill>
-        <p:spPr>
-          <a:xfrm>
-            <a:off x="9427464" y="3593591"/>
-            <a:ext cx="502920" cy="502920"/>
-          </a:xfrm>
-          <a:prstGeom prst="rect">
-            <a:avLst/>
-          </a:prstGeom>
-        </p:spPr>
-      </p:pic>
-      <p:pic>
-        <p:nvPicPr>
-          <p:cNvPr id="42" name="Resultado igual" descr="FaFileAlt-8A94A6.png"/>
-          <p:cNvPicPr>
-            <a:picLocks noChangeAspect="1"/>
-          </p:cNvPicPr>
-          <p:nvPr/>
-        </p:nvPicPr>
-        <p:blipFill>
-          <a:blip r:embed="rId5"/>
-          <a:stretch>
-            <a:fillRect/>
-          </a:stretch>
-        </p:blipFill>
-        <p:spPr>
-          <a:xfrm>
-            <a:off x="10140696" y="3593591"/>
-            <a:ext cx="502920" cy="502920"/>
-          </a:xfrm>
-          <a:prstGeom prst="rect">
-            <a:avLst/>
-          </a:prstGeom>
-        </p:spPr>
-      </p:pic>
-      <p:pic>
-        <p:nvPicPr>
-          <p:cNvPr id="43" name="Resultado igual" descr="FaFileAlt-8A94A6.png"/>
-          <p:cNvPicPr>
-            <a:picLocks noChangeAspect="1"/>
-          </p:cNvPicPr>
-          <p:nvPr/>
-        </p:nvPicPr>
-        <p:blipFill>
-          <a:blip r:embed="rId5"/>
-          <a:stretch>
-            <a:fillRect/>
-          </a:stretch>
-        </p:blipFill>
-        <p:spPr>
-          <a:xfrm>
-            <a:off x="10853928" y="3593591"/>
-            <a:ext cx="502920" cy="502920"/>
-          </a:xfrm>
-          <a:prstGeom prst="rect">
-            <a:avLst/>
-          </a:prstGeom>
-        </p:spPr>
-      </p:pic>
-      <p:sp>
-        <p:nvSpPr>
-          <p:cNvPr id="44" name="Personas"/>
-          <p:cNvSpPr/>
-          <p:nvPr/>
-        </p:nvSpPr>
-        <p:spPr>
-          <a:xfrm>
-            <a:off x="548640" y="4983480"/>
-            <a:ext cx="822960" cy="822960"/>
-          </a:xfrm>
-          <a:prstGeom prst="ellipse">
-            <a:avLst/>
-          </a:prstGeom>
-          <a:solidFill>
-            <a:schemeClr val="accent1"/>
-          </a:solidFill>
-          <a:ln>
-            <a:noFill/>
-          </a:ln>
-          <a:effectLst/>
-        </p:spPr>
-        <p:style>
-          <a:lnRef idx="1">
-            <a:schemeClr val="accent1"/>
-          </a:lnRef>
-          <a:fillRef idx="3">
-            <a:schemeClr val="accent1"/>
-          </a:fillRef>
-          <a:effectRef idx="2">
-            <a:schemeClr val="accent1"/>
-          </a:effectRef>
-          <a:fontRef idx="minor">
-            <a:schemeClr val="lt1"/>
-          </a:fontRef>
-        </p:style>
-        <p:txBody>
-          <a:bodyPr rtlCol="0" anchor="ctr"/>
-          <a:lstStyle/>
-          <a:p>
-            <a:pPr algn="ctr"/>
-          </a:p>
-        </p:txBody>
-      </p:sp>
-      <p:pic>
-        <p:nvPicPr>
-          <p:cNvPr id="45" name="Personas" descr="image.png"/>
-          <p:cNvPicPr>
-            <a:picLocks noChangeAspect="1"/>
-          </p:cNvPicPr>
-          <p:nvPr/>
-        </p:nvPicPr>
-        <p:blipFill>
-          <a:blip r:embed="rId6"/>
-          <a:stretch>
-            <a:fillRect/>
-          </a:stretch>
-        </p:blipFill>
-        <p:spPr>
-          <a:xfrm>
-            <a:off x="746150" y="5180990"/>
-            <a:ext cx="427939" cy="427939"/>
-          </a:xfrm>
-          <a:prstGeom prst="rect">
-            <a:avLst/>
-          </a:prstGeom>
-        </p:spPr>
-      </p:pic>
-      <p:sp>
-        <p:nvSpPr>
-          <p:cNvPr id="46" name="Conclusión"/>
-          <p:cNvSpPr txBox="1"/>
-          <p:nvPr/>
-        </p:nvSpPr>
-        <p:spPr>
-          <a:xfrm>
-            <a:off x="1600200" y="4846320"/>
-            <a:ext cx="10042855" cy="1097280"/>
-          </a:xfrm>
-          <a:prstGeom prst="rect">
-            <a:avLst/>
-          </a:prstGeom>
-          <a:noFill/>
-        </p:spPr>
-        <p:txBody>
-          <a:bodyPr wrap="square" anchor="ctr" lIns="0" rIns="0" tIns="0" bIns="0">
-            <a:spAutoFit/>
-          </a:bodyPr>
-          <a:lstStyle/>
-          <a:p>
-            <a:r>
-              <a:rPr sz="2000" b="1">
-                <a:solidFill>
-                  <a:schemeClr val="tx1"/>
-                </a:solidFill>
-              </a:rPr>
-              <a:t>La idea que nadie más tendría suele salir de las personas.</a:t>
-            </a:r>
-          </a:p>
-          <a:p>
-            <a:pPr>
-              <a:spcBef>
-                <a:spcPts val="400"/>
-              </a:spcBef>
-            </a:pPr>
-            <a:r>
-              <a:rPr sz="1800" b="0">
-                <a:solidFill>
-                  <a:schemeClr val="tx1"/>
-                </a:solidFill>
-              </a:rPr>
-              <a:t>Primero pensamos nosotros; después, la IA amplía lo nuestro.</a:t>
-            </a:r>
           </a:p>
         </p:txBody>
       </p:sp>

</xml_diff>

<commit_message>
Añadir una diapositiva de respuesta tras cada situación del bloque 1
Tras cada «Situación N de 6», una diapositiva con la respuesta, el
porqué y, en las situaciones 5 y 6, el aviso de que son discutibles.
Añadidas en bloque1.pptx y en Curso.pptx sin modificar ninguna
diapositiva existente. El guion lo indica en la actividad.

Co-Authored-By: Claude Opus 5.5 <noreply@anthropic.com>
</commit_message>
<xml_diff>
--- a/diapositivas/bloque1.pptx
+++ b/diapositivas/bloque1.pptx
@@ -16,11 +16,17 @@
     <p:sldId id="261" r:id="rId7"/>
     <p:sldId id="262" r:id="rId8"/>
     <p:sldId id="263" r:id="rId9"/>
+    <p:sldId id="285" r:id="rId36"/>
     <p:sldId id="264" r:id="rId10"/>
+    <p:sldId id="286" r:id="rId37"/>
     <p:sldId id="265" r:id="rId11"/>
+    <p:sldId id="287" r:id="rId38"/>
     <p:sldId id="266" r:id="rId12"/>
+    <p:sldId id="288" r:id="rId39"/>
     <p:sldId id="267" r:id="rId13"/>
+    <p:sldId id="289" r:id="rId40"/>
     <p:sldId id="268" r:id="rId14"/>
+    <p:sldId id="290" r:id="rId41"/>
     <p:sldId id="269" r:id="rId15"/>
     <p:sldId id="270" r:id="rId16"/>
     <p:sldId id="271" r:id="rId17"/>
@@ -153,11 +159,17 @@
             <p14:sldId id="261"/>
             <p14:sldId id="262"/>
             <p14:sldId id="263"/>
+            <p14:sldId id="285"/>
             <p14:sldId id="264"/>
+            <p14:sldId id="286"/>
             <p14:sldId id="265"/>
+            <p14:sldId id="287"/>
             <p14:sldId id="266"/>
+            <p14:sldId id="288"/>
             <p14:sldId id="267"/>
+            <p14:sldId id="289"/>
             <p14:sldId id="268"/>
+            <p14:sldId id="290"/>
             <p14:sldId id="269"/>
           </p14:sldIdLst>
         </p14:section>
@@ -2333,6 +2345,318 @@
         <p14:creationId xmlns:p14="http://schemas.microsoft.com/office/powerpoint/2010/main" val="1024086991"/>
       </p:ext>
     </p:extLst>
+  </p:cSld>
+  <p:clrMapOvr>
+    <a:masterClrMapping/>
+  </p:clrMapOvr>
+</p:notes>
+</file>
+
+<file path=ppt/notesSlides/notesSlide30.xml><?xml version="1.0" encoding="utf-8"?>
+<p:notes xmlns:a="http://schemas.openxmlformats.org/drawingml/2006/main" xmlns:p="http://schemas.openxmlformats.org/presentationml/2006/main" xmlns:r="http://schemas.openxmlformats.org/officeDocument/2006/relationships">
+  <p:cSld>
+    <p:spTree>
+      <p:nvGrpSpPr>
+        <p:cNvPr id="1" name=""/>
+        <p:cNvGrpSpPr/>
+        <p:nvPr/>
+      </p:nvGrpSpPr>
+      <p:grpSpPr>
+        <a:xfrm>
+          <a:off x="0" y="0"/>
+          <a:ext cx="0" cy="0"/>
+          <a:chOff x="0" y="0"/>
+          <a:chExt cx="0" cy="0"/>
+        </a:xfrm>
+      </p:grpSpPr>
+      <p:sp>
+        <p:nvSpPr>
+          <p:cNvPr id="3" name="Notes Placeholder 2"/>
+          <p:cNvSpPr>
+            <a:spLocks noGrp="1"/>
+          </p:cNvSpPr>
+          <p:nvPr>
+            <p:ph type="body" idx="1"/>
+          </p:nvPr>
+        </p:nvSpPr>
+        <p:spPr/>
+        <p:txBody>
+          <a:bodyPr/>
+          <a:lstStyle/>
+          <a:p>
+            <a:r>
+              <a:t>Respuesta a la situación 1: creatividad. Es una idea nueva y útil, pero todavía no se ha puesto en práctica.</a:t>
+            </a:r>
+          </a:p>
+          <a:p/>
+          <a:p>
+            <a:r>
+              <a:t>Criterio para resolver las dudas: ¿es solo una idea o ya se ha puesto en práctica? ¿Aporta valor?</a:t>
+            </a:r>
+          </a:p>
+        </p:txBody>
+      </p:sp>
+    </p:spTree>
+  </p:cSld>
+  <p:clrMapOvr>
+    <a:masterClrMapping/>
+  </p:clrMapOvr>
+</p:notes>
+</file>
+
+<file path=ppt/notesSlides/notesSlide31.xml><?xml version="1.0" encoding="utf-8"?>
+<p:notes xmlns:a="http://schemas.openxmlformats.org/drawingml/2006/main" xmlns:p="http://schemas.openxmlformats.org/presentationml/2006/main" xmlns:r="http://schemas.openxmlformats.org/officeDocument/2006/relationships">
+  <p:cSld>
+    <p:spTree>
+      <p:nvGrpSpPr>
+        <p:cNvPr id="1" name=""/>
+        <p:cNvGrpSpPr/>
+        <p:nvPr/>
+      </p:nvGrpSpPr>
+      <p:grpSpPr>
+        <a:xfrm>
+          <a:off x="0" y="0"/>
+          <a:ext cx="0" cy="0"/>
+          <a:chOff x="0" y="0"/>
+          <a:chExt cx="0" cy="0"/>
+        </a:xfrm>
+      </p:grpSpPr>
+      <p:sp>
+        <p:nvSpPr>
+          <p:cNvPr id="3" name="Notes Placeholder 2"/>
+          <p:cNvSpPr>
+            <a:spLocks noGrp="1"/>
+          </p:cNvSpPr>
+          <p:nvPr>
+            <p:ph type="body" idx="1"/>
+          </p:nvPr>
+        </p:nvSpPr>
+        <p:spPr/>
+        <p:txBody>
+          <a:bodyPr/>
+          <a:lstStyle/>
+          <a:p>
+            <a:r>
+              <a:t>Respuesta a la situación 2: innovación. La idea se ha puesto en práctica y aporta valor: las esperas se reducen.</a:t>
+            </a:r>
+          </a:p>
+          <a:p/>
+          <a:p>
+            <a:r>
+              <a:t>Criterio para resolver las dudas: ¿es solo una idea o ya se ha puesto en práctica? ¿Aporta valor?</a:t>
+            </a:r>
+          </a:p>
+        </p:txBody>
+      </p:sp>
+    </p:spTree>
+  </p:cSld>
+  <p:clrMapOvr>
+    <a:masterClrMapping/>
+  </p:clrMapOvr>
+</p:notes>
+</file>
+
+<file path=ppt/notesSlides/notesSlide32.xml><?xml version="1.0" encoding="utf-8"?>
+<p:notes xmlns:a="http://schemas.openxmlformats.org/drawingml/2006/main" xmlns:p="http://schemas.openxmlformats.org/presentationml/2006/main" xmlns:r="http://schemas.openxmlformats.org/officeDocument/2006/relationships">
+  <p:cSld>
+    <p:spTree>
+      <p:nvGrpSpPr>
+        <p:cNvPr id="1" name=""/>
+        <p:cNvGrpSpPr/>
+        <p:nvPr/>
+      </p:nvGrpSpPr>
+      <p:grpSpPr>
+        <a:xfrm>
+          <a:off x="0" y="0"/>
+          <a:ext cx="0" cy="0"/>
+          <a:chOff x="0" y="0"/>
+          <a:chExt cx="0" cy="0"/>
+        </a:xfrm>
+      </p:grpSpPr>
+      <p:sp>
+        <p:nvSpPr>
+          <p:cNvPr id="3" name="Notes Placeholder 2"/>
+          <p:cNvSpPr>
+            <a:spLocks noGrp="1"/>
+          </p:cNvSpPr>
+          <p:nvPr>
+            <p:ph type="body" idx="1"/>
+          </p:nvPr>
+        </p:nvSpPr>
+        <p:spPr/>
+        <p:txBody>
+          <a:bodyPr/>
+          <a:lstStyle/>
+          <a:p>
+            <a:r>
+              <a:t>Respuesta a la situación 3: competencia digital. Usa una herramienta digital para hacer bien su tarea, pero no cambia cómo se trabaja.</a:t>
+            </a:r>
+          </a:p>
+          <a:p/>
+          <a:p>
+            <a:r>
+              <a:t>Criterio para resolver las dudas: ¿es solo una idea o ya se ha puesto en práctica? ¿Aporta valor?</a:t>
+            </a:r>
+          </a:p>
+        </p:txBody>
+      </p:sp>
+    </p:spTree>
+  </p:cSld>
+  <p:clrMapOvr>
+    <a:masterClrMapping/>
+  </p:clrMapOvr>
+</p:notes>
+</file>
+
+<file path=ppt/notesSlides/notesSlide33.xml><?xml version="1.0" encoding="utf-8"?>
+<p:notes xmlns:a="http://schemas.openxmlformats.org/drawingml/2006/main" xmlns:p="http://schemas.openxmlformats.org/presentationml/2006/main" xmlns:r="http://schemas.openxmlformats.org/officeDocument/2006/relationships">
+  <p:cSld>
+    <p:spTree>
+      <p:nvGrpSpPr>
+        <p:cNvPr id="1" name=""/>
+        <p:cNvGrpSpPr/>
+        <p:nvPr/>
+      </p:nvGrpSpPr>
+      <p:grpSpPr>
+        <a:xfrm>
+          <a:off x="0" y="0"/>
+          <a:ext cx="0" cy="0"/>
+          <a:chOff x="0" y="0"/>
+          <a:chExt cx="0" cy="0"/>
+        </a:xfrm>
+      </p:grpSpPr>
+      <p:sp>
+        <p:nvSpPr>
+          <p:cNvPr id="3" name="Notes Placeholder 2"/>
+          <p:cNvSpPr>
+            <a:spLocks noGrp="1"/>
+          </p:cNvSpPr>
+          <p:nvPr>
+            <p:ph type="body" idx="1"/>
+          </p:nvPr>
+        </p:nvSpPr>
+        <p:spPr/>
+        <p:txBody>
+          <a:bodyPr/>
+          <a:lstStyle/>
+          <a:p>
+            <a:r>
+              <a:t>Respuesta a la situación 4: innovación. Es un cambio ya puesto en práctica que aporta valor: el cliente está informado y el taller recibe menos llamadas.</a:t>
+            </a:r>
+          </a:p>
+          <a:p/>
+          <a:p>
+            <a:r>
+              <a:t>Criterio para resolver las dudas: ¿es solo una idea o ya se ha puesto en práctica? ¿Aporta valor?</a:t>
+            </a:r>
+          </a:p>
+        </p:txBody>
+      </p:sp>
+    </p:spTree>
+  </p:cSld>
+  <p:clrMapOvr>
+    <a:masterClrMapping/>
+  </p:clrMapOvr>
+</p:notes>
+</file>
+
+<file path=ppt/notesSlides/notesSlide34.xml><?xml version="1.0" encoding="utf-8"?>
+<p:notes xmlns:a="http://schemas.openxmlformats.org/drawingml/2006/main" xmlns:p="http://schemas.openxmlformats.org/presentationml/2006/main" xmlns:r="http://schemas.openxmlformats.org/officeDocument/2006/relationships">
+  <p:cSld>
+    <p:spTree>
+      <p:nvGrpSpPr>
+        <p:cNvPr id="1" name=""/>
+        <p:cNvGrpSpPr/>
+        <p:nvPr/>
+      </p:nvGrpSpPr>
+      <p:grpSpPr>
+        <a:xfrm>
+          <a:off x="0" y="0"/>
+          <a:ext cx="0" cy="0"/>
+          <a:chOff x="0" y="0"/>
+          <a:chExt cx="0" cy="0"/>
+        </a:xfrm>
+      </p:grpSpPr>
+      <p:sp>
+        <p:nvSpPr>
+          <p:cNvPr id="3" name="Notes Placeholder 2"/>
+          <p:cNvSpPr>
+            <a:spLocks noGrp="1"/>
+          </p:cNvSpPr>
+          <p:nvPr>
+            <p:ph type="body" idx="1"/>
+          </p:nvPr>
+        </p:nvSpPr>
+        <p:spPr/>
+        <p:txBody>
+          <a:bodyPr/>
+          <a:lstStyle/>
+          <a:p>
+            <a:r>
+              <a:t>Respuesta a la situación 5: creatividad. Por ahora es solo una idea. Si se pone en práctica y funciona, pasa a ser innovación. Es discutible a propósito: si hay votos repartidos, que cada opción explique su razonamiento.</a:t>
+            </a:r>
+          </a:p>
+          <a:p/>
+          <a:p>
+            <a:r>
+              <a:t>Criterio para resolver las dudas: ¿es solo una idea o ya se ha puesto en práctica? ¿Aporta valor?</a:t>
+            </a:r>
+          </a:p>
+        </p:txBody>
+      </p:sp>
+    </p:spTree>
+  </p:cSld>
+  <p:clrMapOvr>
+    <a:masterClrMapping/>
+  </p:clrMapOvr>
+</p:notes>
+</file>
+
+<file path=ppt/notesSlides/notesSlide35.xml><?xml version="1.0" encoding="utf-8"?>
+<p:notes xmlns:a="http://schemas.openxmlformats.org/drawingml/2006/main" xmlns:p="http://schemas.openxmlformats.org/presentationml/2006/main" xmlns:r="http://schemas.openxmlformats.org/officeDocument/2006/relationships">
+  <p:cSld>
+    <p:spTree>
+      <p:nvGrpSpPr>
+        <p:cNvPr id="1" name=""/>
+        <p:cNvGrpSpPr/>
+        <p:nvPr/>
+      </p:nvGrpSpPr>
+      <p:grpSpPr>
+        <a:xfrm>
+          <a:off x="0" y="0"/>
+          <a:ext cx="0" cy="0"/>
+          <a:chOff x="0" y="0"/>
+          <a:chExt cx="0" cy="0"/>
+        </a:xfrm>
+      </p:grpSpPr>
+      <p:sp>
+        <p:nvSpPr>
+          <p:cNvPr id="3" name="Notes Placeholder 2"/>
+          <p:cNvSpPr>
+            <a:spLocks noGrp="1"/>
+          </p:cNvSpPr>
+          <p:nvPr>
+            <p:ph type="body" idx="1"/>
+          </p:nvPr>
+        </p:nvSpPr>
+        <p:spPr/>
+        <p:txBody>
+          <a:bodyPr/>
+          <a:lstStyle/>
+          <a:p>
+            <a:r>
+              <a:t>Respuesta a la situación 6: competencia digital. Usa la IA para una tarea concreta, sin cambiar cómo se atiende. Sería innovación si cambiara la forma de atender a los clientes extranjeros. Es discutible a propósito: si hay votos repartidos, que cada opción explique su razonamiento.</a:t>
+            </a:r>
+          </a:p>
+          <a:p/>
+          <a:p>
+            <a:r>
+              <a:t>Criterio para resolver las dudas: ¿es solo una idea o ya se ha puesto en práctica? ¿Aporta valor?</a:t>
+            </a:r>
+          </a:p>
+        </p:txBody>
+      </p:sp>
+    </p:spTree>
   </p:cSld>
   <p:clrMapOvr>
     <a:masterClrMapping/>
@@ -17898,6 +18222,2742 @@
               <a:t>3</a:t>
             </a:fld>
             <a:endParaRPr lang="en-US"/>
+          </a:p>
+        </p:txBody>
+      </p:sp>
+    </p:spTree>
+  </p:cSld>
+  <p:clrMapOvr>
+    <a:masterClrMapping/>
+  </p:clrMapOvr>
+</p:sld>
+</file>
+
+<file path=ppt/slides/slide30.xml><?xml version="1.0" encoding="utf-8"?>
+<p:sld xmlns:a="http://schemas.openxmlformats.org/drawingml/2006/main" xmlns:p="http://schemas.openxmlformats.org/presentationml/2006/main" xmlns:r="http://schemas.openxmlformats.org/officeDocument/2006/relationships">
+  <p:cSld>
+    <p:spTree>
+      <p:nvGrpSpPr>
+        <p:cNvPr id="1" name=""/>
+        <p:cNvGrpSpPr/>
+        <p:nvPr/>
+      </p:nvGrpSpPr>
+      <p:grpSpPr/>
+      <p:sp>
+        <p:nvSpPr>
+          <p:cNvPr id="2" name="Text 0"/>
+          <p:cNvSpPr>
+            <a:spLocks noGrp="1"/>
+          </p:cNvSpPr>
+          <p:nvPr>
+            <p:ph type="title" idx="100" hasCustomPrompt="1"/>
+          </p:nvPr>
+        </p:nvSpPr>
+        <p:spPr>
+          <a:xfrm>
+            <a:off x="548640" y="411480"/>
+            <a:ext cx="11094415" cy="777240"/>
+          </a:xfrm>
+          <a:prstGeom prst="rect">
+            <a:avLst/>
+          </a:prstGeom>
+          <a:noFill/>
+          <a:ln/>
+        </p:spPr>
+        <p:txBody>
+          <a:bodyPr wrap="square" lIns="0" tIns="0" rIns="0" bIns="0" rtlCol="0" anchor="ctr"/>
+          <a:lstStyle/>
+          <a:p>
+            <a:pPr marL="0" indent="0" algn="l">
+              <a:buNone/>
+            </a:pPr>
+            <a:r>
+              <a:rPr lang="en-US" sz="3200" b="1" dirty="0">
+                <a:solidFill>
+                  <a:schemeClr val="tx1"/>
+                </a:solidFill>
+              </a:rPr>
+              <a:t>Situación 1: respuesta</a:t>
+            </a:r>
+            <a:endParaRPr lang="en-US" sz="3200" dirty="0"/>
+          </a:p>
+        </p:txBody>
+      </p:sp>
+      <p:sp>
+        <p:nvSpPr>
+          <p:cNvPr id="3" name="Etiqueta de tiempo"/>
+          <p:cNvSpPr/>
+          <p:nvPr/>
+        </p:nvSpPr>
+        <p:spPr>
+          <a:xfrm>
+            <a:off x="8556955" y="548640"/>
+            <a:ext cx="3086100" cy="457200"/>
+          </a:xfrm>
+          <a:prstGeom prst="roundRect">
+            <a:avLst>
+              <a:gd name="adj" fmla="val 50000"/>
+            </a:avLst>
+          </a:prstGeom>
+          <a:solidFill>
+            <a:schemeClr val="accent1"/>
+          </a:solidFill>
+          <a:ln/>
+        </p:spPr>
+      </p:sp>
+      <p:sp>
+        <p:nvSpPr>
+          <p:cNvPr id="4" name="Text 2"/>
+          <p:cNvSpPr txBox="1"/>
+          <p:nvPr/>
+        </p:nvSpPr>
+        <p:spPr>
+          <a:xfrm>
+            <a:off x="8556955" y="548640"/>
+            <a:ext cx="3086100" cy="457200"/>
+          </a:xfrm>
+          <a:prstGeom prst="rect">
+            <a:avLst/>
+          </a:prstGeom>
+          <a:noFill/>
+          <a:ln/>
+        </p:spPr>
+        <p:txBody>
+          <a:bodyPr wrap="square" lIns="0" tIns="0" rIns="0" bIns="0" rtlCol="0" anchor="ctr"/>
+          <a:lstStyle/>
+          <a:p>
+            <a:pPr marL="0" indent="0" algn="ctr">
+              <a:buNone/>
+            </a:pPr>
+            <a:r>
+              <a:rPr lang="en-US" sz="1400" b="1" dirty="0">
+                <a:solidFill>
+                  <a:schemeClr val="tx1"/>
+                </a:solidFill>
+              </a:rPr>
+              <a:t>Min. 5–10 · Todo el grupo</a:t>
+            </a:r>
+            <a:endParaRPr lang="en-US" sz="1400" dirty="0"/>
+          </a:p>
+        </p:txBody>
+      </p:sp>
+      <p:sp>
+        <p:nvSpPr>
+          <p:cNvPr id="25" name="Slide Number Placeholder 0"/>
+          <p:cNvSpPr>
+            <a:spLocks noGrp="1"/>
+          </p:cNvSpPr>
+          <p:nvPr>
+            <p:ph type="sldNum" sz="quarter" idx="4294967295"/>
+          </p:nvPr>
+        </p:nvSpPr>
+        <p:spPr>
+          <a:xfrm>
+            <a:off x="11091672" y="6355080"/>
+            <a:ext cx="548640" cy="320040"/>
+          </a:xfrm>
+          <a:prstGeom prst="rect">
+            <a:avLst/>
+          </a:prstGeom>
+          <a:extLst>
+            <a:ext uri="{C572A759-6A51-4108-AA02-DFA0A04FC94B}">
+              <ma14:wrappingTextBoxFlag xmlns:ma14="http://schemas.microsoft.com/office/mac/drawingml/2011/main" xmlns="" val="0"/>
+            </a:ext>
+          </a:extLst>
+        </p:spPr>
+        <p:txBody>
+          <a:bodyPr/>
+          <a:lstStyle>
+            <a:lvl1pPr>
+              <a:defRPr sz="1100">
+                <a:solidFill>
+                  <a:srgbClr val="8A94A6"/>
+                </a:solidFill>
+              </a:defRPr>
+            </a:lvl1pPr>
+          </a:lstStyle>
+          <a:p>
+            <a:pPr algn="r"/>
+            <a:fld id="{F7021451-1387-4CA6-816F-3879F97B5CBC}" type="slidenum">
+              <a:rPr lang="en-US" b="0"/>
+              <a:t>8</a:t>
+            </a:fld>
+            <a:endParaRPr lang="en-US"/>
+          </a:p>
+        </p:txBody>
+      </p:sp>
+      <p:sp>
+        <p:nvSpPr>
+          <p:cNvPr id="26" name="Situación"/>
+          <p:cNvSpPr txBox="1"/>
+          <p:nvPr/>
+        </p:nvSpPr>
+        <p:spPr>
+          <a:xfrm>
+            <a:off x="548640" y="1325880"/>
+            <a:ext cx="11094415" cy="685800"/>
+          </a:xfrm>
+          <a:prstGeom prst="rect">
+            <a:avLst/>
+          </a:prstGeom>
+          <a:noFill/>
+        </p:spPr>
+        <p:txBody>
+          <a:bodyPr wrap="square" anchor="ctr" lIns="0" rIns="0" tIns="0" bIns="0">
+            <a:spAutoFit/>
+          </a:bodyPr>
+          <a:lstStyle/>
+          <a:p>
+            <a:r>
+              <a:rPr sz="1800" b="0" i="1">
+                <a:solidFill>
+                  <a:schemeClr val="tx2"/>
+                </a:solidFill>
+              </a:rPr>
+              <a:t>«Una dependienta propone en una reunión que los clientes puedan reservar por WhatsApp.»</a:t>
+            </a:r>
+          </a:p>
+        </p:txBody>
+      </p:sp>
+      <p:sp>
+        <p:nvSpPr>
+          <p:cNvPr id="27" name="Respuesta"/>
+          <p:cNvSpPr/>
+          <p:nvPr/>
+        </p:nvSpPr>
+        <p:spPr>
+          <a:xfrm>
+            <a:off x="548640" y="2194560"/>
+            <a:ext cx="11094415" cy="1463040"/>
+          </a:xfrm>
+          <a:prstGeom prst="roundRect">
+            <a:avLst>
+              <a:gd name="adj" fmla="val 9374"/>
+            </a:avLst>
+          </a:prstGeom>
+          <a:solidFill>
+            <a:schemeClr val="accent1"/>
+          </a:solidFill>
+          <a:ln>
+            <a:noFill/>
+          </a:ln>
+          <a:effectLst/>
+        </p:spPr>
+        <p:style>
+          <a:lnRef idx="1">
+            <a:schemeClr val="accent1"/>
+          </a:lnRef>
+          <a:fillRef idx="3">
+            <a:schemeClr val="accent1"/>
+          </a:fillRef>
+          <a:effectRef idx="2">
+            <a:schemeClr val="accent1"/>
+          </a:effectRef>
+          <a:fontRef idx="minor">
+            <a:schemeClr val="lt1"/>
+          </a:fontRef>
+        </p:style>
+        <p:txBody>
+          <a:bodyPr rtlCol="0" anchor="ctr"/>
+          <a:lstStyle/>
+          <a:p>
+            <a:pPr algn="ctr"/>
+          </a:p>
+        </p:txBody>
+      </p:sp>
+      <p:sp>
+        <p:nvSpPr>
+          <p:cNvPr id="28" name="Número"/>
+          <p:cNvSpPr/>
+          <p:nvPr/>
+        </p:nvSpPr>
+        <p:spPr>
+          <a:xfrm>
+            <a:off x="868680" y="2377440"/>
+            <a:ext cx="1097280" cy="1097280"/>
+          </a:xfrm>
+          <a:prstGeom prst="ellipse">
+            <a:avLst/>
+          </a:prstGeom>
+          <a:solidFill>
+            <a:schemeClr val="bg1"/>
+          </a:solidFill>
+          <a:ln>
+            <a:noFill/>
+          </a:ln>
+          <a:effectLst/>
+        </p:spPr>
+        <p:style>
+          <a:lnRef idx="1">
+            <a:schemeClr val="accent1"/>
+          </a:lnRef>
+          <a:fillRef idx="3">
+            <a:schemeClr val="accent1"/>
+          </a:fillRef>
+          <a:effectRef idx="2">
+            <a:schemeClr val="accent1"/>
+          </a:effectRef>
+          <a:fontRef idx="minor">
+            <a:schemeClr val="lt1"/>
+          </a:fontRef>
+        </p:style>
+        <p:txBody>
+          <a:bodyPr rtlCol="0" anchor="ctr"/>
+          <a:lstStyle/>
+          <a:p>
+            <a:pPr algn="ctr"/>
+          </a:p>
+        </p:txBody>
+      </p:sp>
+      <p:sp>
+        <p:nvSpPr>
+          <p:cNvPr id="29" name="Número de la opción"/>
+          <p:cNvSpPr txBox="1"/>
+          <p:nvPr/>
+        </p:nvSpPr>
+        <p:spPr>
+          <a:xfrm>
+            <a:off x="868680" y="2377440"/>
+            <a:ext cx="1097280" cy="1097280"/>
+          </a:xfrm>
+          <a:prstGeom prst="rect">
+            <a:avLst/>
+          </a:prstGeom>
+          <a:noFill/>
+        </p:spPr>
+        <p:txBody>
+          <a:bodyPr wrap="square" anchor="ctr" lIns="0" rIns="0" tIns="0" bIns="0">
+            <a:spAutoFit/>
+          </a:bodyPr>
+          <a:lstStyle/>
+          <a:p>
+            <a:pPr algn="ctr"/>
+            <a:r>
+              <a:rPr sz="4800" b="1" i="0">
+                <a:solidFill>
+                  <a:schemeClr val="accent1"/>
+                </a:solidFill>
+              </a:rPr>
+              <a:t>1</a:t>
+            </a:r>
+          </a:p>
+        </p:txBody>
+      </p:sp>
+      <p:sp>
+        <p:nvSpPr>
+          <p:cNvPr id="30" name="Nombre de la respuesta"/>
+          <p:cNvSpPr txBox="1"/>
+          <p:nvPr/>
+        </p:nvSpPr>
+        <p:spPr>
+          <a:xfrm>
+            <a:off x="2286000" y="2194560"/>
+            <a:ext cx="9082735" cy="1463040"/>
+          </a:xfrm>
+          <a:prstGeom prst="rect">
+            <a:avLst/>
+          </a:prstGeom>
+          <a:noFill/>
+        </p:spPr>
+        <p:txBody>
+          <a:bodyPr wrap="square" anchor="ctr" lIns="0" rIns="0" tIns="0" bIns="0">
+            <a:spAutoFit/>
+          </a:bodyPr>
+          <a:lstStyle/>
+          <a:p>
+            <a:r>
+              <a:rPr sz="4000" b="1" i="0">
+                <a:solidFill>
+                  <a:schemeClr val="tx1"/>
+                </a:solidFill>
+              </a:rPr>
+              <a:t>Creatividad</a:t>
+            </a:r>
+          </a:p>
+        </p:txBody>
+      </p:sp>
+      <p:sp>
+        <p:nvSpPr>
+          <p:cNvPr id="31" name="Por qué"/>
+          <p:cNvSpPr/>
+          <p:nvPr/>
+        </p:nvSpPr>
+        <p:spPr>
+          <a:xfrm>
+            <a:off x="548640" y="3931920"/>
+            <a:ext cx="11094415" cy="1600200"/>
+          </a:xfrm>
+          <a:prstGeom prst="roundRect">
+            <a:avLst>
+              <a:gd name="adj" fmla="val 8571"/>
+            </a:avLst>
+          </a:prstGeom>
+          <a:solidFill>
+            <a:schemeClr val="bg2"/>
+          </a:solidFill>
+          <a:ln>
+            <a:noFill/>
+          </a:ln>
+          <a:effectLst/>
+        </p:spPr>
+        <p:style>
+          <a:lnRef idx="1">
+            <a:schemeClr val="accent1"/>
+          </a:lnRef>
+          <a:fillRef idx="3">
+            <a:schemeClr val="accent1"/>
+          </a:fillRef>
+          <a:effectRef idx="2">
+            <a:schemeClr val="accent1"/>
+          </a:effectRef>
+          <a:fontRef idx="minor">
+            <a:schemeClr val="lt1"/>
+          </a:fontRef>
+        </p:style>
+        <p:txBody>
+          <a:bodyPr rtlCol="0" anchor="ctr"/>
+          <a:lstStyle/>
+          <a:p>
+            <a:pPr algn="ctr"/>
+          </a:p>
+        </p:txBody>
+      </p:sp>
+      <p:sp>
+        <p:nvSpPr>
+          <p:cNvPr id="32" name="Explicación"/>
+          <p:cNvSpPr txBox="1"/>
+          <p:nvPr/>
+        </p:nvSpPr>
+        <p:spPr>
+          <a:xfrm>
+            <a:off x="914400" y="3931920"/>
+            <a:ext cx="10362895" cy="1600200"/>
+          </a:xfrm>
+          <a:prstGeom prst="rect">
+            <a:avLst/>
+          </a:prstGeom>
+          <a:noFill/>
+        </p:spPr>
+        <p:txBody>
+          <a:bodyPr wrap="square" anchor="ctr" lIns="0" rIns="0" tIns="0" bIns="0">
+            <a:spAutoFit/>
+          </a:bodyPr>
+          <a:lstStyle/>
+          <a:p>
+            <a:r>
+              <a:rPr sz="1600" b="1" i="0">
+                <a:solidFill>
+                  <a:schemeClr val="tx2"/>
+                </a:solidFill>
+              </a:rPr>
+              <a:t>Por qué</a:t>
+            </a:r>
+          </a:p>
+          <a:p>
+            <a:pPr>
+              <a:spcBef>
+                <a:spcPts val="600"/>
+              </a:spcBef>
+            </a:pPr>
+            <a:r>
+              <a:rPr sz="2200" b="0" i="0">
+                <a:solidFill>
+                  <a:schemeClr val="tx1"/>
+                </a:solidFill>
+              </a:rPr>
+              <a:t>Es una idea nueva y útil, pero todavía no se ha puesto en práctica.</a:t>
+            </a:r>
+          </a:p>
+        </p:txBody>
+      </p:sp>
+    </p:spTree>
+  </p:cSld>
+  <p:clrMapOvr>
+    <a:masterClrMapping/>
+  </p:clrMapOvr>
+</p:sld>
+</file>
+
+<file path=ppt/slides/slide31.xml><?xml version="1.0" encoding="utf-8"?>
+<p:sld xmlns:a="http://schemas.openxmlformats.org/drawingml/2006/main" xmlns:p="http://schemas.openxmlformats.org/presentationml/2006/main" xmlns:r="http://schemas.openxmlformats.org/officeDocument/2006/relationships">
+  <p:cSld>
+    <p:spTree>
+      <p:nvGrpSpPr>
+        <p:cNvPr id="1" name=""/>
+        <p:cNvGrpSpPr/>
+        <p:nvPr/>
+      </p:nvGrpSpPr>
+      <p:grpSpPr/>
+      <p:sp>
+        <p:nvSpPr>
+          <p:cNvPr id="2" name="Text 0"/>
+          <p:cNvSpPr>
+            <a:spLocks noGrp="1"/>
+          </p:cNvSpPr>
+          <p:nvPr>
+            <p:ph type="title" idx="100" hasCustomPrompt="1"/>
+          </p:nvPr>
+        </p:nvSpPr>
+        <p:spPr>
+          <a:xfrm>
+            <a:off x="548640" y="411480"/>
+            <a:ext cx="11094415" cy="777240"/>
+          </a:xfrm>
+          <a:prstGeom prst="rect">
+            <a:avLst/>
+          </a:prstGeom>
+          <a:noFill/>
+          <a:ln/>
+        </p:spPr>
+        <p:txBody>
+          <a:bodyPr wrap="square" lIns="0" tIns="0" rIns="0" bIns="0" rtlCol="0" anchor="ctr"/>
+          <a:lstStyle/>
+          <a:p>
+            <a:pPr marL="0" indent="0" algn="l">
+              <a:buNone/>
+            </a:pPr>
+            <a:r>
+              <a:rPr lang="en-US" sz="3200" b="1" dirty="0">
+                <a:solidFill>
+                  <a:schemeClr val="tx1"/>
+                </a:solidFill>
+              </a:rPr>
+              <a:t>Situación 2: respuesta</a:t>
+            </a:r>
+            <a:endParaRPr lang="en-US" sz="3200" dirty="0"/>
+          </a:p>
+        </p:txBody>
+      </p:sp>
+      <p:sp>
+        <p:nvSpPr>
+          <p:cNvPr id="3" name="Etiqueta de tiempo"/>
+          <p:cNvSpPr/>
+          <p:nvPr/>
+        </p:nvSpPr>
+        <p:spPr>
+          <a:xfrm>
+            <a:off x="8556955" y="548640"/>
+            <a:ext cx="3086100" cy="457200"/>
+          </a:xfrm>
+          <a:prstGeom prst="roundRect">
+            <a:avLst>
+              <a:gd name="adj" fmla="val 50000"/>
+            </a:avLst>
+          </a:prstGeom>
+          <a:solidFill>
+            <a:schemeClr val="accent1"/>
+          </a:solidFill>
+          <a:ln/>
+        </p:spPr>
+      </p:sp>
+      <p:sp>
+        <p:nvSpPr>
+          <p:cNvPr id="4" name="Text 2"/>
+          <p:cNvSpPr txBox="1"/>
+          <p:nvPr/>
+        </p:nvSpPr>
+        <p:spPr>
+          <a:xfrm>
+            <a:off x="8556955" y="548640"/>
+            <a:ext cx="3086100" cy="457200"/>
+          </a:xfrm>
+          <a:prstGeom prst="rect">
+            <a:avLst/>
+          </a:prstGeom>
+          <a:noFill/>
+          <a:ln/>
+        </p:spPr>
+        <p:txBody>
+          <a:bodyPr wrap="square" lIns="0" tIns="0" rIns="0" bIns="0" rtlCol="0" anchor="ctr"/>
+          <a:lstStyle/>
+          <a:p>
+            <a:pPr marL="0" indent="0" algn="ctr">
+              <a:buNone/>
+            </a:pPr>
+            <a:r>
+              <a:rPr lang="en-US" sz="1400" b="1" dirty="0">
+                <a:solidFill>
+                  <a:schemeClr val="tx1"/>
+                </a:solidFill>
+              </a:rPr>
+              <a:t>Min. 5–10 · Todo el grupo</a:t>
+            </a:r>
+            <a:endParaRPr lang="en-US" sz="1400" dirty="0"/>
+          </a:p>
+        </p:txBody>
+      </p:sp>
+      <p:sp>
+        <p:nvSpPr>
+          <p:cNvPr id="25" name="Slide Number Placeholder 0"/>
+          <p:cNvSpPr>
+            <a:spLocks noGrp="1"/>
+          </p:cNvSpPr>
+          <p:nvPr>
+            <p:ph type="sldNum" sz="quarter" idx="4294967295"/>
+          </p:nvPr>
+        </p:nvSpPr>
+        <p:spPr>
+          <a:xfrm>
+            <a:off x="11091672" y="6355080"/>
+            <a:ext cx="548640" cy="320040"/>
+          </a:xfrm>
+          <a:prstGeom prst="rect">
+            <a:avLst/>
+          </a:prstGeom>
+          <a:extLst>
+            <a:ext uri="{C572A759-6A51-4108-AA02-DFA0A04FC94B}">
+              <ma14:wrappingTextBoxFlag xmlns:ma14="http://schemas.microsoft.com/office/mac/drawingml/2011/main" xmlns="" val="0"/>
+            </a:ext>
+          </a:extLst>
+        </p:spPr>
+        <p:txBody>
+          <a:bodyPr/>
+          <a:lstStyle>
+            <a:lvl1pPr>
+              <a:defRPr sz="1100">
+                <a:solidFill>
+                  <a:srgbClr val="8A94A6"/>
+                </a:solidFill>
+              </a:defRPr>
+            </a:lvl1pPr>
+          </a:lstStyle>
+          <a:p>
+            <a:pPr algn="r"/>
+            <a:fld id="{F7021451-1387-4CA6-816F-3879F97B5CBC}" type="slidenum">
+              <a:rPr lang="en-US" b="0"/>
+              <a:t>9</a:t>
+            </a:fld>
+            <a:endParaRPr lang="en-US"/>
+          </a:p>
+        </p:txBody>
+      </p:sp>
+      <p:sp>
+        <p:nvSpPr>
+          <p:cNvPr id="26" name="Situación"/>
+          <p:cNvSpPr txBox="1"/>
+          <p:nvPr/>
+        </p:nvSpPr>
+        <p:spPr>
+          <a:xfrm>
+            <a:off x="548640" y="1325880"/>
+            <a:ext cx="11094415" cy="685800"/>
+          </a:xfrm>
+          <a:prstGeom prst="rect">
+            <a:avLst/>
+          </a:prstGeom>
+          <a:noFill/>
+        </p:spPr>
+        <p:txBody>
+          <a:bodyPr wrap="square" anchor="ctr" lIns="0" rIns="0" tIns="0" bIns="0">
+            <a:spAutoFit/>
+          </a:bodyPr>
+          <a:lstStyle/>
+          <a:p>
+            <a:r>
+              <a:rPr sz="1800" b="0" i="1">
+                <a:solidFill>
+                  <a:schemeClr val="tx2"/>
+                </a:solidFill>
+              </a:rPr>
+              <a:t>«La tienda pone en marcha las reservas por WhatsApp y las esperas se reducen.»</a:t>
+            </a:r>
+          </a:p>
+        </p:txBody>
+      </p:sp>
+      <p:sp>
+        <p:nvSpPr>
+          <p:cNvPr id="27" name="Respuesta"/>
+          <p:cNvSpPr/>
+          <p:nvPr/>
+        </p:nvSpPr>
+        <p:spPr>
+          <a:xfrm>
+            <a:off x="548640" y="2194560"/>
+            <a:ext cx="11094415" cy="1463040"/>
+          </a:xfrm>
+          <a:prstGeom prst="roundRect">
+            <a:avLst>
+              <a:gd name="adj" fmla="val 9374"/>
+            </a:avLst>
+          </a:prstGeom>
+          <a:solidFill>
+            <a:schemeClr val="accent3"/>
+          </a:solidFill>
+          <a:ln>
+            <a:noFill/>
+          </a:ln>
+          <a:effectLst/>
+        </p:spPr>
+        <p:style>
+          <a:lnRef idx="1">
+            <a:schemeClr val="accent1"/>
+          </a:lnRef>
+          <a:fillRef idx="3">
+            <a:schemeClr val="accent1"/>
+          </a:fillRef>
+          <a:effectRef idx="2">
+            <a:schemeClr val="accent1"/>
+          </a:effectRef>
+          <a:fontRef idx="minor">
+            <a:schemeClr val="lt1"/>
+          </a:fontRef>
+        </p:style>
+        <p:txBody>
+          <a:bodyPr rtlCol="0" anchor="ctr"/>
+          <a:lstStyle/>
+          <a:p>
+            <a:pPr algn="ctr"/>
+          </a:p>
+        </p:txBody>
+      </p:sp>
+      <p:sp>
+        <p:nvSpPr>
+          <p:cNvPr id="28" name="Número"/>
+          <p:cNvSpPr/>
+          <p:nvPr/>
+        </p:nvSpPr>
+        <p:spPr>
+          <a:xfrm>
+            <a:off x="868680" y="2377440"/>
+            <a:ext cx="1097280" cy="1097280"/>
+          </a:xfrm>
+          <a:prstGeom prst="ellipse">
+            <a:avLst/>
+          </a:prstGeom>
+          <a:solidFill>
+            <a:schemeClr val="bg1"/>
+          </a:solidFill>
+          <a:ln>
+            <a:noFill/>
+          </a:ln>
+          <a:effectLst/>
+        </p:spPr>
+        <p:style>
+          <a:lnRef idx="1">
+            <a:schemeClr val="accent1"/>
+          </a:lnRef>
+          <a:fillRef idx="3">
+            <a:schemeClr val="accent1"/>
+          </a:fillRef>
+          <a:effectRef idx="2">
+            <a:schemeClr val="accent1"/>
+          </a:effectRef>
+          <a:fontRef idx="minor">
+            <a:schemeClr val="lt1"/>
+          </a:fontRef>
+        </p:style>
+        <p:txBody>
+          <a:bodyPr rtlCol="0" anchor="ctr"/>
+          <a:lstStyle/>
+          <a:p>
+            <a:pPr algn="ctr"/>
+          </a:p>
+        </p:txBody>
+      </p:sp>
+      <p:sp>
+        <p:nvSpPr>
+          <p:cNvPr id="29" name="Número de la opción"/>
+          <p:cNvSpPr txBox="1"/>
+          <p:nvPr/>
+        </p:nvSpPr>
+        <p:spPr>
+          <a:xfrm>
+            <a:off x="868680" y="2377440"/>
+            <a:ext cx="1097280" cy="1097280"/>
+          </a:xfrm>
+          <a:prstGeom prst="rect">
+            <a:avLst/>
+          </a:prstGeom>
+          <a:noFill/>
+        </p:spPr>
+        <p:txBody>
+          <a:bodyPr wrap="square" anchor="ctr" lIns="0" rIns="0" tIns="0" bIns="0">
+            <a:spAutoFit/>
+          </a:bodyPr>
+          <a:lstStyle/>
+          <a:p>
+            <a:pPr algn="ctr"/>
+            <a:r>
+              <a:rPr sz="4800" b="1" i="0">
+                <a:solidFill>
+                  <a:schemeClr val="accent3"/>
+                </a:solidFill>
+              </a:rPr>
+              <a:t>2</a:t>
+            </a:r>
+          </a:p>
+        </p:txBody>
+      </p:sp>
+      <p:sp>
+        <p:nvSpPr>
+          <p:cNvPr id="30" name="Nombre de la respuesta"/>
+          <p:cNvSpPr txBox="1"/>
+          <p:nvPr/>
+        </p:nvSpPr>
+        <p:spPr>
+          <a:xfrm>
+            <a:off x="2286000" y="2194560"/>
+            <a:ext cx="9082735" cy="1463040"/>
+          </a:xfrm>
+          <a:prstGeom prst="rect">
+            <a:avLst/>
+          </a:prstGeom>
+          <a:noFill/>
+        </p:spPr>
+        <p:txBody>
+          <a:bodyPr wrap="square" anchor="ctr" lIns="0" rIns="0" tIns="0" bIns="0">
+            <a:spAutoFit/>
+          </a:bodyPr>
+          <a:lstStyle/>
+          <a:p>
+            <a:r>
+              <a:rPr sz="4000" b="1" i="0">
+                <a:solidFill>
+                  <a:schemeClr val="bg1"/>
+                </a:solidFill>
+              </a:rPr>
+              <a:t>Innovación</a:t>
+            </a:r>
+          </a:p>
+        </p:txBody>
+      </p:sp>
+      <p:sp>
+        <p:nvSpPr>
+          <p:cNvPr id="31" name="Por qué"/>
+          <p:cNvSpPr/>
+          <p:nvPr/>
+        </p:nvSpPr>
+        <p:spPr>
+          <a:xfrm>
+            <a:off x="548640" y="3931920"/>
+            <a:ext cx="11094415" cy="1600200"/>
+          </a:xfrm>
+          <a:prstGeom prst="roundRect">
+            <a:avLst>
+              <a:gd name="adj" fmla="val 8571"/>
+            </a:avLst>
+          </a:prstGeom>
+          <a:solidFill>
+            <a:schemeClr val="bg2"/>
+          </a:solidFill>
+          <a:ln>
+            <a:noFill/>
+          </a:ln>
+          <a:effectLst/>
+        </p:spPr>
+        <p:style>
+          <a:lnRef idx="1">
+            <a:schemeClr val="accent1"/>
+          </a:lnRef>
+          <a:fillRef idx="3">
+            <a:schemeClr val="accent1"/>
+          </a:fillRef>
+          <a:effectRef idx="2">
+            <a:schemeClr val="accent1"/>
+          </a:effectRef>
+          <a:fontRef idx="minor">
+            <a:schemeClr val="lt1"/>
+          </a:fontRef>
+        </p:style>
+        <p:txBody>
+          <a:bodyPr rtlCol="0" anchor="ctr"/>
+          <a:lstStyle/>
+          <a:p>
+            <a:pPr algn="ctr"/>
+          </a:p>
+        </p:txBody>
+      </p:sp>
+      <p:sp>
+        <p:nvSpPr>
+          <p:cNvPr id="32" name="Explicación"/>
+          <p:cNvSpPr txBox="1"/>
+          <p:nvPr/>
+        </p:nvSpPr>
+        <p:spPr>
+          <a:xfrm>
+            <a:off x="914400" y="3931920"/>
+            <a:ext cx="10362895" cy="1600200"/>
+          </a:xfrm>
+          <a:prstGeom prst="rect">
+            <a:avLst/>
+          </a:prstGeom>
+          <a:noFill/>
+        </p:spPr>
+        <p:txBody>
+          <a:bodyPr wrap="square" anchor="ctr" lIns="0" rIns="0" tIns="0" bIns="0">
+            <a:spAutoFit/>
+          </a:bodyPr>
+          <a:lstStyle/>
+          <a:p>
+            <a:r>
+              <a:rPr sz="1600" b="1" i="0">
+                <a:solidFill>
+                  <a:schemeClr val="tx2"/>
+                </a:solidFill>
+              </a:rPr>
+              <a:t>Por qué</a:t>
+            </a:r>
+          </a:p>
+          <a:p>
+            <a:pPr>
+              <a:spcBef>
+                <a:spcPts val="600"/>
+              </a:spcBef>
+            </a:pPr>
+            <a:r>
+              <a:rPr sz="2200" b="0" i="0">
+                <a:solidFill>
+                  <a:schemeClr val="tx1"/>
+                </a:solidFill>
+              </a:rPr>
+              <a:t>La idea se ha puesto en práctica y aporta valor: las esperas se reducen.</a:t>
+            </a:r>
+          </a:p>
+        </p:txBody>
+      </p:sp>
+    </p:spTree>
+  </p:cSld>
+  <p:clrMapOvr>
+    <a:masterClrMapping/>
+  </p:clrMapOvr>
+</p:sld>
+</file>
+
+<file path=ppt/slides/slide32.xml><?xml version="1.0" encoding="utf-8"?>
+<p:sld xmlns:a="http://schemas.openxmlformats.org/drawingml/2006/main" xmlns:p="http://schemas.openxmlformats.org/presentationml/2006/main" xmlns:r="http://schemas.openxmlformats.org/officeDocument/2006/relationships">
+  <p:cSld>
+    <p:spTree>
+      <p:nvGrpSpPr>
+        <p:cNvPr id="1" name=""/>
+        <p:cNvGrpSpPr/>
+        <p:nvPr/>
+      </p:nvGrpSpPr>
+      <p:grpSpPr/>
+      <p:sp>
+        <p:nvSpPr>
+          <p:cNvPr id="2" name="Text 0"/>
+          <p:cNvSpPr>
+            <a:spLocks noGrp="1"/>
+          </p:cNvSpPr>
+          <p:nvPr>
+            <p:ph type="title" idx="100" hasCustomPrompt="1"/>
+          </p:nvPr>
+        </p:nvSpPr>
+        <p:spPr>
+          <a:xfrm>
+            <a:off x="548640" y="411480"/>
+            <a:ext cx="11094415" cy="777240"/>
+          </a:xfrm>
+          <a:prstGeom prst="rect">
+            <a:avLst/>
+          </a:prstGeom>
+          <a:noFill/>
+          <a:ln/>
+        </p:spPr>
+        <p:txBody>
+          <a:bodyPr wrap="square" lIns="0" tIns="0" rIns="0" bIns="0" rtlCol="0" anchor="ctr"/>
+          <a:lstStyle/>
+          <a:p>
+            <a:pPr marL="0" indent="0" algn="l">
+              <a:buNone/>
+            </a:pPr>
+            <a:r>
+              <a:rPr lang="en-US" sz="3200" b="1" dirty="0">
+                <a:solidFill>
+                  <a:schemeClr val="tx1"/>
+                </a:solidFill>
+              </a:rPr>
+              <a:t>Situación 3: respuesta</a:t>
+            </a:r>
+            <a:endParaRPr lang="en-US" sz="3200" dirty="0"/>
+          </a:p>
+        </p:txBody>
+      </p:sp>
+      <p:sp>
+        <p:nvSpPr>
+          <p:cNvPr id="3" name="Etiqueta de tiempo"/>
+          <p:cNvSpPr/>
+          <p:nvPr/>
+        </p:nvSpPr>
+        <p:spPr>
+          <a:xfrm>
+            <a:off x="8556955" y="548640"/>
+            <a:ext cx="3086100" cy="457200"/>
+          </a:xfrm>
+          <a:prstGeom prst="roundRect">
+            <a:avLst>
+              <a:gd name="adj" fmla="val 50000"/>
+            </a:avLst>
+          </a:prstGeom>
+          <a:solidFill>
+            <a:schemeClr val="accent1"/>
+          </a:solidFill>
+          <a:ln/>
+        </p:spPr>
+      </p:sp>
+      <p:sp>
+        <p:nvSpPr>
+          <p:cNvPr id="4" name="Text 2"/>
+          <p:cNvSpPr txBox="1"/>
+          <p:nvPr/>
+        </p:nvSpPr>
+        <p:spPr>
+          <a:xfrm>
+            <a:off x="8556955" y="548640"/>
+            <a:ext cx="3086100" cy="457200"/>
+          </a:xfrm>
+          <a:prstGeom prst="rect">
+            <a:avLst/>
+          </a:prstGeom>
+          <a:noFill/>
+          <a:ln/>
+        </p:spPr>
+        <p:txBody>
+          <a:bodyPr wrap="square" lIns="0" tIns="0" rIns="0" bIns="0" rtlCol="0" anchor="ctr"/>
+          <a:lstStyle/>
+          <a:p>
+            <a:pPr marL="0" indent="0" algn="ctr">
+              <a:buNone/>
+            </a:pPr>
+            <a:r>
+              <a:rPr lang="en-US" sz="1400" b="1" dirty="0">
+                <a:solidFill>
+                  <a:schemeClr val="tx1"/>
+                </a:solidFill>
+              </a:rPr>
+              <a:t>Min. 5–10 · Todo el grupo</a:t>
+            </a:r>
+            <a:endParaRPr lang="en-US" sz="1400" dirty="0"/>
+          </a:p>
+        </p:txBody>
+      </p:sp>
+      <p:sp>
+        <p:nvSpPr>
+          <p:cNvPr id="25" name="Slide Number Placeholder 0"/>
+          <p:cNvSpPr>
+            <a:spLocks noGrp="1"/>
+          </p:cNvSpPr>
+          <p:nvPr>
+            <p:ph type="sldNum" sz="quarter" idx="4294967295"/>
+          </p:nvPr>
+        </p:nvSpPr>
+        <p:spPr>
+          <a:xfrm>
+            <a:off x="11091672" y="6355080"/>
+            <a:ext cx="548640" cy="320040"/>
+          </a:xfrm>
+          <a:prstGeom prst="rect">
+            <a:avLst/>
+          </a:prstGeom>
+          <a:extLst>
+            <a:ext uri="{C572A759-6A51-4108-AA02-DFA0A04FC94B}">
+              <ma14:wrappingTextBoxFlag xmlns:ma14="http://schemas.microsoft.com/office/mac/drawingml/2011/main" xmlns="" val="0"/>
+            </a:ext>
+          </a:extLst>
+        </p:spPr>
+        <p:txBody>
+          <a:bodyPr/>
+          <a:lstStyle>
+            <a:lvl1pPr>
+              <a:defRPr sz="1100">
+                <a:solidFill>
+                  <a:srgbClr val="8A94A6"/>
+                </a:solidFill>
+              </a:defRPr>
+            </a:lvl1pPr>
+          </a:lstStyle>
+          <a:p>
+            <a:pPr algn="r"/>
+            <a:fld id="{F7021451-1387-4CA6-816F-3879F97B5CBC}" type="slidenum">
+              <a:rPr lang="en-US" b="0"/>
+              <a:t>10</a:t>
+            </a:fld>
+            <a:endParaRPr lang="en-US"/>
+          </a:p>
+        </p:txBody>
+      </p:sp>
+      <p:sp>
+        <p:nvSpPr>
+          <p:cNvPr id="26" name="Situación"/>
+          <p:cNvSpPr txBox="1"/>
+          <p:nvPr/>
+        </p:nvSpPr>
+        <p:spPr>
+          <a:xfrm>
+            <a:off x="548640" y="1325880"/>
+            <a:ext cx="11094415" cy="685800"/>
+          </a:xfrm>
+          <a:prstGeom prst="rect">
+            <a:avLst/>
+          </a:prstGeom>
+          <a:noFill/>
+        </p:spPr>
+        <p:txBody>
+          <a:bodyPr wrap="square" anchor="ctr" lIns="0" rIns="0" tIns="0" bIns="0">
+            <a:spAutoFit/>
+          </a:bodyPr>
+          <a:lstStyle/>
+          <a:p>
+            <a:r>
+              <a:rPr sz="1800" b="0" i="1">
+                <a:solidFill>
+                  <a:schemeClr val="tx2"/>
+                </a:solidFill>
+              </a:rPr>
+              <a:t>«Un administrativo usa una tabla dinámica para resumir las ventas del mes.»</a:t>
+            </a:r>
+          </a:p>
+        </p:txBody>
+      </p:sp>
+      <p:sp>
+        <p:nvSpPr>
+          <p:cNvPr id="27" name="Respuesta"/>
+          <p:cNvSpPr/>
+          <p:nvPr/>
+        </p:nvSpPr>
+        <p:spPr>
+          <a:xfrm>
+            <a:off x="548640" y="2194560"/>
+            <a:ext cx="11094415" cy="1463040"/>
+          </a:xfrm>
+          <a:prstGeom prst="roundRect">
+            <a:avLst>
+              <a:gd name="adj" fmla="val 9374"/>
+            </a:avLst>
+          </a:prstGeom>
+          <a:solidFill>
+            <a:schemeClr val="accent4"/>
+          </a:solidFill>
+          <a:ln>
+            <a:noFill/>
+          </a:ln>
+          <a:effectLst/>
+        </p:spPr>
+        <p:style>
+          <a:lnRef idx="1">
+            <a:schemeClr val="accent1"/>
+          </a:lnRef>
+          <a:fillRef idx="3">
+            <a:schemeClr val="accent1"/>
+          </a:fillRef>
+          <a:effectRef idx="2">
+            <a:schemeClr val="accent1"/>
+          </a:effectRef>
+          <a:fontRef idx="minor">
+            <a:schemeClr val="lt1"/>
+          </a:fontRef>
+        </p:style>
+        <p:txBody>
+          <a:bodyPr rtlCol="0" anchor="ctr"/>
+          <a:lstStyle/>
+          <a:p>
+            <a:pPr algn="ctr"/>
+          </a:p>
+        </p:txBody>
+      </p:sp>
+      <p:sp>
+        <p:nvSpPr>
+          <p:cNvPr id="28" name="Número"/>
+          <p:cNvSpPr/>
+          <p:nvPr/>
+        </p:nvSpPr>
+        <p:spPr>
+          <a:xfrm>
+            <a:off x="868680" y="2377440"/>
+            <a:ext cx="1097280" cy="1097280"/>
+          </a:xfrm>
+          <a:prstGeom prst="ellipse">
+            <a:avLst/>
+          </a:prstGeom>
+          <a:solidFill>
+            <a:schemeClr val="bg1"/>
+          </a:solidFill>
+          <a:ln>
+            <a:noFill/>
+          </a:ln>
+          <a:effectLst/>
+        </p:spPr>
+        <p:style>
+          <a:lnRef idx="1">
+            <a:schemeClr val="accent1"/>
+          </a:lnRef>
+          <a:fillRef idx="3">
+            <a:schemeClr val="accent1"/>
+          </a:fillRef>
+          <a:effectRef idx="2">
+            <a:schemeClr val="accent1"/>
+          </a:effectRef>
+          <a:fontRef idx="minor">
+            <a:schemeClr val="lt1"/>
+          </a:fontRef>
+        </p:style>
+        <p:txBody>
+          <a:bodyPr rtlCol="0" anchor="ctr"/>
+          <a:lstStyle/>
+          <a:p>
+            <a:pPr algn="ctr"/>
+          </a:p>
+        </p:txBody>
+      </p:sp>
+      <p:sp>
+        <p:nvSpPr>
+          <p:cNvPr id="29" name="Número de la opción"/>
+          <p:cNvSpPr txBox="1"/>
+          <p:nvPr/>
+        </p:nvSpPr>
+        <p:spPr>
+          <a:xfrm>
+            <a:off x="868680" y="2377440"/>
+            <a:ext cx="1097280" cy="1097280"/>
+          </a:xfrm>
+          <a:prstGeom prst="rect">
+            <a:avLst/>
+          </a:prstGeom>
+          <a:noFill/>
+        </p:spPr>
+        <p:txBody>
+          <a:bodyPr wrap="square" anchor="ctr" lIns="0" rIns="0" tIns="0" bIns="0">
+            <a:spAutoFit/>
+          </a:bodyPr>
+          <a:lstStyle/>
+          <a:p>
+            <a:pPr algn="ctr"/>
+            <a:r>
+              <a:rPr sz="4800" b="1" i="0">
+                <a:solidFill>
+                  <a:schemeClr val="accent4"/>
+                </a:solidFill>
+              </a:rPr>
+              <a:t>3</a:t>
+            </a:r>
+          </a:p>
+        </p:txBody>
+      </p:sp>
+      <p:sp>
+        <p:nvSpPr>
+          <p:cNvPr id="30" name="Nombre de la respuesta"/>
+          <p:cNvSpPr txBox="1"/>
+          <p:nvPr/>
+        </p:nvSpPr>
+        <p:spPr>
+          <a:xfrm>
+            <a:off x="2286000" y="2194560"/>
+            <a:ext cx="9082735" cy="1463040"/>
+          </a:xfrm>
+          <a:prstGeom prst="rect">
+            <a:avLst/>
+          </a:prstGeom>
+          <a:noFill/>
+        </p:spPr>
+        <p:txBody>
+          <a:bodyPr wrap="square" anchor="ctr" lIns="0" rIns="0" tIns="0" bIns="0">
+            <a:spAutoFit/>
+          </a:bodyPr>
+          <a:lstStyle/>
+          <a:p>
+            <a:r>
+              <a:rPr sz="4000" b="1" i="0">
+                <a:solidFill>
+                  <a:schemeClr val="bg1"/>
+                </a:solidFill>
+              </a:rPr>
+              <a:t>Competencia digital</a:t>
+            </a:r>
+          </a:p>
+        </p:txBody>
+      </p:sp>
+      <p:sp>
+        <p:nvSpPr>
+          <p:cNvPr id="31" name="Por qué"/>
+          <p:cNvSpPr/>
+          <p:nvPr/>
+        </p:nvSpPr>
+        <p:spPr>
+          <a:xfrm>
+            <a:off x="548640" y="3931920"/>
+            <a:ext cx="11094415" cy="1600200"/>
+          </a:xfrm>
+          <a:prstGeom prst="roundRect">
+            <a:avLst>
+              <a:gd name="adj" fmla="val 8571"/>
+            </a:avLst>
+          </a:prstGeom>
+          <a:solidFill>
+            <a:schemeClr val="bg2"/>
+          </a:solidFill>
+          <a:ln>
+            <a:noFill/>
+          </a:ln>
+          <a:effectLst/>
+        </p:spPr>
+        <p:style>
+          <a:lnRef idx="1">
+            <a:schemeClr val="accent1"/>
+          </a:lnRef>
+          <a:fillRef idx="3">
+            <a:schemeClr val="accent1"/>
+          </a:fillRef>
+          <a:effectRef idx="2">
+            <a:schemeClr val="accent1"/>
+          </a:effectRef>
+          <a:fontRef idx="minor">
+            <a:schemeClr val="lt1"/>
+          </a:fontRef>
+        </p:style>
+        <p:txBody>
+          <a:bodyPr rtlCol="0" anchor="ctr"/>
+          <a:lstStyle/>
+          <a:p>
+            <a:pPr algn="ctr"/>
+          </a:p>
+        </p:txBody>
+      </p:sp>
+      <p:sp>
+        <p:nvSpPr>
+          <p:cNvPr id="32" name="Explicación"/>
+          <p:cNvSpPr txBox="1"/>
+          <p:nvPr/>
+        </p:nvSpPr>
+        <p:spPr>
+          <a:xfrm>
+            <a:off x="914400" y="3931920"/>
+            <a:ext cx="10362895" cy="1600200"/>
+          </a:xfrm>
+          <a:prstGeom prst="rect">
+            <a:avLst/>
+          </a:prstGeom>
+          <a:noFill/>
+        </p:spPr>
+        <p:txBody>
+          <a:bodyPr wrap="square" anchor="ctr" lIns="0" rIns="0" tIns="0" bIns="0">
+            <a:spAutoFit/>
+          </a:bodyPr>
+          <a:lstStyle/>
+          <a:p>
+            <a:r>
+              <a:rPr sz="1600" b="1" i="0">
+                <a:solidFill>
+                  <a:schemeClr val="tx2"/>
+                </a:solidFill>
+              </a:rPr>
+              <a:t>Por qué</a:t>
+            </a:r>
+          </a:p>
+          <a:p>
+            <a:pPr>
+              <a:spcBef>
+                <a:spcPts val="600"/>
+              </a:spcBef>
+            </a:pPr>
+            <a:r>
+              <a:rPr sz="2200" b="0" i="0">
+                <a:solidFill>
+                  <a:schemeClr val="tx1"/>
+                </a:solidFill>
+              </a:rPr>
+              <a:t>Usa una herramienta digital para hacer bien su tarea, pero no cambia cómo se trabaja.</a:t>
+            </a:r>
+          </a:p>
+        </p:txBody>
+      </p:sp>
+    </p:spTree>
+  </p:cSld>
+  <p:clrMapOvr>
+    <a:masterClrMapping/>
+  </p:clrMapOvr>
+</p:sld>
+</file>
+
+<file path=ppt/slides/slide33.xml><?xml version="1.0" encoding="utf-8"?>
+<p:sld xmlns:a="http://schemas.openxmlformats.org/drawingml/2006/main" xmlns:p="http://schemas.openxmlformats.org/presentationml/2006/main" xmlns:r="http://schemas.openxmlformats.org/officeDocument/2006/relationships">
+  <p:cSld>
+    <p:spTree>
+      <p:nvGrpSpPr>
+        <p:cNvPr id="1" name=""/>
+        <p:cNvGrpSpPr/>
+        <p:nvPr/>
+      </p:nvGrpSpPr>
+      <p:grpSpPr/>
+      <p:sp>
+        <p:nvSpPr>
+          <p:cNvPr id="2" name="Text 0"/>
+          <p:cNvSpPr>
+            <a:spLocks noGrp="1"/>
+          </p:cNvSpPr>
+          <p:nvPr>
+            <p:ph type="title" idx="100" hasCustomPrompt="1"/>
+          </p:nvPr>
+        </p:nvSpPr>
+        <p:spPr>
+          <a:xfrm>
+            <a:off x="548640" y="411480"/>
+            <a:ext cx="11094415" cy="777240"/>
+          </a:xfrm>
+          <a:prstGeom prst="rect">
+            <a:avLst/>
+          </a:prstGeom>
+          <a:noFill/>
+          <a:ln/>
+        </p:spPr>
+        <p:txBody>
+          <a:bodyPr wrap="square" lIns="0" tIns="0" rIns="0" bIns="0" rtlCol="0" anchor="ctr"/>
+          <a:lstStyle/>
+          <a:p>
+            <a:pPr marL="0" indent="0" algn="l">
+              <a:buNone/>
+            </a:pPr>
+            <a:r>
+              <a:rPr lang="en-US" sz="3200" b="1" dirty="0">
+                <a:solidFill>
+                  <a:schemeClr val="tx1"/>
+                </a:solidFill>
+              </a:rPr>
+              <a:t>Situación 4: respuesta</a:t>
+            </a:r>
+            <a:endParaRPr lang="en-US" sz="3200" dirty="0"/>
+          </a:p>
+        </p:txBody>
+      </p:sp>
+      <p:sp>
+        <p:nvSpPr>
+          <p:cNvPr id="3" name="Etiqueta de tiempo"/>
+          <p:cNvSpPr/>
+          <p:nvPr/>
+        </p:nvSpPr>
+        <p:spPr>
+          <a:xfrm>
+            <a:off x="8556955" y="548640"/>
+            <a:ext cx="3086100" cy="457200"/>
+          </a:xfrm>
+          <a:prstGeom prst="roundRect">
+            <a:avLst>
+              <a:gd name="adj" fmla="val 50000"/>
+            </a:avLst>
+          </a:prstGeom>
+          <a:solidFill>
+            <a:schemeClr val="accent1"/>
+          </a:solidFill>
+          <a:ln/>
+        </p:spPr>
+      </p:sp>
+      <p:sp>
+        <p:nvSpPr>
+          <p:cNvPr id="4" name="Text 2"/>
+          <p:cNvSpPr txBox="1"/>
+          <p:nvPr/>
+        </p:nvSpPr>
+        <p:spPr>
+          <a:xfrm>
+            <a:off x="8556955" y="548640"/>
+            <a:ext cx="3086100" cy="457200"/>
+          </a:xfrm>
+          <a:prstGeom prst="rect">
+            <a:avLst/>
+          </a:prstGeom>
+          <a:noFill/>
+          <a:ln/>
+        </p:spPr>
+        <p:txBody>
+          <a:bodyPr wrap="square" lIns="0" tIns="0" rIns="0" bIns="0" rtlCol="0" anchor="ctr"/>
+          <a:lstStyle/>
+          <a:p>
+            <a:pPr marL="0" indent="0" algn="ctr">
+              <a:buNone/>
+            </a:pPr>
+            <a:r>
+              <a:rPr lang="en-US" sz="1400" b="1" dirty="0">
+                <a:solidFill>
+                  <a:schemeClr val="tx1"/>
+                </a:solidFill>
+              </a:rPr>
+              <a:t>Min. 5–10 · Todo el grupo</a:t>
+            </a:r>
+            <a:endParaRPr lang="en-US" sz="1400" dirty="0"/>
+          </a:p>
+        </p:txBody>
+      </p:sp>
+      <p:sp>
+        <p:nvSpPr>
+          <p:cNvPr id="25" name="Slide Number Placeholder 0"/>
+          <p:cNvSpPr>
+            <a:spLocks noGrp="1"/>
+          </p:cNvSpPr>
+          <p:nvPr>
+            <p:ph type="sldNum" sz="quarter" idx="4294967295"/>
+          </p:nvPr>
+        </p:nvSpPr>
+        <p:spPr>
+          <a:xfrm>
+            <a:off x="11091672" y="6355080"/>
+            <a:ext cx="548640" cy="320040"/>
+          </a:xfrm>
+          <a:prstGeom prst="rect">
+            <a:avLst/>
+          </a:prstGeom>
+          <a:extLst>
+            <a:ext uri="{C572A759-6A51-4108-AA02-DFA0A04FC94B}">
+              <ma14:wrappingTextBoxFlag xmlns:ma14="http://schemas.microsoft.com/office/mac/drawingml/2011/main" xmlns="" val="0"/>
+            </a:ext>
+          </a:extLst>
+        </p:spPr>
+        <p:txBody>
+          <a:bodyPr/>
+          <a:lstStyle>
+            <a:lvl1pPr>
+              <a:defRPr sz="1100">
+                <a:solidFill>
+                  <a:srgbClr val="8A94A6"/>
+                </a:solidFill>
+              </a:defRPr>
+            </a:lvl1pPr>
+          </a:lstStyle>
+          <a:p>
+            <a:pPr algn="r"/>
+            <a:fld id="{F7021451-1387-4CA6-816F-3879F97B5CBC}" type="slidenum">
+              <a:rPr lang="en-US" b="0"/>
+              <a:t>11</a:t>
+            </a:fld>
+            <a:endParaRPr lang="en-US"/>
+          </a:p>
+        </p:txBody>
+      </p:sp>
+      <p:sp>
+        <p:nvSpPr>
+          <p:cNvPr id="26" name="Situación"/>
+          <p:cNvSpPr txBox="1"/>
+          <p:nvPr/>
+        </p:nvSpPr>
+        <p:spPr>
+          <a:xfrm>
+            <a:off x="548640" y="1325880"/>
+            <a:ext cx="11094415" cy="685800"/>
+          </a:xfrm>
+          <a:prstGeom prst="rect">
+            <a:avLst/>
+          </a:prstGeom>
+          <a:noFill/>
+        </p:spPr>
+        <p:txBody>
+          <a:bodyPr wrap="square" anchor="ctr" lIns="0" rIns="0" tIns="0" bIns="0">
+            <a:spAutoFit/>
+          </a:bodyPr>
+          <a:lstStyle/>
+          <a:p>
+            <a:r>
+              <a:rPr sz="1800" b="0" i="1">
+                <a:solidFill>
+                  <a:schemeClr val="tx2"/>
+                </a:solidFill>
+              </a:rPr>
+              <a:t>«Un taller empieza a enviar al cliente fotos del coche a medida que lo repara y recibe menos llamadas preguntando.»</a:t>
+            </a:r>
+          </a:p>
+        </p:txBody>
+      </p:sp>
+      <p:sp>
+        <p:nvSpPr>
+          <p:cNvPr id="27" name="Respuesta"/>
+          <p:cNvSpPr/>
+          <p:nvPr/>
+        </p:nvSpPr>
+        <p:spPr>
+          <a:xfrm>
+            <a:off x="548640" y="2194560"/>
+            <a:ext cx="11094415" cy="1463040"/>
+          </a:xfrm>
+          <a:prstGeom prst="roundRect">
+            <a:avLst>
+              <a:gd name="adj" fmla="val 9374"/>
+            </a:avLst>
+          </a:prstGeom>
+          <a:solidFill>
+            <a:schemeClr val="accent3"/>
+          </a:solidFill>
+          <a:ln>
+            <a:noFill/>
+          </a:ln>
+          <a:effectLst/>
+        </p:spPr>
+        <p:style>
+          <a:lnRef idx="1">
+            <a:schemeClr val="accent1"/>
+          </a:lnRef>
+          <a:fillRef idx="3">
+            <a:schemeClr val="accent1"/>
+          </a:fillRef>
+          <a:effectRef idx="2">
+            <a:schemeClr val="accent1"/>
+          </a:effectRef>
+          <a:fontRef idx="minor">
+            <a:schemeClr val="lt1"/>
+          </a:fontRef>
+        </p:style>
+        <p:txBody>
+          <a:bodyPr rtlCol="0" anchor="ctr"/>
+          <a:lstStyle/>
+          <a:p>
+            <a:pPr algn="ctr"/>
+          </a:p>
+        </p:txBody>
+      </p:sp>
+      <p:sp>
+        <p:nvSpPr>
+          <p:cNvPr id="28" name="Número"/>
+          <p:cNvSpPr/>
+          <p:nvPr/>
+        </p:nvSpPr>
+        <p:spPr>
+          <a:xfrm>
+            <a:off x="868680" y="2377440"/>
+            <a:ext cx="1097280" cy="1097280"/>
+          </a:xfrm>
+          <a:prstGeom prst="ellipse">
+            <a:avLst/>
+          </a:prstGeom>
+          <a:solidFill>
+            <a:schemeClr val="bg1"/>
+          </a:solidFill>
+          <a:ln>
+            <a:noFill/>
+          </a:ln>
+          <a:effectLst/>
+        </p:spPr>
+        <p:style>
+          <a:lnRef idx="1">
+            <a:schemeClr val="accent1"/>
+          </a:lnRef>
+          <a:fillRef idx="3">
+            <a:schemeClr val="accent1"/>
+          </a:fillRef>
+          <a:effectRef idx="2">
+            <a:schemeClr val="accent1"/>
+          </a:effectRef>
+          <a:fontRef idx="minor">
+            <a:schemeClr val="lt1"/>
+          </a:fontRef>
+        </p:style>
+        <p:txBody>
+          <a:bodyPr rtlCol="0" anchor="ctr"/>
+          <a:lstStyle/>
+          <a:p>
+            <a:pPr algn="ctr"/>
+          </a:p>
+        </p:txBody>
+      </p:sp>
+      <p:sp>
+        <p:nvSpPr>
+          <p:cNvPr id="29" name="Número de la opción"/>
+          <p:cNvSpPr txBox="1"/>
+          <p:nvPr/>
+        </p:nvSpPr>
+        <p:spPr>
+          <a:xfrm>
+            <a:off x="868680" y="2377440"/>
+            <a:ext cx="1097280" cy="1097280"/>
+          </a:xfrm>
+          <a:prstGeom prst="rect">
+            <a:avLst/>
+          </a:prstGeom>
+          <a:noFill/>
+        </p:spPr>
+        <p:txBody>
+          <a:bodyPr wrap="square" anchor="ctr" lIns="0" rIns="0" tIns="0" bIns="0">
+            <a:spAutoFit/>
+          </a:bodyPr>
+          <a:lstStyle/>
+          <a:p>
+            <a:pPr algn="ctr"/>
+            <a:r>
+              <a:rPr sz="4800" b="1" i="0">
+                <a:solidFill>
+                  <a:schemeClr val="accent3"/>
+                </a:solidFill>
+              </a:rPr>
+              <a:t>2</a:t>
+            </a:r>
+          </a:p>
+        </p:txBody>
+      </p:sp>
+      <p:sp>
+        <p:nvSpPr>
+          <p:cNvPr id="30" name="Nombre de la respuesta"/>
+          <p:cNvSpPr txBox="1"/>
+          <p:nvPr/>
+        </p:nvSpPr>
+        <p:spPr>
+          <a:xfrm>
+            <a:off x="2286000" y="2194560"/>
+            <a:ext cx="9082735" cy="1463040"/>
+          </a:xfrm>
+          <a:prstGeom prst="rect">
+            <a:avLst/>
+          </a:prstGeom>
+          <a:noFill/>
+        </p:spPr>
+        <p:txBody>
+          <a:bodyPr wrap="square" anchor="ctr" lIns="0" rIns="0" tIns="0" bIns="0">
+            <a:spAutoFit/>
+          </a:bodyPr>
+          <a:lstStyle/>
+          <a:p>
+            <a:r>
+              <a:rPr sz="4000" b="1" i="0">
+                <a:solidFill>
+                  <a:schemeClr val="bg1"/>
+                </a:solidFill>
+              </a:rPr>
+              <a:t>Innovación</a:t>
+            </a:r>
+          </a:p>
+        </p:txBody>
+      </p:sp>
+      <p:sp>
+        <p:nvSpPr>
+          <p:cNvPr id="31" name="Por qué"/>
+          <p:cNvSpPr/>
+          <p:nvPr/>
+        </p:nvSpPr>
+        <p:spPr>
+          <a:xfrm>
+            <a:off x="548640" y="3931920"/>
+            <a:ext cx="11094415" cy="1600200"/>
+          </a:xfrm>
+          <a:prstGeom prst="roundRect">
+            <a:avLst>
+              <a:gd name="adj" fmla="val 8571"/>
+            </a:avLst>
+          </a:prstGeom>
+          <a:solidFill>
+            <a:schemeClr val="bg2"/>
+          </a:solidFill>
+          <a:ln>
+            <a:noFill/>
+          </a:ln>
+          <a:effectLst/>
+        </p:spPr>
+        <p:style>
+          <a:lnRef idx="1">
+            <a:schemeClr val="accent1"/>
+          </a:lnRef>
+          <a:fillRef idx="3">
+            <a:schemeClr val="accent1"/>
+          </a:fillRef>
+          <a:effectRef idx="2">
+            <a:schemeClr val="accent1"/>
+          </a:effectRef>
+          <a:fontRef idx="minor">
+            <a:schemeClr val="lt1"/>
+          </a:fontRef>
+        </p:style>
+        <p:txBody>
+          <a:bodyPr rtlCol="0" anchor="ctr"/>
+          <a:lstStyle/>
+          <a:p>
+            <a:pPr algn="ctr"/>
+          </a:p>
+        </p:txBody>
+      </p:sp>
+      <p:sp>
+        <p:nvSpPr>
+          <p:cNvPr id="32" name="Explicación"/>
+          <p:cNvSpPr txBox="1"/>
+          <p:nvPr/>
+        </p:nvSpPr>
+        <p:spPr>
+          <a:xfrm>
+            <a:off x="914400" y="3931920"/>
+            <a:ext cx="10362895" cy="1600200"/>
+          </a:xfrm>
+          <a:prstGeom prst="rect">
+            <a:avLst/>
+          </a:prstGeom>
+          <a:noFill/>
+        </p:spPr>
+        <p:txBody>
+          <a:bodyPr wrap="square" anchor="ctr" lIns="0" rIns="0" tIns="0" bIns="0">
+            <a:spAutoFit/>
+          </a:bodyPr>
+          <a:lstStyle/>
+          <a:p>
+            <a:r>
+              <a:rPr sz="1600" b="1" i="0">
+                <a:solidFill>
+                  <a:schemeClr val="tx2"/>
+                </a:solidFill>
+              </a:rPr>
+              <a:t>Por qué</a:t>
+            </a:r>
+          </a:p>
+          <a:p>
+            <a:pPr>
+              <a:spcBef>
+                <a:spcPts val="600"/>
+              </a:spcBef>
+            </a:pPr>
+            <a:r>
+              <a:rPr sz="2200" b="0" i="0">
+                <a:solidFill>
+                  <a:schemeClr val="tx1"/>
+                </a:solidFill>
+              </a:rPr>
+              <a:t>Es un cambio ya puesto en práctica que aporta valor: el cliente está informado y el taller recibe menos llamadas.</a:t>
+            </a:r>
+          </a:p>
+        </p:txBody>
+      </p:sp>
+    </p:spTree>
+  </p:cSld>
+  <p:clrMapOvr>
+    <a:masterClrMapping/>
+  </p:clrMapOvr>
+</p:sld>
+</file>
+
+<file path=ppt/slides/slide34.xml><?xml version="1.0" encoding="utf-8"?>
+<p:sld xmlns:a="http://schemas.openxmlformats.org/drawingml/2006/main" xmlns:p="http://schemas.openxmlformats.org/presentationml/2006/main" xmlns:r="http://schemas.openxmlformats.org/officeDocument/2006/relationships">
+  <p:cSld>
+    <p:spTree>
+      <p:nvGrpSpPr>
+        <p:cNvPr id="1" name=""/>
+        <p:cNvGrpSpPr/>
+        <p:nvPr/>
+      </p:nvGrpSpPr>
+      <p:grpSpPr/>
+      <p:sp>
+        <p:nvSpPr>
+          <p:cNvPr id="2" name="Text 0"/>
+          <p:cNvSpPr>
+            <a:spLocks noGrp="1"/>
+          </p:cNvSpPr>
+          <p:nvPr>
+            <p:ph type="title" idx="100" hasCustomPrompt="1"/>
+          </p:nvPr>
+        </p:nvSpPr>
+        <p:spPr>
+          <a:xfrm>
+            <a:off x="548640" y="411480"/>
+            <a:ext cx="11094415" cy="777240"/>
+          </a:xfrm>
+          <a:prstGeom prst="rect">
+            <a:avLst/>
+          </a:prstGeom>
+          <a:noFill/>
+          <a:ln/>
+        </p:spPr>
+        <p:txBody>
+          <a:bodyPr wrap="square" lIns="0" tIns="0" rIns="0" bIns="0" rtlCol="0" anchor="ctr"/>
+          <a:lstStyle/>
+          <a:p>
+            <a:pPr marL="0" indent="0" algn="l">
+              <a:buNone/>
+            </a:pPr>
+            <a:r>
+              <a:rPr lang="en-US" sz="3200" b="1" dirty="0">
+                <a:solidFill>
+                  <a:schemeClr val="tx1"/>
+                </a:solidFill>
+              </a:rPr>
+              <a:t>Situación 5: respuesta</a:t>
+            </a:r>
+            <a:endParaRPr lang="en-US" sz="3200" dirty="0"/>
+          </a:p>
+        </p:txBody>
+      </p:sp>
+      <p:sp>
+        <p:nvSpPr>
+          <p:cNvPr id="3" name="Etiqueta de tiempo"/>
+          <p:cNvSpPr/>
+          <p:nvPr/>
+        </p:nvSpPr>
+        <p:spPr>
+          <a:xfrm>
+            <a:off x="8556955" y="548640"/>
+            <a:ext cx="3086100" cy="457200"/>
+          </a:xfrm>
+          <a:prstGeom prst="roundRect">
+            <a:avLst>
+              <a:gd name="adj" fmla="val 50000"/>
+            </a:avLst>
+          </a:prstGeom>
+          <a:solidFill>
+            <a:schemeClr val="accent1"/>
+          </a:solidFill>
+          <a:ln/>
+        </p:spPr>
+      </p:sp>
+      <p:sp>
+        <p:nvSpPr>
+          <p:cNvPr id="4" name="Text 2"/>
+          <p:cNvSpPr txBox="1"/>
+          <p:nvPr/>
+        </p:nvSpPr>
+        <p:spPr>
+          <a:xfrm>
+            <a:off x="8556955" y="548640"/>
+            <a:ext cx="3086100" cy="457200"/>
+          </a:xfrm>
+          <a:prstGeom prst="rect">
+            <a:avLst/>
+          </a:prstGeom>
+          <a:noFill/>
+          <a:ln/>
+        </p:spPr>
+        <p:txBody>
+          <a:bodyPr wrap="square" lIns="0" tIns="0" rIns="0" bIns="0" rtlCol="0" anchor="ctr"/>
+          <a:lstStyle/>
+          <a:p>
+            <a:pPr marL="0" indent="0" algn="ctr">
+              <a:buNone/>
+            </a:pPr>
+            <a:r>
+              <a:rPr lang="en-US" sz="1400" b="1" dirty="0">
+                <a:solidFill>
+                  <a:schemeClr val="tx1"/>
+                </a:solidFill>
+              </a:rPr>
+              <a:t>Min. 5–10 · Todo el grupo</a:t>
+            </a:r>
+            <a:endParaRPr lang="en-US" sz="1400" dirty="0"/>
+          </a:p>
+        </p:txBody>
+      </p:sp>
+      <p:sp>
+        <p:nvSpPr>
+          <p:cNvPr id="25" name="Slide Number Placeholder 0"/>
+          <p:cNvSpPr>
+            <a:spLocks noGrp="1"/>
+          </p:cNvSpPr>
+          <p:nvPr>
+            <p:ph type="sldNum" sz="quarter" idx="4294967295"/>
+          </p:nvPr>
+        </p:nvSpPr>
+        <p:spPr>
+          <a:xfrm>
+            <a:off x="11091672" y="6355080"/>
+            <a:ext cx="548640" cy="320040"/>
+          </a:xfrm>
+          <a:prstGeom prst="rect">
+            <a:avLst/>
+          </a:prstGeom>
+          <a:extLst>
+            <a:ext uri="{C572A759-6A51-4108-AA02-DFA0A04FC94B}">
+              <ma14:wrappingTextBoxFlag xmlns:ma14="http://schemas.microsoft.com/office/mac/drawingml/2011/main" xmlns="" val="0"/>
+            </a:ext>
+          </a:extLst>
+        </p:spPr>
+        <p:txBody>
+          <a:bodyPr/>
+          <a:lstStyle>
+            <a:lvl1pPr>
+              <a:defRPr sz="1100">
+                <a:solidFill>
+                  <a:srgbClr val="8A94A6"/>
+                </a:solidFill>
+              </a:defRPr>
+            </a:lvl1pPr>
+          </a:lstStyle>
+          <a:p>
+            <a:pPr algn="r"/>
+            <a:fld id="{F7021451-1387-4CA6-816F-3879F97B5CBC}" type="slidenum">
+              <a:rPr lang="en-US" b="0"/>
+              <a:t>12</a:t>
+            </a:fld>
+            <a:endParaRPr lang="en-US"/>
+          </a:p>
+        </p:txBody>
+      </p:sp>
+      <p:sp>
+        <p:nvSpPr>
+          <p:cNvPr id="26" name="Situación"/>
+          <p:cNvSpPr txBox="1"/>
+          <p:nvPr/>
+        </p:nvSpPr>
+        <p:spPr>
+          <a:xfrm>
+            <a:off x="548640" y="1325880"/>
+            <a:ext cx="11094415" cy="685800"/>
+          </a:xfrm>
+          <a:prstGeom prst="rect">
+            <a:avLst/>
+          </a:prstGeom>
+          <a:noFill/>
+        </p:spPr>
+        <p:txBody>
+          <a:bodyPr wrap="square" anchor="ctr" lIns="0" rIns="0" tIns="0" bIns="0">
+            <a:spAutoFit/>
+          </a:bodyPr>
+          <a:lstStyle/>
+          <a:p>
+            <a:r>
+              <a:rPr sz="1800" b="0" i="1">
+                <a:solidFill>
+                  <a:schemeClr val="tx2"/>
+                </a:solidFill>
+              </a:rPr>
+              <a:t>«A un empleado se le ocurre usar las cajas de los pedidos como expositor en el mostrador.»</a:t>
+            </a:r>
+          </a:p>
+        </p:txBody>
+      </p:sp>
+      <p:sp>
+        <p:nvSpPr>
+          <p:cNvPr id="27" name="Respuesta"/>
+          <p:cNvSpPr/>
+          <p:nvPr/>
+        </p:nvSpPr>
+        <p:spPr>
+          <a:xfrm>
+            <a:off x="548640" y="2194560"/>
+            <a:ext cx="11094415" cy="1463040"/>
+          </a:xfrm>
+          <a:prstGeom prst="roundRect">
+            <a:avLst>
+              <a:gd name="adj" fmla="val 9374"/>
+            </a:avLst>
+          </a:prstGeom>
+          <a:solidFill>
+            <a:schemeClr val="accent1"/>
+          </a:solidFill>
+          <a:ln>
+            <a:noFill/>
+          </a:ln>
+          <a:effectLst/>
+        </p:spPr>
+        <p:style>
+          <a:lnRef idx="1">
+            <a:schemeClr val="accent1"/>
+          </a:lnRef>
+          <a:fillRef idx="3">
+            <a:schemeClr val="accent1"/>
+          </a:fillRef>
+          <a:effectRef idx="2">
+            <a:schemeClr val="accent1"/>
+          </a:effectRef>
+          <a:fontRef idx="minor">
+            <a:schemeClr val="lt1"/>
+          </a:fontRef>
+        </p:style>
+        <p:txBody>
+          <a:bodyPr rtlCol="0" anchor="ctr"/>
+          <a:lstStyle/>
+          <a:p>
+            <a:pPr algn="ctr"/>
+          </a:p>
+        </p:txBody>
+      </p:sp>
+      <p:sp>
+        <p:nvSpPr>
+          <p:cNvPr id="28" name="Número"/>
+          <p:cNvSpPr/>
+          <p:nvPr/>
+        </p:nvSpPr>
+        <p:spPr>
+          <a:xfrm>
+            <a:off x="868680" y="2377440"/>
+            <a:ext cx="1097280" cy="1097280"/>
+          </a:xfrm>
+          <a:prstGeom prst="ellipse">
+            <a:avLst/>
+          </a:prstGeom>
+          <a:solidFill>
+            <a:schemeClr val="bg1"/>
+          </a:solidFill>
+          <a:ln>
+            <a:noFill/>
+          </a:ln>
+          <a:effectLst/>
+        </p:spPr>
+        <p:style>
+          <a:lnRef idx="1">
+            <a:schemeClr val="accent1"/>
+          </a:lnRef>
+          <a:fillRef idx="3">
+            <a:schemeClr val="accent1"/>
+          </a:fillRef>
+          <a:effectRef idx="2">
+            <a:schemeClr val="accent1"/>
+          </a:effectRef>
+          <a:fontRef idx="minor">
+            <a:schemeClr val="lt1"/>
+          </a:fontRef>
+        </p:style>
+        <p:txBody>
+          <a:bodyPr rtlCol="0" anchor="ctr"/>
+          <a:lstStyle/>
+          <a:p>
+            <a:pPr algn="ctr"/>
+          </a:p>
+        </p:txBody>
+      </p:sp>
+      <p:sp>
+        <p:nvSpPr>
+          <p:cNvPr id="29" name="Número de la opción"/>
+          <p:cNvSpPr txBox="1"/>
+          <p:nvPr/>
+        </p:nvSpPr>
+        <p:spPr>
+          <a:xfrm>
+            <a:off x="868680" y="2377440"/>
+            <a:ext cx="1097280" cy="1097280"/>
+          </a:xfrm>
+          <a:prstGeom prst="rect">
+            <a:avLst/>
+          </a:prstGeom>
+          <a:noFill/>
+        </p:spPr>
+        <p:txBody>
+          <a:bodyPr wrap="square" anchor="ctr" lIns="0" rIns="0" tIns="0" bIns="0">
+            <a:spAutoFit/>
+          </a:bodyPr>
+          <a:lstStyle/>
+          <a:p>
+            <a:pPr algn="ctr"/>
+            <a:r>
+              <a:rPr sz="4800" b="1" i="0">
+                <a:solidFill>
+                  <a:schemeClr val="accent1"/>
+                </a:solidFill>
+              </a:rPr>
+              <a:t>1</a:t>
+            </a:r>
+          </a:p>
+        </p:txBody>
+      </p:sp>
+      <p:sp>
+        <p:nvSpPr>
+          <p:cNvPr id="30" name="Nombre de la respuesta"/>
+          <p:cNvSpPr txBox="1"/>
+          <p:nvPr/>
+        </p:nvSpPr>
+        <p:spPr>
+          <a:xfrm>
+            <a:off x="2286000" y="2194560"/>
+            <a:ext cx="9082735" cy="1463040"/>
+          </a:xfrm>
+          <a:prstGeom prst="rect">
+            <a:avLst/>
+          </a:prstGeom>
+          <a:noFill/>
+        </p:spPr>
+        <p:txBody>
+          <a:bodyPr wrap="square" anchor="ctr" lIns="0" rIns="0" tIns="0" bIns="0">
+            <a:spAutoFit/>
+          </a:bodyPr>
+          <a:lstStyle/>
+          <a:p>
+            <a:r>
+              <a:rPr sz="4000" b="1" i="0">
+                <a:solidFill>
+                  <a:schemeClr val="tx1"/>
+                </a:solidFill>
+              </a:rPr>
+              <a:t>Creatividad</a:t>
+            </a:r>
+          </a:p>
+        </p:txBody>
+      </p:sp>
+      <p:sp>
+        <p:nvSpPr>
+          <p:cNvPr id="31" name="Por qué"/>
+          <p:cNvSpPr/>
+          <p:nvPr/>
+        </p:nvSpPr>
+        <p:spPr>
+          <a:xfrm>
+            <a:off x="548640" y="3931920"/>
+            <a:ext cx="11094415" cy="1600200"/>
+          </a:xfrm>
+          <a:prstGeom prst="roundRect">
+            <a:avLst>
+              <a:gd name="adj" fmla="val 8571"/>
+            </a:avLst>
+          </a:prstGeom>
+          <a:solidFill>
+            <a:schemeClr val="bg2"/>
+          </a:solidFill>
+          <a:ln>
+            <a:noFill/>
+          </a:ln>
+          <a:effectLst/>
+        </p:spPr>
+        <p:style>
+          <a:lnRef idx="1">
+            <a:schemeClr val="accent1"/>
+          </a:lnRef>
+          <a:fillRef idx="3">
+            <a:schemeClr val="accent1"/>
+          </a:fillRef>
+          <a:effectRef idx="2">
+            <a:schemeClr val="accent1"/>
+          </a:effectRef>
+          <a:fontRef idx="minor">
+            <a:schemeClr val="lt1"/>
+          </a:fontRef>
+        </p:style>
+        <p:txBody>
+          <a:bodyPr rtlCol="0" anchor="ctr"/>
+          <a:lstStyle/>
+          <a:p>
+            <a:pPr algn="ctr"/>
+          </a:p>
+        </p:txBody>
+      </p:sp>
+      <p:sp>
+        <p:nvSpPr>
+          <p:cNvPr id="32" name="Explicación"/>
+          <p:cNvSpPr txBox="1"/>
+          <p:nvPr/>
+        </p:nvSpPr>
+        <p:spPr>
+          <a:xfrm>
+            <a:off x="914400" y="3931920"/>
+            <a:ext cx="10362895" cy="1600200"/>
+          </a:xfrm>
+          <a:prstGeom prst="rect">
+            <a:avLst/>
+          </a:prstGeom>
+          <a:noFill/>
+        </p:spPr>
+        <p:txBody>
+          <a:bodyPr wrap="square" anchor="ctr" lIns="0" rIns="0" tIns="0" bIns="0">
+            <a:spAutoFit/>
+          </a:bodyPr>
+          <a:lstStyle/>
+          <a:p>
+            <a:r>
+              <a:rPr sz="1600" b="1" i="0">
+                <a:solidFill>
+                  <a:schemeClr val="tx2"/>
+                </a:solidFill>
+              </a:rPr>
+              <a:t>Por qué</a:t>
+            </a:r>
+          </a:p>
+          <a:p>
+            <a:pPr>
+              <a:spcBef>
+                <a:spcPts val="600"/>
+              </a:spcBef>
+            </a:pPr>
+            <a:r>
+              <a:rPr sz="2200" b="0" i="0">
+                <a:solidFill>
+                  <a:schemeClr val="tx1"/>
+                </a:solidFill>
+              </a:rPr>
+              <a:t>Por ahora es solo una idea. Si se pone en práctica y funciona, pasa a ser innovación.</a:t>
+            </a:r>
+          </a:p>
+        </p:txBody>
+      </p:sp>
+      <p:sp>
+        <p:nvSpPr>
+          <p:cNvPr id="33" name="Aviso"/>
+          <p:cNvSpPr txBox="1"/>
+          <p:nvPr/>
+        </p:nvSpPr>
+        <p:spPr>
+          <a:xfrm>
+            <a:off x="548640" y="5669280"/>
+            <a:ext cx="11094415" cy="411480"/>
+          </a:xfrm>
+          <a:prstGeom prst="rect">
+            <a:avLst/>
+          </a:prstGeom>
+          <a:noFill/>
+        </p:spPr>
+        <p:txBody>
+          <a:bodyPr wrap="square" anchor="ctr" lIns="0" rIns="0" tIns="0" bIns="0">
+            <a:spAutoFit/>
+          </a:bodyPr>
+          <a:lstStyle/>
+          <a:p>
+            <a:r>
+              <a:rPr sz="1600" b="1" i="1">
+                <a:solidFill>
+                  <a:schemeClr val="accent3"/>
+                </a:solidFill>
+              </a:rPr>
+              <a:t>Situación discutible a propósito: lo importante es el razonamiento, no acertar.</a:t>
+            </a:r>
+          </a:p>
+        </p:txBody>
+      </p:sp>
+    </p:spTree>
+  </p:cSld>
+  <p:clrMapOvr>
+    <a:masterClrMapping/>
+  </p:clrMapOvr>
+</p:sld>
+</file>
+
+<file path=ppt/slides/slide35.xml><?xml version="1.0" encoding="utf-8"?>
+<p:sld xmlns:a="http://schemas.openxmlformats.org/drawingml/2006/main" xmlns:p="http://schemas.openxmlformats.org/presentationml/2006/main" xmlns:r="http://schemas.openxmlformats.org/officeDocument/2006/relationships">
+  <p:cSld>
+    <p:spTree>
+      <p:nvGrpSpPr>
+        <p:cNvPr id="1" name=""/>
+        <p:cNvGrpSpPr/>
+        <p:nvPr/>
+      </p:nvGrpSpPr>
+      <p:grpSpPr/>
+      <p:sp>
+        <p:nvSpPr>
+          <p:cNvPr id="2" name="Text 0"/>
+          <p:cNvSpPr>
+            <a:spLocks noGrp="1"/>
+          </p:cNvSpPr>
+          <p:nvPr>
+            <p:ph type="title" idx="100" hasCustomPrompt="1"/>
+          </p:nvPr>
+        </p:nvSpPr>
+        <p:spPr>
+          <a:xfrm>
+            <a:off x="548640" y="411480"/>
+            <a:ext cx="11094415" cy="777240"/>
+          </a:xfrm>
+          <a:prstGeom prst="rect">
+            <a:avLst/>
+          </a:prstGeom>
+          <a:noFill/>
+          <a:ln/>
+        </p:spPr>
+        <p:txBody>
+          <a:bodyPr wrap="square" lIns="0" tIns="0" rIns="0" bIns="0" rtlCol="0" anchor="ctr"/>
+          <a:lstStyle/>
+          <a:p>
+            <a:pPr marL="0" indent="0" algn="l">
+              <a:buNone/>
+            </a:pPr>
+            <a:r>
+              <a:rPr lang="en-US" sz="3200" b="1" dirty="0">
+                <a:solidFill>
+                  <a:schemeClr val="tx1"/>
+                </a:solidFill>
+              </a:rPr>
+              <a:t>Situación 6: respuesta</a:t>
+            </a:r>
+            <a:endParaRPr lang="en-US" sz="3200" dirty="0"/>
+          </a:p>
+        </p:txBody>
+      </p:sp>
+      <p:sp>
+        <p:nvSpPr>
+          <p:cNvPr id="3" name="Etiqueta de tiempo"/>
+          <p:cNvSpPr/>
+          <p:nvPr/>
+        </p:nvSpPr>
+        <p:spPr>
+          <a:xfrm>
+            <a:off x="8556955" y="548640"/>
+            <a:ext cx="3086100" cy="457200"/>
+          </a:xfrm>
+          <a:prstGeom prst="roundRect">
+            <a:avLst>
+              <a:gd name="adj" fmla="val 50000"/>
+            </a:avLst>
+          </a:prstGeom>
+          <a:solidFill>
+            <a:schemeClr val="accent1"/>
+          </a:solidFill>
+          <a:ln/>
+        </p:spPr>
+      </p:sp>
+      <p:sp>
+        <p:nvSpPr>
+          <p:cNvPr id="4" name="Text 2"/>
+          <p:cNvSpPr txBox="1"/>
+          <p:nvPr/>
+        </p:nvSpPr>
+        <p:spPr>
+          <a:xfrm>
+            <a:off x="8556955" y="548640"/>
+            <a:ext cx="3086100" cy="457200"/>
+          </a:xfrm>
+          <a:prstGeom prst="rect">
+            <a:avLst/>
+          </a:prstGeom>
+          <a:noFill/>
+          <a:ln/>
+        </p:spPr>
+        <p:txBody>
+          <a:bodyPr wrap="square" lIns="0" tIns="0" rIns="0" bIns="0" rtlCol="0" anchor="ctr"/>
+          <a:lstStyle/>
+          <a:p>
+            <a:pPr marL="0" indent="0" algn="ctr">
+              <a:buNone/>
+            </a:pPr>
+            <a:r>
+              <a:rPr lang="en-US" sz="1400" b="1" dirty="0">
+                <a:solidFill>
+                  <a:schemeClr val="tx1"/>
+                </a:solidFill>
+              </a:rPr>
+              <a:t>Min. 5–10 · Todo el grupo</a:t>
+            </a:r>
+            <a:endParaRPr lang="en-US" sz="1400" dirty="0"/>
+          </a:p>
+        </p:txBody>
+      </p:sp>
+      <p:sp>
+        <p:nvSpPr>
+          <p:cNvPr id="25" name="Slide Number Placeholder 0"/>
+          <p:cNvSpPr>
+            <a:spLocks noGrp="1"/>
+          </p:cNvSpPr>
+          <p:nvPr>
+            <p:ph type="sldNum" sz="quarter" idx="4294967295"/>
+          </p:nvPr>
+        </p:nvSpPr>
+        <p:spPr>
+          <a:xfrm>
+            <a:off x="11091672" y="6355080"/>
+            <a:ext cx="548640" cy="320040"/>
+          </a:xfrm>
+          <a:prstGeom prst="rect">
+            <a:avLst/>
+          </a:prstGeom>
+          <a:extLst>
+            <a:ext uri="{C572A759-6A51-4108-AA02-DFA0A04FC94B}">
+              <ma14:wrappingTextBoxFlag xmlns:ma14="http://schemas.microsoft.com/office/mac/drawingml/2011/main" xmlns="" val="0"/>
+            </a:ext>
+          </a:extLst>
+        </p:spPr>
+        <p:txBody>
+          <a:bodyPr/>
+          <a:lstStyle>
+            <a:lvl1pPr>
+              <a:defRPr sz="1100">
+                <a:solidFill>
+                  <a:srgbClr val="8A94A6"/>
+                </a:solidFill>
+              </a:defRPr>
+            </a:lvl1pPr>
+          </a:lstStyle>
+          <a:p>
+            <a:pPr algn="r"/>
+            <a:fld id="{F7021451-1387-4CA6-816F-3879F97B5CBC}" type="slidenum">
+              <a:rPr lang="en-US" b="0"/>
+              <a:t>13</a:t>
+            </a:fld>
+            <a:endParaRPr lang="en-US"/>
+          </a:p>
+        </p:txBody>
+      </p:sp>
+      <p:sp>
+        <p:nvSpPr>
+          <p:cNvPr id="26" name="Situación"/>
+          <p:cNvSpPr txBox="1"/>
+          <p:nvPr/>
+        </p:nvSpPr>
+        <p:spPr>
+          <a:xfrm>
+            <a:off x="548640" y="1325880"/>
+            <a:ext cx="11094415" cy="685800"/>
+          </a:xfrm>
+          <a:prstGeom prst="rect">
+            <a:avLst/>
+          </a:prstGeom>
+          <a:noFill/>
+        </p:spPr>
+        <p:txBody>
+          <a:bodyPr wrap="square" anchor="ctr" lIns="0" rIns="0" tIns="0" bIns="0">
+            <a:spAutoFit/>
+          </a:bodyPr>
+          <a:lstStyle/>
+          <a:p>
+            <a:r>
+              <a:rPr sz="1800" b="0" i="1">
+                <a:solidFill>
+                  <a:schemeClr val="tx2"/>
+                </a:solidFill>
+              </a:rPr>
+              <a:t>«Una camarera usa una IA para traducir la carta al inglés.»</a:t>
+            </a:r>
+          </a:p>
+        </p:txBody>
+      </p:sp>
+      <p:sp>
+        <p:nvSpPr>
+          <p:cNvPr id="27" name="Respuesta"/>
+          <p:cNvSpPr/>
+          <p:nvPr/>
+        </p:nvSpPr>
+        <p:spPr>
+          <a:xfrm>
+            <a:off x="548640" y="2194560"/>
+            <a:ext cx="11094415" cy="1463040"/>
+          </a:xfrm>
+          <a:prstGeom prst="roundRect">
+            <a:avLst>
+              <a:gd name="adj" fmla="val 9374"/>
+            </a:avLst>
+          </a:prstGeom>
+          <a:solidFill>
+            <a:schemeClr val="accent4"/>
+          </a:solidFill>
+          <a:ln>
+            <a:noFill/>
+          </a:ln>
+          <a:effectLst/>
+        </p:spPr>
+        <p:style>
+          <a:lnRef idx="1">
+            <a:schemeClr val="accent1"/>
+          </a:lnRef>
+          <a:fillRef idx="3">
+            <a:schemeClr val="accent1"/>
+          </a:fillRef>
+          <a:effectRef idx="2">
+            <a:schemeClr val="accent1"/>
+          </a:effectRef>
+          <a:fontRef idx="minor">
+            <a:schemeClr val="lt1"/>
+          </a:fontRef>
+        </p:style>
+        <p:txBody>
+          <a:bodyPr rtlCol="0" anchor="ctr"/>
+          <a:lstStyle/>
+          <a:p>
+            <a:pPr algn="ctr"/>
+          </a:p>
+        </p:txBody>
+      </p:sp>
+      <p:sp>
+        <p:nvSpPr>
+          <p:cNvPr id="28" name="Número"/>
+          <p:cNvSpPr/>
+          <p:nvPr/>
+        </p:nvSpPr>
+        <p:spPr>
+          <a:xfrm>
+            <a:off x="868680" y="2377440"/>
+            <a:ext cx="1097280" cy="1097280"/>
+          </a:xfrm>
+          <a:prstGeom prst="ellipse">
+            <a:avLst/>
+          </a:prstGeom>
+          <a:solidFill>
+            <a:schemeClr val="bg1"/>
+          </a:solidFill>
+          <a:ln>
+            <a:noFill/>
+          </a:ln>
+          <a:effectLst/>
+        </p:spPr>
+        <p:style>
+          <a:lnRef idx="1">
+            <a:schemeClr val="accent1"/>
+          </a:lnRef>
+          <a:fillRef idx="3">
+            <a:schemeClr val="accent1"/>
+          </a:fillRef>
+          <a:effectRef idx="2">
+            <a:schemeClr val="accent1"/>
+          </a:effectRef>
+          <a:fontRef idx="minor">
+            <a:schemeClr val="lt1"/>
+          </a:fontRef>
+        </p:style>
+        <p:txBody>
+          <a:bodyPr rtlCol="0" anchor="ctr"/>
+          <a:lstStyle/>
+          <a:p>
+            <a:pPr algn="ctr"/>
+          </a:p>
+        </p:txBody>
+      </p:sp>
+      <p:sp>
+        <p:nvSpPr>
+          <p:cNvPr id="29" name="Número de la opción"/>
+          <p:cNvSpPr txBox="1"/>
+          <p:nvPr/>
+        </p:nvSpPr>
+        <p:spPr>
+          <a:xfrm>
+            <a:off x="868680" y="2377440"/>
+            <a:ext cx="1097280" cy="1097280"/>
+          </a:xfrm>
+          <a:prstGeom prst="rect">
+            <a:avLst/>
+          </a:prstGeom>
+          <a:noFill/>
+        </p:spPr>
+        <p:txBody>
+          <a:bodyPr wrap="square" anchor="ctr" lIns="0" rIns="0" tIns="0" bIns="0">
+            <a:spAutoFit/>
+          </a:bodyPr>
+          <a:lstStyle/>
+          <a:p>
+            <a:pPr algn="ctr"/>
+            <a:r>
+              <a:rPr sz="4800" b="1" i="0">
+                <a:solidFill>
+                  <a:schemeClr val="accent4"/>
+                </a:solidFill>
+              </a:rPr>
+              <a:t>3</a:t>
+            </a:r>
+          </a:p>
+        </p:txBody>
+      </p:sp>
+      <p:sp>
+        <p:nvSpPr>
+          <p:cNvPr id="30" name="Nombre de la respuesta"/>
+          <p:cNvSpPr txBox="1"/>
+          <p:nvPr/>
+        </p:nvSpPr>
+        <p:spPr>
+          <a:xfrm>
+            <a:off x="2286000" y="2194560"/>
+            <a:ext cx="9082735" cy="1463040"/>
+          </a:xfrm>
+          <a:prstGeom prst="rect">
+            <a:avLst/>
+          </a:prstGeom>
+          <a:noFill/>
+        </p:spPr>
+        <p:txBody>
+          <a:bodyPr wrap="square" anchor="ctr" lIns="0" rIns="0" tIns="0" bIns="0">
+            <a:spAutoFit/>
+          </a:bodyPr>
+          <a:lstStyle/>
+          <a:p>
+            <a:r>
+              <a:rPr sz="4000" b="1" i="0">
+                <a:solidFill>
+                  <a:schemeClr val="bg1"/>
+                </a:solidFill>
+              </a:rPr>
+              <a:t>Competencia digital</a:t>
+            </a:r>
+          </a:p>
+        </p:txBody>
+      </p:sp>
+      <p:sp>
+        <p:nvSpPr>
+          <p:cNvPr id="31" name="Por qué"/>
+          <p:cNvSpPr/>
+          <p:nvPr/>
+        </p:nvSpPr>
+        <p:spPr>
+          <a:xfrm>
+            <a:off x="548640" y="3931920"/>
+            <a:ext cx="11094415" cy="1600200"/>
+          </a:xfrm>
+          <a:prstGeom prst="roundRect">
+            <a:avLst>
+              <a:gd name="adj" fmla="val 8571"/>
+            </a:avLst>
+          </a:prstGeom>
+          <a:solidFill>
+            <a:schemeClr val="bg2"/>
+          </a:solidFill>
+          <a:ln>
+            <a:noFill/>
+          </a:ln>
+          <a:effectLst/>
+        </p:spPr>
+        <p:style>
+          <a:lnRef idx="1">
+            <a:schemeClr val="accent1"/>
+          </a:lnRef>
+          <a:fillRef idx="3">
+            <a:schemeClr val="accent1"/>
+          </a:fillRef>
+          <a:effectRef idx="2">
+            <a:schemeClr val="accent1"/>
+          </a:effectRef>
+          <a:fontRef idx="minor">
+            <a:schemeClr val="lt1"/>
+          </a:fontRef>
+        </p:style>
+        <p:txBody>
+          <a:bodyPr rtlCol="0" anchor="ctr"/>
+          <a:lstStyle/>
+          <a:p>
+            <a:pPr algn="ctr"/>
+          </a:p>
+        </p:txBody>
+      </p:sp>
+      <p:sp>
+        <p:nvSpPr>
+          <p:cNvPr id="32" name="Explicación"/>
+          <p:cNvSpPr txBox="1"/>
+          <p:nvPr/>
+        </p:nvSpPr>
+        <p:spPr>
+          <a:xfrm>
+            <a:off x="914400" y="3931920"/>
+            <a:ext cx="10362895" cy="1600200"/>
+          </a:xfrm>
+          <a:prstGeom prst="rect">
+            <a:avLst/>
+          </a:prstGeom>
+          <a:noFill/>
+        </p:spPr>
+        <p:txBody>
+          <a:bodyPr wrap="square" anchor="ctr" lIns="0" rIns="0" tIns="0" bIns="0">
+            <a:spAutoFit/>
+          </a:bodyPr>
+          <a:lstStyle/>
+          <a:p>
+            <a:r>
+              <a:rPr sz="1600" b="1" i="0">
+                <a:solidFill>
+                  <a:schemeClr val="tx2"/>
+                </a:solidFill>
+              </a:rPr>
+              <a:t>Por qué</a:t>
+            </a:r>
+          </a:p>
+          <a:p>
+            <a:pPr>
+              <a:spcBef>
+                <a:spcPts val="600"/>
+              </a:spcBef>
+            </a:pPr>
+            <a:r>
+              <a:rPr sz="2200" b="0" i="0">
+                <a:solidFill>
+                  <a:schemeClr val="tx1"/>
+                </a:solidFill>
+              </a:rPr>
+              <a:t>Usa la IA para una tarea concreta, sin cambiar cómo se atiende. Sería innovación si cambiara la forma de atender a los clientes extranjeros.</a:t>
+            </a:r>
+          </a:p>
+        </p:txBody>
+      </p:sp>
+      <p:sp>
+        <p:nvSpPr>
+          <p:cNvPr id="33" name="Aviso"/>
+          <p:cNvSpPr txBox="1"/>
+          <p:nvPr/>
+        </p:nvSpPr>
+        <p:spPr>
+          <a:xfrm>
+            <a:off x="548640" y="5669280"/>
+            <a:ext cx="11094415" cy="411480"/>
+          </a:xfrm>
+          <a:prstGeom prst="rect">
+            <a:avLst/>
+          </a:prstGeom>
+          <a:noFill/>
+        </p:spPr>
+        <p:txBody>
+          <a:bodyPr wrap="square" anchor="ctr" lIns="0" rIns="0" tIns="0" bIns="0">
+            <a:spAutoFit/>
+          </a:bodyPr>
+          <a:lstStyle/>
+          <a:p>
+            <a:r>
+              <a:rPr sz="1600" b="1" i="1">
+                <a:solidFill>
+                  <a:schemeClr val="accent3"/>
+                </a:solidFill>
+              </a:rPr>
+              <a:t>Situación discutible a propósito: lo importante es el razonamiento, no acertar.</a:t>
+            </a:r>
           </a:p>
         </p:txBody>
       </p:sp>

</xml_diff>